<commit_message>
adding comment for slide info
</commit_message>
<xml_diff>
--- a/WP4/prelim.res.pptx
+++ b/WP4/prelim.res.pptx
@@ -5857,7 +5857,7 @@
         <p:spPr>
           <a:xfrm>
             <a:off x="349514" y="1013355"/>
-            <a:ext cx="6270362" cy="5355312"/>
+            <a:ext cx="6270362" cy="3970318"/>
           </a:xfrm>
           <a:prstGeom prst="rect">
             <a:avLst/>
@@ -5876,9 +5876,94 @@
             </a:r>
           </a:p>
           <a:p>
+            <a:endParaRPr lang="en-US" dirty="0"/>
+          </a:p>
+          <a:p>
+            <a:r>
+              <a:rPr lang="en-US" b="1" dirty="0"/>
+              <a:t> </a:t>
+            </a:r>
+            <a:r>
+              <a:rPr lang="en-US" b="1" dirty="0" err="1"/>
+              <a:t>search.term</a:t>
+            </a:r>
+            <a:r>
+              <a:rPr lang="en-US" b="1" dirty="0"/>
+              <a:t>                                    </a:t>
+            </a:r>
+            <a:r>
+              <a:rPr lang="en-US" b="1" dirty="0" err="1"/>
+              <a:t>nmbr</a:t>
+            </a:r>
+            <a:r>
+              <a:rPr lang="en-US" b="1" dirty="0"/>
+              <a:t>. of documents pulled</a:t>
+            </a:r>
+          </a:p>
+          <a:p>
             <a:r>
               <a:rPr lang="en-US" dirty="0"/>
-              <a:t>"</a:t>
+              <a:t> </a:t>
+            </a:r>
+            <a:r>
+              <a:rPr lang="en-US" dirty="0" err="1"/>
+              <a:t>barcelona</a:t>
+            </a:r>
+            <a:r>
+              <a:rPr lang="en-US" dirty="0"/>
+              <a:t> convention*?               	37</a:t>
+            </a:r>
+          </a:p>
+          <a:p>
+            <a:r>
+              <a:rPr lang="en-US" dirty="0"/>
+              <a:t> birds directive*?                            	6</a:t>
+            </a:r>
+          </a:p>
+          <a:p>
+            <a:r>
+              <a:rPr lang="en-US" dirty="0"/>
+              <a:t> habitats directive*?                      	56</a:t>
+            </a:r>
+          </a:p>
+          <a:p>
+            <a:r>
+              <a:rPr lang="en-US" dirty="0"/>
+              <a:t> </a:t>
+            </a:r>
+            <a:r>
+              <a:rPr lang="en-US" dirty="0" err="1"/>
+              <a:t>helcom</a:t>
+            </a:r>
+            <a:r>
+              <a:rPr lang="en-US" dirty="0"/>
+              <a:t>*?                                       	12</a:t>
+            </a:r>
+          </a:p>
+          <a:p>
+            <a:r>
+              <a:rPr lang="en-US" dirty="0"/>
+              <a:t> marine protected area*?            	18</a:t>
+            </a:r>
+          </a:p>
+          <a:p>
+            <a:r>
+              <a:rPr lang="en-US" dirty="0"/>
+              <a:t> </a:t>
+            </a:r>
+            <a:r>
+              <a:rPr lang="en-US" dirty="0" err="1"/>
+              <a:t>ospar</a:t>
+            </a:r>
+            <a:r>
+              <a:rPr lang="en-US" dirty="0"/>
+              <a:t>*?                                          	19</a:t>
+            </a:r>
+          </a:p>
+          <a:p>
+            <a:r>
+              <a:rPr lang="en-US" dirty="0"/>
+              <a:t> </a:t>
             </a:r>
             <a:r>
               <a:rPr lang="en-US" dirty="0" err="1"/>
@@ -5886,165 +5971,31 @@
             </a:r>
             <a:r>
               <a:rPr lang="en-US" dirty="0"/>
-              <a:t> site*?"                                          </a:t>
+              <a:t> site*?                                	1</a:t>
             </a:r>
           </a:p>
           <a:p>
             <a:r>
               <a:rPr lang="en-US" dirty="0"/>
-              <a:t>"wetland of international importance*?"                  </a:t>
+              <a:t> sites of community importance*?         5</a:t>
             </a:r>
           </a:p>
           <a:p>
             <a:r>
               <a:rPr lang="en-US" dirty="0"/>
-              <a:t>"world heritage site*?"                                </a:t>
+              <a:t> special areas of conservation*?    	16</a:t>
             </a:r>
           </a:p>
           <a:p>
             <a:r>
               <a:rPr lang="en-US" dirty="0"/>
-              <a:t>"</a:t>
-            </a:r>
-            <a:r>
-              <a:rPr lang="en-US" dirty="0" err="1"/>
-              <a:t>unesco-mab</a:t>
-            </a:r>
+              <a:t> special protection area*?           	7</a:t>
+            </a:r>
+          </a:p>
+          <a:p>
             <a:r>
               <a:rPr lang="en-US" dirty="0"/>
-              <a:t> biosphere reserve*?"                         </a:t>
-            </a:r>
-          </a:p>
-          <a:p>
-            <a:r>
-              <a:rPr lang="en-US" dirty="0"/>
-              <a:t>"</a:t>
-            </a:r>
-            <a:r>
-              <a:rPr lang="en-US" dirty="0" err="1"/>
-              <a:t>barcelona</a:t>
-            </a:r>
-            <a:r>
-              <a:rPr lang="en-US" dirty="0"/>
-              <a:t> convention*?"                                </a:t>
-            </a:r>
-          </a:p>
-          <a:p>
-            <a:r>
-              <a:rPr lang="en-US" dirty="0"/>
-              <a:t>"specially protected areas of </a:t>
-            </a:r>
-            <a:r>
-              <a:rPr lang="en-US" dirty="0" err="1"/>
-              <a:t>mediterranean</a:t>
-            </a:r>
-            <a:r>
-              <a:rPr lang="en-US" dirty="0"/>
-              <a:t> importance*?"</a:t>
-            </a:r>
-          </a:p>
-          <a:p>
-            <a:r>
-              <a:rPr lang="en-US" dirty="0"/>
-              <a:t>"habitats directive*?"                                    </a:t>
-            </a:r>
-          </a:p>
-          <a:p>
-            <a:r>
-              <a:rPr lang="en-US" dirty="0"/>
-              <a:t>"sites of community importance*?"                        </a:t>
-            </a:r>
-          </a:p>
-          <a:p>
-            <a:r>
-              <a:rPr lang="en-US" dirty="0"/>
-              <a:t>"site of community importance*?"                        </a:t>
-            </a:r>
-          </a:p>
-          <a:p>
-            <a:r>
-              <a:rPr lang="en-US" dirty="0"/>
-              <a:t>"special areas of conservation*?"                        </a:t>
-            </a:r>
-          </a:p>
-          <a:p>
-            <a:r>
-              <a:rPr lang="en-US" dirty="0"/>
-              <a:t>"birds directive*?"                                       </a:t>
-            </a:r>
-          </a:p>
-          <a:p>
-            <a:r>
-              <a:rPr lang="en-US" dirty="0"/>
-              <a:t>"special protection area*?"                              </a:t>
-            </a:r>
-          </a:p>
-          <a:p>
-            <a:r>
-              <a:rPr lang="en-US" dirty="0"/>
-              <a:t>"</a:t>
-            </a:r>
-            <a:r>
-              <a:rPr lang="en-US" dirty="0" err="1"/>
-              <a:t>helcom</a:t>
-            </a:r>
-            <a:r>
-              <a:rPr lang="en-US" dirty="0"/>
-              <a:t>*?"                                               </a:t>
-            </a:r>
-          </a:p>
-          <a:p>
-            <a:r>
-              <a:rPr lang="en-US" dirty="0"/>
-              <a:t>"</a:t>
-            </a:r>
-            <a:r>
-              <a:rPr lang="en-US" dirty="0" err="1"/>
-              <a:t>baltic</a:t>
-            </a:r>
-            <a:r>
-              <a:rPr lang="en-US" dirty="0"/>
-              <a:t> sea protected area*?"                            </a:t>
-            </a:r>
-          </a:p>
-          <a:p>
-            <a:r>
-              <a:rPr lang="en-US" dirty="0"/>
-              <a:t>"</a:t>
-            </a:r>
-            <a:r>
-              <a:rPr lang="en-US" dirty="0" err="1"/>
-              <a:t>ospar</a:t>
-            </a:r>
-            <a:r>
-              <a:rPr lang="en-US" dirty="0"/>
-              <a:t>*?"                                                 </a:t>
-            </a:r>
-          </a:p>
-          <a:p>
-            <a:r>
-              <a:rPr lang="en-US" dirty="0"/>
-              <a:t>"marine protected area*?"                                </a:t>
-            </a:r>
-          </a:p>
-          <a:p>
-            <a:r>
-              <a:rPr lang="en-US" dirty="0"/>
-              <a:t>"</a:t>
-            </a:r>
-            <a:r>
-              <a:rPr lang="en-US" dirty="0" err="1"/>
-              <a:t>cartagena</a:t>
-            </a:r>
-            <a:r>
-              <a:rPr lang="en-US" dirty="0"/>
-              <a:t> convention*?"                                  </a:t>
-            </a:r>
-          </a:p>
-          <a:p>
-            <a:r>
-              <a:rPr lang="en-US" dirty="0"/>
-              <a:t>"specially protected area*?" </a:t>
+              <a:t> world heritage site*?               	2</a:t>
             </a:r>
             <a:endParaRPr lang="da-DK" dirty="0"/>
           </a:p>

</xml_diff>

<commit_message>
adding more info to the slides
</commit_message>
<xml_diff>
--- a/WP4/prelim.res.pptx
+++ b/WP4/prelim.res.pptx
@@ -13,7 +13,8 @@
     <p:sldId id="261" r:id="rId7"/>
     <p:sldId id="264" r:id="rId8"/>
     <p:sldId id="262" r:id="rId9"/>
-    <p:sldId id="263" r:id="rId10"/>
+    <p:sldId id="265" r:id="rId10"/>
+    <p:sldId id="263" r:id="rId11"/>
   </p:sldIdLst>
   <p:sldSz cx="12192000" cy="6858000"/>
   <p:notesSz cx="6858000" cy="9144000"/>
@@ -4237,6 +4238,485 @@
 </p:sld>
 </file>
 
+<file path=ppt/slides/slide10.xml><?xml version="1.0" encoding="utf-8"?>
+<p:sld xmlns:a="http://schemas.openxmlformats.org/drawingml/2006/main" xmlns:r="http://schemas.openxmlformats.org/officeDocument/2006/relationships" xmlns:p="http://schemas.openxmlformats.org/presentationml/2006/main">
+  <p:cSld>
+    <p:spTree>
+      <p:nvGrpSpPr>
+        <p:cNvPr id="1" name=""/>
+        <p:cNvGrpSpPr/>
+        <p:nvPr/>
+      </p:nvGrpSpPr>
+      <p:grpSpPr>
+        <a:xfrm>
+          <a:off x="0" y="0"/>
+          <a:ext cx="0" cy="0"/>
+          <a:chOff x="0" y="0"/>
+          <a:chExt cx="0" cy="0"/>
+        </a:xfrm>
+      </p:grpSpPr>
+      <p:sp>
+        <p:nvSpPr>
+          <p:cNvPr id="2" name="TextBox 1">
+            <a:extLst>
+              <a:ext uri="{FF2B5EF4-FFF2-40B4-BE49-F238E27FC236}">
+                <a16:creationId xmlns:a16="http://schemas.microsoft.com/office/drawing/2014/main" id="{5BB07304-B6AC-47B8-CA58-4A667E6847DC}"/>
+              </a:ext>
+            </a:extLst>
+          </p:cNvPr>
+          <p:cNvSpPr txBox="1"/>
+          <p:nvPr/>
+        </p:nvSpPr>
+        <p:spPr>
+          <a:xfrm>
+            <a:off x="300245" y="661366"/>
+            <a:ext cx="11646590" cy="3139321"/>
+          </a:xfrm>
+          <a:prstGeom prst="rect">
+            <a:avLst/>
+          </a:prstGeom>
+          <a:noFill/>
+        </p:spPr>
+        <p:txBody>
+          <a:bodyPr wrap="square" rtlCol="0">
+            <a:spAutoFit/>
+          </a:bodyPr>
+          <a:lstStyle/>
+          <a:p>
+            <a:r>
+              <a:rPr lang="da-DK" b="1" dirty="0" err="1"/>
+              <a:t>Moving</a:t>
+            </a:r>
+            <a:r>
+              <a:rPr lang="da-DK" b="1" dirty="0"/>
+              <a:t> forwards </a:t>
+            </a:r>
+            <a:r>
+              <a:rPr lang="da-DK" b="1" dirty="0" err="1"/>
+              <a:t>what</a:t>
+            </a:r>
+            <a:r>
+              <a:rPr lang="da-DK" b="1" dirty="0"/>
+              <a:t> kind of </a:t>
+            </a:r>
+            <a:r>
+              <a:rPr lang="da-DK" b="1" dirty="0" err="1"/>
+              <a:t>analysis</a:t>
+            </a:r>
+            <a:r>
+              <a:rPr lang="da-DK" b="1" dirty="0"/>
+              <a:t> </a:t>
+            </a:r>
+            <a:r>
+              <a:rPr lang="da-DK" b="1" dirty="0" err="1"/>
+              <a:t>should</a:t>
+            </a:r>
+            <a:r>
+              <a:rPr lang="da-DK" b="1" dirty="0"/>
+              <a:t> I </a:t>
+            </a:r>
+            <a:r>
+              <a:rPr lang="da-DK" b="1" dirty="0" err="1"/>
+              <a:t>preform</a:t>
+            </a:r>
+            <a:r>
+              <a:rPr lang="da-DK" b="1" dirty="0"/>
+              <a:t>?</a:t>
+            </a:r>
+          </a:p>
+          <a:p>
+            <a:endParaRPr lang="da-DK" b="1" dirty="0"/>
+          </a:p>
+          <a:p>
+            <a:r>
+              <a:rPr lang="da-DK" b="1" dirty="0"/>
+              <a:t>NETWORKS:</a:t>
+            </a:r>
+          </a:p>
+          <a:p>
+            <a:pPr marL="285750" indent="-285750">
+              <a:buFont typeface="Wingdings" panose="05000000000000000000" pitchFamily="2" charset="2"/>
+              <a:buChar char="à"/>
+            </a:pPr>
+            <a:r>
+              <a:rPr lang="da-DK" dirty="0">
+                <a:sym typeface="Wingdings" panose="05000000000000000000" pitchFamily="2" charset="2"/>
+              </a:rPr>
+              <a:t>Same </a:t>
+            </a:r>
+            <a:r>
+              <a:rPr lang="da-DK" dirty="0" err="1">
+                <a:sym typeface="Wingdings" panose="05000000000000000000" pitchFamily="2" charset="2"/>
+              </a:rPr>
+              <a:t>ones</a:t>
+            </a:r>
+            <a:r>
+              <a:rPr lang="da-DK" dirty="0">
+                <a:sym typeface="Wingdings" panose="05000000000000000000" pitchFamily="2" charset="2"/>
+              </a:rPr>
+              <a:t> as I did in </a:t>
+            </a:r>
+            <a:r>
+              <a:rPr lang="da-DK" dirty="0" err="1">
+                <a:sym typeface="Wingdings" panose="05000000000000000000" pitchFamily="2" charset="2"/>
+              </a:rPr>
+              <a:t>thesis</a:t>
+            </a:r>
+            <a:r>
+              <a:rPr lang="da-DK" dirty="0">
+                <a:sym typeface="Wingdings" panose="05000000000000000000" pitchFamily="2" charset="2"/>
+              </a:rPr>
+              <a:t>? </a:t>
+            </a:r>
+          </a:p>
+          <a:p>
+            <a:pPr marL="742950" lvl="1" indent="-285750">
+              <a:buFont typeface="Wingdings" panose="05000000000000000000" pitchFamily="2" charset="2"/>
+              <a:buChar char="à"/>
+            </a:pPr>
+            <a:r>
+              <a:rPr lang="da-DK" dirty="0">
+                <a:sym typeface="Wingdings" panose="05000000000000000000" pitchFamily="2" charset="2"/>
+              </a:rPr>
+              <a:t>Is </a:t>
+            </a:r>
+            <a:r>
+              <a:rPr lang="da-DK" dirty="0" err="1">
+                <a:sym typeface="Wingdings" panose="05000000000000000000" pitchFamily="2" charset="2"/>
+              </a:rPr>
+              <a:t>this</a:t>
+            </a:r>
+            <a:r>
+              <a:rPr lang="da-DK" dirty="0">
+                <a:sym typeface="Wingdings" panose="05000000000000000000" pitchFamily="2" charset="2"/>
+              </a:rPr>
+              <a:t> </a:t>
+            </a:r>
+            <a:r>
+              <a:rPr lang="da-DK" dirty="0" err="1">
+                <a:sym typeface="Wingdings" panose="05000000000000000000" pitchFamily="2" charset="2"/>
+              </a:rPr>
+              <a:t>technically</a:t>
+            </a:r>
+            <a:r>
+              <a:rPr lang="da-DK" dirty="0">
+                <a:sym typeface="Wingdings" panose="05000000000000000000" pitchFamily="2" charset="2"/>
+              </a:rPr>
+              <a:t> </a:t>
+            </a:r>
+            <a:r>
+              <a:rPr lang="da-DK" dirty="0" err="1">
+                <a:sym typeface="Wingdings" panose="05000000000000000000" pitchFamily="2" charset="2"/>
+              </a:rPr>
+              <a:t>bipartite</a:t>
+            </a:r>
+            <a:r>
+              <a:rPr lang="da-DK" dirty="0">
+                <a:sym typeface="Wingdings" panose="05000000000000000000" pitchFamily="2" charset="2"/>
+              </a:rPr>
+              <a:t> </a:t>
+            </a:r>
+            <a:r>
+              <a:rPr lang="da-DK" dirty="0" err="1">
+                <a:sym typeface="Wingdings" panose="05000000000000000000" pitchFamily="2" charset="2"/>
+              </a:rPr>
+              <a:t>since</a:t>
+            </a:r>
+            <a:r>
+              <a:rPr lang="da-DK" dirty="0">
+                <a:sym typeface="Wingdings" panose="05000000000000000000" pitchFamily="2" charset="2"/>
+              </a:rPr>
+              <a:t> a </a:t>
+            </a:r>
+            <a:r>
+              <a:rPr lang="da-DK" dirty="0" err="1">
+                <a:sym typeface="Wingdings" panose="05000000000000000000" pitchFamily="2" charset="2"/>
+              </a:rPr>
+              <a:t>result</a:t>
+            </a:r>
+            <a:r>
+              <a:rPr lang="da-DK" dirty="0">
+                <a:sym typeface="Wingdings" panose="05000000000000000000" pitchFamily="2" charset="2"/>
+              </a:rPr>
+              <a:t> </a:t>
+            </a:r>
+            <a:r>
+              <a:rPr lang="da-DK" dirty="0" err="1">
+                <a:sym typeface="Wingdings" panose="05000000000000000000" pitchFamily="2" charset="2"/>
+              </a:rPr>
+              <a:t>document</a:t>
+            </a:r>
+            <a:r>
+              <a:rPr lang="da-DK" dirty="0">
+                <a:sym typeface="Wingdings" panose="05000000000000000000" pitchFamily="2" charset="2"/>
+              </a:rPr>
+              <a:t> </a:t>
+            </a:r>
+            <a:r>
+              <a:rPr lang="da-DK" dirty="0" err="1">
+                <a:sym typeface="Wingdings" panose="05000000000000000000" pitchFamily="2" charset="2"/>
+              </a:rPr>
+              <a:t>can</a:t>
+            </a:r>
+            <a:r>
+              <a:rPr lang="da-DK" dirty="0">
+                <a:sym typeface="Wingdings" panose="05000000000000000000" pitchFamily="2" charset="2"/>
+              </a:rPr>
+              <a:t> </a:t>
+            </a:r>
+            <a:r>
+              <a:rPr lang="da-DK" dirty="0" err="1">
+                <a:sym typeface="Wingdings" panose="05000000000000000000" pitchFamily="2" charset="2"/>
+              </a:rPr>
+              <a:t>also</a:t>
+            </a:r>
+            <a:r>
+              <a:rPr lang="da-DK" dirty="0">
+                <a:sym typeface="Wingdings" panose="05000000000000000000" pitchFamily="2" charset="2"/>
+              </a:rPr>
+              <a:t> </a:t>
+            </a:r>
+            <a:r>
+              <a:rPr lang="da-DK" dirty="0" err="1">
+                <a:sym typeface="Wingdings" panose="05000000000000000000" pitchFamily="2" charset="2"/>
+              </a:rPr>
+              <a:t>be</a:t>
+            </a:r>
+            <a:r>
+              <a:rPr lang="da-DK" dirty="0">
+                <a:sym typeface="Wingdings" panose="05000000000000000000" pitchFamily="2" charset="2"/>
+              </a:rPr>
+              <a:t> a citation </a:t>
+            </a:r>
+          </a:p>
+          <a:p>
+            <a:pPr marL="1200150" lvl="2" indent="-285750">
+              <a:buFont typeface="Wingdings" panose="05000000000000000000" pitchFamily="2" charset="2"/>
+              <a:buChar char="à"/>
+            </a:pPr>
+            <a:r>
+              <a:rPr lang="da-DK" dirty="0">
+                <a:sym typeface="Wingdings" panose="05000000000000000000" pitchFamily="2" charset="2"/>
+              </a:rPr>
+              <a:t>In addition </a:t>
+            </a:r>
+            <a:r>
+              <a:rPr lang="da-DK" dirty="0" err="1">
+                <a:sym typeface="Wingdings" panose="05000000000000000000" pitchFamily="2" charset="2"/>
+              </a:rPr>
+              <a:t>now</a:t>
+            </a:r>
+            <a:r>
+              <a:rPr lang="da-DK" dirty="0">
+                <a:sym typeface="Wingdings" panose="05000000000000000000" pitchFamily="2" charset="2"/>
+              </a:rPr>
+              <a:t> </a:t>
+            </a:r>
+            <a:r>
+              <a:rPr lang="da-DK" dirty="0" err="1">
+                <a:sym typeface="Wingdings" panose="05000000000000000000" pitchFamily="2" charset="2"/>
+              </a:rPr>
+              <a:t>we</a:t>
+            </a:r>
+            <a:r>
+              <a:rPr lang="da-DK" dirty="0">
+                <a:sym typeface="Wingdings" panose="05000000000000000000" pitchFamily="2" charset="2"/>
+              </a:rPr>
+              <a:t> have </a:t>
+            </a:r>
+            <a:r>
+              <a:rPr lang="da-DK" dirty="0" err="1">
+                <a:sym typeface="Wingdings" panose="05000000000000000000" pitchFamily="2" charset="2"/>
+              </a:rPr>
+              <a:t>three</a:t>
+            </a:r>
+            <a:r>
+              <a:rPr lang="da-DK" dirty="0">
+                <a:sym typeface="Wingdings" panose="05000000000000000000" pitchFamily="2" charset="2"/>
+              </a:rPr>
+              <a:t> </a:t>
+            </a:r>
+            <a:r>
+              <a:rPr lang="da-DK" dirty="0" err="1">
+                <a:sym typeface="Wingdings" panose="05000000000000000000" pitchFamily="2" charset="2"/>
+              </a:rPr>
+              <a:t>levels</a:t>
+            </a:r>
+            <a:r>
+              <a:rPr lang="da-DK" dirty="0">
+                <a:sym typeface="Wingdings" panose="05000000000000000000" pitchFamily="2" charset="2"/>
+              </a:rPr>
+              <a:t>, </a:t>
+            </a:r>
+            <a:r>
+              <a:rPr lang="da-DK" dirty="0" err="1">
+                <a:sym typeface="Wingdings" panose="05000000000000000000" pitchFamily="2" charset="2"/>
+              </a:rPr>
+              <a:t>result</a:t>
+            </a:r>
+            <a:r>
+              <a:rPr lang="da-DK" dirty="0">
+                <a:sym typeface="Wingdings" panose="05000000000000000000" pitchFamily="2" charset="2"/>
+              </a:rPr>
+              <a:t> doc, 1st </a:t>
+            </a:r>
+            <a:r>
+              <a:rPr lang="da-DK" dirty="0" err="1">
+                <a:sym typeface="Wingdings" panose="05000000000000000000" pitchFamily="2" charset="2"/>
+              </a:rPr>
+              <a:t>order</a:t>
+            </a:r>
+            <a:r>
+              <a:rPr lang="da-DK" dirty="0">
+                <a:sym typeface="Wingdings" panose="05000000000000000000" pitchFamily="2" charset="2"/>
+              </a:rPr>
+              <a:t> citation and </a:t>
+            </a:r>
+            <a:r>
+              <a:rPr lang="da-DK" dirty="0" err="1">
+                <a:sym typeface="Wingdings" panose="05000000000000000000" pitchFamily="2" charset="2"/>
+              </a:rPr>
+              <a:t>second</a:t>
+            </a:r>
+            <a:r>
+              <a:rPr lang="da-DK" dirty="0">
+                <a:sym typeface="Wingdings" panose="05000000000000000000" pitchFamily="2" charset="2"/>
+              </a:rPr>
+              <a:t> </a:t>
+            </a:r>
+            <a:r>
+              <a:rPr lang="da-DK" dirty="0" err="1">
+                <a:sym typeface="Wingdings" panose="05000000000000000000" pitchFamily="2" charset="2"/>
+              </a:rPr>
+              <a:t>order</a:t>
+            </a:r>
+            <a:r>
+              <a:rPr lang="da-DK" dirty="0">
+                <a:sym typeface="Wingdings" panose="05000000000000000000" pitchFamily="2" charset="2"/>
+              </a:rPr>
+              <a:t> citation</a:t>
+            </a:r>
+          </a:p>
+          <a:p>
+            <a:pPr marL="285750" indent="-285750">
+              <a:buFont typeface="Wingdings" panose="05000000000000000000" pitchFamily="2" charset="2"/>
+              <a:buChar char="à"/>
+            </a:pPr>
+            <a:r>
+              <a:rPr lang="da-DK" dirty="0">
+                <a:sym typeface="Wingdings" panose="05000000000000000000" pitchFamily="2" charset="2"/>
+              </a:rPr>
+              <a:t>A </a:t>
+            </a:r>
+            <a:r>
+              <a:rPr lang="da-DK" dirty="0" err="1">
+                <a:sym typeface="Wingdings" panose="05000000000000000000" pitchFamily="2" charset="2"/>
+              </a:rPr>
+              <a:t>particular</a:t>
+            </a:r>
+            <a:r>
+              <a:rPr lang="da-DK" dirty="0">
+                <a:sym typeface="Wingdings" panose="05000000000000000000" pitchFamily="2" charset="2"/>
+              </a:rPr>
+              <a:t> </a:t>
+            </a:r>
+            <a:r>
+              <a:rPr lang="da-DK" dirty="0" err="1">
+                <a:sym typeface="Wingdings" panose="05000000000000000000" pitchFamily="2" charset="2"/>
+              </a:rPr>
+              <a:t>analysis</a:t>
+            </a:r>
+            <a:r>
+              <a:rPr lang="da-DK" dirty="0">
+                <a:sym typeface="Wingdings" panose="05000000000000000000" pitchFamily="2" charset="2"/>
+              </a:rPr>
+              <a:t> for the term </a:t>
+            </a:r>
+            <a:r>
+              <a:rPr lang="da-DK" dirty="0" err="1">
+                <a:sym typeface="Wingdings" panose="05000000000000000000" pitchFamily="2" charset="2"/>
+              </a:rPr>
+              <a:t>ococcurances</a:t>
+            </a:r>
+            <a:r>
+              <a:rPr lang="da-DK" dirty="0">
+                <a:sym typeface="Wingdings" panose="05000000000000000000" pitchFamily="2" charset="2"/>
+              </a:rPr>
+              <a:t> </a:t>
+            </a:r>
+            <a:r>
+              <a:rPr lang="da-DK" dirty="0" err="1">
+                <a:sym typeface="Wingdings" panose="05000000000000000000" pitchFamily="2" charset="2"/>
+              </a:rPr>
+              <a:t>network</a:t>
+            </a:r>
+            <a:r>
+              <a:rPr lang="da-DK" dirty="0">
+                <a:sym typeface="Wingdings" panose="05000000000000000000" pitchFamily="2" charset="2"/>
+              </a:rPr>
+              <a:t>?</a:t>
+            </a:r>
+          </a:p>
+          <a:p>
+            <a:pPr marL="285750" indent="-285750">
+              <a:buFont typeface="Wingdings" panose="05000000000000000000" pitchFamily="2" charset="2"/>
+              <a:buChar char="à"/>
+            </a:pPr>
+            <a:endParaRPr lang="da-DK" dirty="0">
+              <a:sym typeface="Wingdings" panose="05000000000000000000" pitchFamily="2" charset="2"/>
+            </a:endParaRPr>
+          </a:p>
+          <a:p>
+            <a:r>
+              <a:rPr lang="da-DK" b="1" dirty="0">
+                <a:sym typeface="Wingdings" panose="05000000000000000000" pitchFamily="2" charset="2"/>
+              </a:rPr>
+              <a:t>TEXT DATA:</a:t>
+            </a:r>
+          </a:p>
+          <a:p>
+            <a:r>
+              <a:rPr lang="da-DK" dirty="0">
+                <a:sym typeface="Wingdings" panose="05000000000000000000" pitchFamily="2" charset="2"/>
+              </a:rPr>
+              <a:t> Term </a:t>
+            </a:r>
+            <a:r>
+              <a:rPr lang="da-DK" dirty="0" err="1">
+                <a:sym typeface="Wingdings" panose="05000000000000000000" pitchFamily="2" charset="2"/>
+              </a:rPr>
+              <a:t>frequencies</a:t>
+            </a:r>
+            <a:r>
+              <a:rPr lang="da-DK" dirty="0">
+                <a:sym typeface="Wingdings" panose="05000000000000000000" pitchFamily="2" charset="2"/>
+              </a:rPr>
+              <a:t>?</a:t>
+            </a:r>
+          </a:p>
+          <a:p>
+            <a:r>
+              <a:rPr lang="da-DK" dirty="0">
+                <a:sym typeface="Wingdings" pitchFamily="2" charset="2"/>
+              </a:rPr>
+              <a:t> ?</a:t>
+            </a:r>
+          </a:p>
+        </p:txBody>
+      </p:sp>
+    </p:spTree>
+    <p:extLst>
+      <p:ext uri="{BB962C8B-B14F-4D97-AF65-F5344CB8AC3E}">
+        <p14:creationId xmlns:p14="http://schemas.microsoft.com/office/powerpoint/2010/main" val="1461501907"/>
+      </p:ext>
+    </p:extLst>
+  </p:cSld>
+  <p:clrMapOvr>
+    <a:masterClrMapping/>
+  </p:clrMapOvr>
+</p:sld>
+</file>
+
 <file path=ppt/slides/slide2.xml><?xml version="1.0" encoding="utf-8"?>
 <p:sld xmlns:a="http://schemas.openxmlformats.org/drawingml/2006/main" xmlns:r="http://schemas.openxmlformats.org/officeDocument/2006/relationships" xmlns:p="http://schemas.openxmlformats.org/presentationml/2006/main">
   <p:cSld>
@@ -5856,8 +6336,8 @@
         </p:nvSpPr>
         <p:spPr>
           <a:xfrm>
-            <a:off x="349514" y="1013355"/>
-            <a:ext cx="6270362" cy="3970318"/>
+            <a:off x="349513" y="1731812"/>
+            <a:ext cx="11842487" cy="3970318"/>
           </a:xfrm>
           <a:prstGeom prst="rect">
             <a:avLst/>
@@ -5889,7 +6369,7 @@
             </a:r>
             <a:r>
               <a:rPr lang="en-US" b="1" dirty="0"/>
-              <a:t>                                    </a:t>
+              <a:t>                              </a:t>
             </a:r>
             <a:r>
               <a:rPr lang="en-US" b="1" dirty="0" err="1"/>
@@ -5897,7 +6377,47 @@
             </a:r>
             <a:r>
               <a:rPr lang="en-US" b="1" dirty="0"/>
-              <a:t>. of documents pulled</a:t>
+              <a:t>. of documents pulled.     </a:t>
+            </a:r>
+            <a:r>
+              <a:rPr lang="en-US" b="1" dirty="0" err="1"/>
+              <a:t>Nmbr</a:t>
+            </a:r>
+            <a:r>
+              <a:rPr lang="en-US" b="1" dirty="0"/>
+              <a:t>. Of </a:t>
+            </a:r>
+            <a:r>
+              <a:rPr lang="en-US" b="1" dirty="0" err="1"/>
+              <a:t>mpas</a:t>
+            </a:r>
+            <a:r>
+              <a:rPr lang="en-US" b="1" dirty="0"/>
+              <a:t>        </a:t>
+            </a:r>
+            <a:r>
+              <a:rPr lang="en-US" b="1" dirty="0" err="1"/>
+              <a:t>Nmbr</a:t>
+            </a:r>
+            <a:r>
+              <a:rPr lang="en-US" b="1" dirty="0"/>
+              <a:t>. Of EU countries linked via </a:t>
+            </a:r>
+            <a:r>
+              <a:rPr lang="en-US" b="1" dirty="0" err="1"/>
+              <a:t>mpa</a:t>
+            </a:r>
+            <a:r>
+              <a:rPr lang="en-US" b="1" dirty="0"/>
+              <a:t> </a:t>
+            </a:r>
+            <a:r>
+              <a:rPr lang="en-US" b="1" dirty="0" err="1"/>
+              <a:t>desig</a:t>
+            </a:r>
+            <a:r>
+              <a:rPr lang="en-US" b="1" dirty="0"/>
+              <a:t>.</a:t>
             </a:r>
           </a:p>
           <a:p>
@@ -5911,19 +6431,19 @@
             </a:r>
             <a:r>
               <a:rPr lang="en-US" dirty="0"/>
-              <a:t> convention*?               	37</a:t>
+              <a:t> convention*?               	37			24			4</a:t>
             </a:r>
           </a:p>
           <a:p>
             <a:r>
               <a:rPr lang="en-US" dirty="0"/>
-              <a:t> birds directive*?                            	6</a:t>
+              <a:t> birds directive*?                            	6			843			23</a:t>
             </a:r>
           </a:p>
           <a:p>
             <a:r>
               <a:rPr lang="en-US" dirty="0"/>
-              <a:t> habitats directive*?                      	56</a:t>
+              <a:t> habitats directive*?                      	56			1869			22</a:t>
             </a:r>
           </a:p>
           <a:p>
@@ -5937,13 +6457,13 @@
             </a:r>
             <a:r>
               <a:rPr lang="en-US" dirty="0"/>
-              <a:t>*?                                       	12</a:t>
+              <a:t>*?                                       	12			163			8</a:t>
             </a:r>
           </a:p>
           <a:p>
             <a:r>
               <a:rPr lang="en-US" dirty="0"/>
-              <a:t> marine protected area*?            	18</a:t>
+              <a:t> marine protected area*?            	18			441 			10</a:t>
             </a:r>
           </a:p>
           <a:p>
@@ -5957,7 +6477,7 @@
             </a:r>
             <a:r>
               <a:rPr lang="en-US" dirty="0"/>
-              <a:t>*?                                          	19</a:t>
+              <a:t>*?                                          	19			441			10</a:t>
             </a:r>
           </a:p>
           <a:p>
@@ -5971,31 +6491,31 @@
             </a:r>
             <a:r>
               <a:rPr lang="en-US" dirty="0"/>
-              <a:t> site*?                                	1</a:t>
+              <a:t> site*?                                	1			237			18</a:t>
             </a:r>
           </a:p>
           <a:p>
             <a:r>
               <a:rPr lang="en-US" dirty="0"/>
-              <a:t> sites of community importance*?         5</a:t>
+              <a:t> sites of community importance*?         5			481			18</a:t>
             </a:r>
           </a:p>
           <a:p>
             <a:r>
               <a:rPr lang="en-US" dirty="0"/>
-              <a:t> special areas of conservation*?    	16</a:t>
+              <a:t> special areas of conservation*?    	16			1388			19</a:t>
             </a:r>
           </a:p>
           <a:p>
             <a:r>
               <a:rPr lang="en-US" dirty="0"/>
-              <a:t> special protection area*?           	7</a:t>
+              <a:t> special protection area*?           	7			843			23</a:t>
             </a:r>
           </a:p>
           <a:p>
             <a:r>
               <a:rPr lang="en-US" dirty="0"/>
-              <a:t> world heritage site*?               	2</a:t>
+              <a:t> world heritage site*?               	2			9			4</a:t>
             </a:r>
             <a:endParaRPr lang="da-DK" dirty="0"/>
           </a:p>
@@ -6015,8 +6535,8 @@
         </p:nvSpPr>
         <p:spPr>
           <a:xfrm>
-            <a:off x="7877175" y="870480"/>
-            <a:ext cx="3965311" cy="1200329"/>
+            <a:off x="4113344" y="213136"/>
+            <a:ext cx="8078656" cy="646331"/>
           </a:xfrm>
           <a:prstGeom prst="rect">
             <a:avLst/>
@@ -8338,7 +8858,7 @@
           <p:cNvPr id="2" name="TextBox 1">
             <a:extLst>
               <a:ext uri="{FF2B5EF4-FFF2-40B4-BE49-F238E27FC236}">
-                <a16:creationId xmlns:a16="http://schemas.microsoft.com/office/drawing/2014/main" id="{5BB07304-B6AC-47B8-CA58-4A667E6847DC}"/>
+                <a16:creationId xmlns:a16="http://schemas.microsoft.com/office/drawing/2014/main" id="{AA54756A-6B1F-B0BE-66FA-268FDD5CAE98}"/>
               </a:ext>
             </a:extLst>
           </p:cNvPr>
@@ -8347,8 +8867,8 @@
         </p:nvSpPr>
         <p:spPr>
           <a:xfrm>
-            <a:off x="300245" y="661366"/>
-            <a:ext cx="11646590" cy="2862322"/>
+            <a:off x="129502" y="1172279"/>
+            <a:ext cx="4773573" cy="5109091"/>
           </a:xfrm>
           <a:prstGeom prst="rect">
             <a:avLst/>
@@ -8362,410 +8882,420 @@
           <a:lstStyle/>
           <a:p>
             <a:r>
-              <a:rPr lang="da-DK" b="1" dirty="0" err="1"/>
-              <a:t>Moving</a:t>
-            </a:r>
-            <a:r>
-              <a:rPr lang="da-DK" b="1" dirty="0"/>
-              <a:t> forwards </a:t>
-            </a:r>
-            <a:r>
-              <a:rPr lang="da-DK" b="1" dirty="0" err="1"/>
-              <a:t>what</a:t>
-            </a:r>
-            <a:r>
-              <a:rPr lang="da-DK" b="1" dirty="0"/>
-              <a:t> kind of </a:t>
-            </a:r>
-            <a:r>
-              <a:rPr lang="da-DK" b="1" dirty="0" err="1"/>
-              <a:t>analysis</a:t>
-            </a:r>
-            <a:r>
-              <a:rPr lang="da-DK" b="1" dirty="0"/>
-              <a:t> </a:t>
-            </a:r>
-            <a:r>
-              <a:rPr lang="da-DK" b="1" dirty="0" err="1"/>
-              <a:t>should</a:t>
-            </a:r>
-            <a:r>
-              <a:rPr lang="da-DK" b="1" dirty="0"/>
-              <a:t> I </a:t>
-            </a:r>
-            <a:r>
-              <a:rPr lang="da-DK" b="1" dirty="0" err="1"/>
-              <a:t>preform</a:t>
-            </a:r>
-            <a:r>
-              <a:rPr lang="da-DK" b="1" dirty="0"/>
-              <a:t>?</a:t>
-            </a:r>
-          </a:p>
-          <a:p>
-            <a:endParaRPr lang="da-DK" b="1" dirty="0"/>
-          </a:p>
-          <a:p>
-            <a:r>
-              <a:rPr lang="da-DK" b="1" dirty="0"/>
-              <a:t>NETWORKS:</a:t>
+              <a:rPr lang="en-US" b="1" dirty="0"/>
+              <a:t>What I have for the text data for both queries</a:t>
+            </a:r>
+          </a:p>
+          <a:p>
+            <a:endParaRPr lang="en-US" b="1" dirty="0"/>
+          </a:p>
+          <a:p>
+            <a:endParaRPr lang="en-US" sz="1600" b="1" dirty="0"/>
+          </a:p>
+          <a:p>
+            <a:r>
+              <a:rPr lang="en-US" sz="1600" dirty="0"/>
+              <a:t>Extracted title and body and combined them. </a:t>
+            </a:r>
+          </a:p>
+          <a:p>
+            <a:endParaRPr lang="en-US" sz="1600" b="1" dirty="0"/>
+          </a:p>
+          <a:p>
+            <a:r>
+              <a:rPr lang="en-US" sz="1600" b="1" dirty="0"/>
+              <a:t>For possible text model analysis:</a:t>
             </a:r>
           </a:p>
           <a:p>
             <a:pPr marL="285750" indent="-285750">
-              <a:buFont typeface="Wingdings" panose="05000000000000000000" pitchFamily="2" charset="2"/>
+              <a:buFont typeface="Wingdings" pitchFamily="2" charset="2"/>
               <a:buChar char="à"/>
             </a:pPr>
             <a:r>
-              <a:rPr lang="da-DK" dirty="0">
-                <a:sym typeface="Wingdings" panose="05000000000000000000" pitchFamily="2" charset="2"/>
-              </a:rPr>
-              <a:t>Same </a:t>
-            </a:r>
-            <a:r>
-              <a:rPr lang="da-DK" dirty="0" err="1">
-                <a:sym typeface="Wingdings" panose="05000000000000000000" pitchFamily="2" charset="2"/>
-              </a:rPr>
-              <a:t>ones</a:t>
-            </a:r>
-            <a:r>
-              <a:rPr lang="da-DK" dirty="0">
-                <a:sym typeface="Wingdings" panose="05000000000000000000" pitchFamily="2" charset="2"/>
-              </a:rPr>
-              <a:t> as I did in </a:t>
-            </a:r>
-            <a:r>
-              <a:rPr lang="da-DK" dirty="0" err="1">
-                <a:sym typeface="Wingdings" panose="05000000000000000000" pitchFamily="2" charset="2"/>
-              </a:rPr>
-              <a:t>thesis</a:t>
-            </a:r>
-            <a:r>
-              <a:rPr lang="da-DK" dirty="0">
-                <a:sym typeface="Wingdings" panose="05000000000000000000" pitchFamily="2" charset="2"/>
-              </a:rPr>
-              <a:t>? </a:t>
-            </a:r>
-          </a:p>
-          <a:p>
-            <a:pPr marL="742950" lvl="1" indent="-285750">
-              <a:buFont typeface="Wingdings" panose="05000000000000000000" pitchFamily="2" charset="2"/>
+              <a:rPr lang="en-US" sz="1600" dirty="0">
+                <a:sym typeface="Wingdings" pitchFamily="2" charset="2"/>
+              </a:rPr>
+              <a:t>Converted to lowercase</a:t>
+            </a:r>
+          </a:p>
+          <a:p>
+            <a:pPr marL="285750" indent="-285750">
+              <a:buFont typeface="Wingdings" pitchFamily="2" charset="2"/>
               <a:buChar char="à"/>
             </a:pPr>
             <a:r>
-              <a:rPr lang="da-DK" dirty="0">
-                <a:sym typeface="Wingdings" panose="05000000000000000000" pitchFamily="2" charset="2"/>
-              </a:rPr>
-              <a:t>Is </a:t>
-            </a:r>
-            <a:r>
-              <a:rPr lang="da-DK" dirty="0" err="1">
-                <a:sym typeface="Wingdings" panose="05000000000000000000" pitchFamily="2" charset="2"/>
-              </a:rPr>
-              <a:t>this</a:t>
-            </a:r>
-            <a:r>
-              <a:rPr lang="da-DK" dirty="0">
-                <a:sym typeface="Wingdings" panose="05000000000000000000" pitchFamily="2" charset="2"/>
-              </a:rPr>
-              <a:t> </a:t>
-            </a:r>
-            <a:r>
-              <a:rPr lang="da-DK" dirty="0" err="1">
-                <a:sym typeface="Wingdings" panose="05000000000000000000" pitchFamily="2" charset="2"/>
-              </a:rPr>
-              <a:t>technically</a:t>
-            </a:r>
-            <a:r>
-              <a:rPr lang="da-DK" dirty="0">
-                <a:sym typeface="Wingdings" panose="05000000000000000000" pitchFamily="2" charset="2"/>
-              </a:rPr>
-              <a:t> </a:t>
-            </a:r>
-            <a:r>
-              <a:rPr lang="da-DK" dirty="0" err="1">
-                <a:sym typeface="Wingdings" panose="05000000000000000000" pitchFamily="2" charset="2"/>
-              </a:rPr>
-              <a:t>bipartite</a:t>
-            </a:r>
-            <a:r>
-              <a:rPr lang="da-DK" dirty="0">
-                <a:sym typeface="Wingdings" panose="05000000000000000000" pitchFamily="2" charset="2"/>
-              </a:rPr>
-              <a:t> </a:t>
-            </a:r>
-            <a:r>
-              <a:rPr lang="da-DK" dirty="0" err="1">
-                <a:sym typeface="Wingdings" panose="05000000000000000000" pitchFamily="2" charset="2"/>
-              </a:rPr>
-              <a:t>since</a:t>
-            </a:r>
-            <a:r>
-              <a:rPr lang="da-DK" dirty="0">
-                <a:sym typeface="Wingdings" panose="05000000000000000000" pitchFamily="2" charset="2"/>
-              </a:rPr>
-              <a:t> a </a:t>
-            </a:r>
-            <a:r>
-              <a:rPr lang="da-DK" dirty="0" err="1">
-                <a:sym typeface="Wingdings" panose="05000000000000000000" pitchFamily="2" charset="2"/>
-              </a:rPr>
-              <a:t>result</a:t>
-            </a:r>
-            <a:r>
-              <a:rPr lang="da-DK" dirty="0">
-                <a:sym typeface="Wingdings" panose="05000000000000000000" pitchFamily="2" charset="2"/>
-              </a:rPr>
-              <a:t> </a:t>
-            </a:r>
-            <a:r>
-              <a:rPr lang="da-DK" dirty="0" err="1">
-                <a:sym typeface="Wingdings" panose="05000000000000000000" pitchFamily="2" charset="2"/>
-              </a:rPr>
-              <a:t>document</a:t>
-            </a:r>
-            <a:r>
-              <a:rPr lang="da-DK" dirty="0">
-                <a:sym typeface="Wingdings" panose="05000000000000000000" pitchFamily="2" charset="2"/>
-              </a:rPr>
-              <a:t> </a:t>
-            </a:r>
-            <a:r>
-              <a:rPr lang="da-DK" dirty="0" err="1">
-                <a:sym typeface="Wingdings" panose="05000000000000000000" pitchFamily="2" charset="2"/>
-              </a:rPr>
-              <a:t>can</a:t>
-            </a:r>
-            <a:r>
-              <a:rPr lang="da-DK" dirty="0">
-                <a:sym typeface="Wingdings" panose="05000000000000000000" pitchFamily="2" charset="2"/>
-              </a:rPr>
-              <a:t> </a:t>
-            </a:r>
-            <a:r>
-              <a:rPr lang="da-DK" dirty="0" err="1">
-                <a:sym typeface="Wingdings" panose="05000000000000000000" pitchFamily="2" charset="2"/>
-              </a:rPr>
-              <a:t>also</a:t>
-            </a:r>
-            <a:r>
-              <a:rPr lang="da-DK" dirty="0">
-                <a:sym typeface="Wingdings" panose="05000000000000000000" pitchFamily="2" charset="2"/>
-              </a:rPr>
-              <a:t> </a:t>
-            </a:r>
-            <a:r>
-              <a:rPr lang="da-DK" dirty="0" err="1">
-                <a:sym typeface="Wingdings" panose="05000000000000000000" pitchFamily="2" charset="2"/>
-              </a:rPr>
-              <a:t>be</a:t>
-            </a:r>
-            <a:r>
-              <a:rPr lang="da-DK" dirty="0">
-                <a:sym typeface="Wingdings" panose="05000000000000000000" pitchFamily="2" charset="2"/>
-              </a:rPr>
-              <a:t> a citation </a:t>
-            </a:r>
-          </a:p>
-          <a:p>
-            <a:pPr marL="1200150" lvl="2" indent="-285750">
-              <a:buFont typeface="Wingdings" panose="05000000000000000000" pitchFamily="2" charset="2"/>
+              <a:rPr lang="en-US" sz="1600" dirty="0">
+                <a:sym typeface="Wingdings" pitchFamily="2" charset="2"/>
+              </a:rPr>
+              <a:t>Removed numbers</a:t>
+            </a:r>
+          </a:p>
+          <a:p>
+            <a:pPr marL="285750" indent="-285750">
+              <a:buFont typeface="Wingdings" pitchFamily="2" charset="2"/>
               <a:buChar char="à"/>
             </a:pPr>
             <a:r>
-              <a:rPr lang="da-DK" dirty="0">
-                <a:sym typeface="Wingdings" panose="05000000000000000000" pitchFamily="2" charset="2"/>
-              </a:rPr>
-              <a:t>In addition </a:t>
-            </a:r>
-            <a:r>
-              <a:rPr lang="da-DK" dirty="0" err="1">
-                <a:sym typeface="Wingdings" panose="05000000000000000000" pitchFamily="2" charset="2"/>
-              </a:rPr>
-              <a:t>now</a:t>
-            </a:r>
-            <a:r>
-              <a:rPr lang="da-DK" dirty="0">
-                <a:sym typeface="Wingdings" panose="05000000000000000000" pitchFamily="2" charset="2"/>
-              </a:rPr>
-              <a:t> </a:t>
-            </a:r>
-            <a:r>
-              <a:rPr lang="da-DK" dirty="0" err="1">
-                <a:sym typeface="Wingdings" panose="05000000000000000000" pitchFamily="2" charset="2"/>
-              </a:rPr>
-              <a:t>we</a:t>
-            </a:r>
-            <a:r>
-              <a:rPr lang="da-DK" dirty="0">
-                <a:sym typeface="Wingdings" panose="05000000000000000000" pitchFamily="2" charset="2"/>
-              </a:rPr>
-              <a:t> have </a:t>
-            </a:r>
-            <a:r>
-              <a:rPr lang="da-DK" dirty="0" err="1">
-                <a:sym typeface="Wingdings" panose="05000000000000000000" pitchFamily="2" charset="2"/>
-              </a:rPr>
-              <a:t>three</a:t>
-            </a:r>
-            <a:r>
-              <a:rPr lang="da-DK" dirty="0">
-                <a:sym typeface="Wingdings" panose="05000000000000000000" pitchFamily="2" charset="2"/>
-              </a:rPr>
-              <a:t> </a:t>
-            </a:r>
-            <a:r>
-              <a:rPr lang="da-DK" dirty="0" err="1">
-                <a:sym typeface="Wingdings" panose="05000000000000000000" pitchFamily="2" charset="2"/>
-              </a:rPr>
-              <a:t>levels</a:t>
-            </a:r>
-            <a:r>
-              <a:rPr lang="da-DK" dirty="0">
-                <a:sym typeface="Wingdings" panose="05000000000000000000" pitchFamily="2" charset="2"/>
-              </a:rPr>
-              <a:t>, </a:t>
-            </a:r>
-            <a:r>
-              <a:rPr lang="da-DK" dirty="0" err="1">
-                <a:sym typeface="Wingdings" panose="05000000000000000000" pitchFamily="2" charset="2"/>
-              </a:rPr>
-              <a:t>result</a:t>
-            </a:r>
-            <a:r>
-              <a:rPr lang="da-DK" dirty="0">
-                <a:sym typeface="Wingdings" panose="05000000000000000000" pitchFamily="2" charset="2"/>
-              </a:rPr>
-              <a:t> doc, 1st </a:t>
-            </a:r>
-            <a:r>
-              <a:rPr lang="da-DK" dirty="0" err="1">
-                <a:sym typeface="Wingdings" panose="05000000000000000000" pitchFamily="2" charset="2"/>
-              </a:rPr>
-              <a:t>order</a:t>
-            </a:r>
-            <a:r>
-              <a:rPr lang="da-DK" dirty="0">
-                <a:sym typeface="Wingdings" panose="05000000000000000000" pitchFamily="2" charset="2"/>
-              </a:rPr>
-              <a:t> citation and </a:t>
-            </a:r>
-            <a:r>
-              <a:rPr lang="da-DK" dirty="0" err="1">
-                <a:sym typeface="Wingdings" panose="05000000000000000000" pitchFamily="2" charset="2"/>
-              </a:rPr>
-              <a:t>second</a:t>
-            </a:r>
-            <a:r>
-              <a:rPr lang="da-DK" dirty="0">
-                <a:sym typeface="Wingdings" panose="05000000000000000000" pitchFamily="2" charset="2"/>
-              </a:rPr>
-              <a:t> </a:t>
-            </a:r>
-            <a:r>
-              <a:rPr lang="da-DK" dirty="0" err="1">
-                <a:sym typeface="Wingdings" panose="05000000000000000000" pitchFamily="2" charset="2"/>
-              </a:rPr>
-              <a:t>order</a:t>
-            </a:r>
-            <a:r>
-              <a:rPr lang="da-DK" dirty="0">
-                <a:sym typeface="Wingdings" panose="05000000000000000000" pitchFamily="2" charset="2"/>
-              </a:rPr>
-              <a:t> citation</a:t>
+              <a:rPr lang="en-US" sz="1600" dirty="0">
+                <a:sym typeface="Wingdings" pitchFamily="2" charset="2"/>
+              </a:rPr>
+              <a:t>Removed punctuation and special characters</a:t>
             </a:r>
           </a:p>
           <a:p>
             <a:pPr marL="285750" indent="-285750">
-              <a:buFont typeface="Wingdings" panose="05000000000000000000" pitchFamily="2" charset="2"/>
+              <a:buFont typeface="Wingdings" pitchFamily="2" charset="2"/>
               <a:buChar char="à"/>
             </a:pPr>
             <a:r>
-              <a:rPr lang="da-DK" dirty="0">
-                <a:sym typeface="Wingdings" panose="05000000000000000000" pitchFamily="2" charset="2"/>
-              </a:rPr>
-              <a:t>A </a:t>
-            </a:r>
-            <a:r>
-              <a:rPr lang="da-DK" dirty="0" err="1">
-                <a:sym typeface="Wingdings" panose="05000000000000000000" pitchFamily="2" charset="2"/>
-              </a:rPr>
-              <a:t>particular</a:t>
-            </a:r>
-            <a:r>
-              <a:rPr lang="da-DK" dirty="0">
-                <a:sym typeface="Wingdings" panose="05000000000000000000" pitchFamily="2" charset="2"/>
-              </a:rPr>
-              <a:t> </a:t>
-            </a:r>
-            <a:r>
-              <a:rPr lang="da-DK" dirty="0" err="1">
-                <a:sym typeface="Wingdings" panose="05000000000000000000" pitchFamily="2" charset="2"/>
-              </a:rPr>
-              <a:t>analysis</a:t>
-            </a:r>
-            <a:r>
-              <a:rPr lang="da-DK" dirty="0">
-                <a:sym typeface="Wingdings" panose="05000000000000000000" pitchFamily="2" charset="2"/>
-              </a:rPr>
-              <a:t> for the term </a:t>
-            </a:r>
-            <a:r>
-              <a:rPr lang="da-DK" dirty="0" err="1">
-                <a:sym typeface="Wingdings" panose="05000000000000000000" pitchFamily="2" charset="2"/>
-              </a:rPr>
-              <a:t>ococcurances</a:t>
-            </a:r>
-            <a:r>
-              <a:rPr lang="da-DK" dirty="0">
-                <a:sym typeface="Wingdings" panose="05000000000000000000" pitchFamily="2" charset="2"/>
-              </a:rPr>
-              <a:t> </a:t>
-            </a:r>
-            <a:r>
-              <a:rPr lang="da-DK" dirty="0" err="1">
-                <a:sym typeface="Wingdings" panose="05000000000000000000" pitchFamily="2" charset="2"/>
-              </a:rPr>
-              <a:t>network</a:t>
-            </a:r>
-            <a:r>
-              <a:rPr lang="da-DK" dirty="0">
-                <a:sym typeface="Wingdings" panose="05000000000000000000" pitchFamily="2" charset="2"/>
-              </a:rPr>
-              <a:t>?</a:t>
+              <a:rPr lang="en-US" sz="1600" dirty="0">
+                <a:sym typeface="Wingdings" pitchFamily="2" charset="2"/>
+              </a:rPr>
+              <a:t>Remove stop words</a:t>
             </a:r>
           </a:p>
           <a:p>
             <a:pPr marL="285750" indent="-285750">
-              <a:buFont typeface="Wingdings" panose="05000000000000000000" pitchFamily="2" charset="2"/>
+              <a:buFont typeface="Wingdings" pitchFamily="2" charset="2"/>
               <a:buChar char="à"/>
             </a:pPr>
-            <a:endParaRPr lang="da-DK" dirty="0">
-              <a:sym typeface="Wingdings" panose="05000000000000000000" pitchFamily="2" charset="2"/>
-            </a:endParaRPr>
-          </a:p>
-          <a:p>
-            <a:r>
-              <a:rPr lang="da-DK" b="1" dirty="0">
-                <a:sym typeface="Wingdings" panose="05000000000000000000" pitchFamily="2" charset="2"/>
-              </a:rPr>
-              <a:t>TEXT DATA:</a:t>
-            </a:r>
-          </a:p>
-          <a:p>
-            <a:r>
-              <a:rPr lang="da-DK" dirty="0">
-                <a:sym typeface="Wingdings" panose="05000000000000000000" pitchFamily="2" charset="2"/>
-              </a:rPr>
-              <a:t>??</a:t>
-            </a:r>
+            <a:r>
+              <a:rPr lang="en-US" sz="1600" dirty="0">
+                <a:sym typeface="Wingdings" pitchFamily="2" charset="2"/>
+              </a:rPr>
+              <a:t>Stemmed words</a:t>
+            </a:r>
+            <a:endParaRPr lang="en-US" sz="1600" dirty="0"/>
+          </a:p>
+          <a:p>
+            <a:endParaRPr lang="en-US" sz="1600" b="1" dirty="0"/>
+          </a:p>
+          <a:p>
+            <a:endParaRPr lang="en-US" sz="1600" b="1" dirty="0"/>
+          </a:p>
+          <a:p>
+            <a:endParaRPr lang="en-US" sz="1600" b="1" dirty="0"/>
+          </a:p>
+          <a:p>
+            <a:endParaRPr lang="en-US" sz="1600" b="1" dirty="0"/>
+          </a:p>
+          <a:p>
+            <a:endParaRPr lang="en-US" sz="1600" b="1" dirty="0"/>
+          </a:p>
+          <a:p>
+            <a:r>
+              <a:rPr lang="en-US" sz="1600" b="1" dirty="0"/>
+              <a:t>For possible sentiment analysis:</a:t>
+            </a:r>
+          </a:p>
+          <a:p>
+            <a:r>
+              <a:rPr lang="en-US" sz="1600" dirty="0">
+                <a:sym typeface="Wingdings" pitchFamily="2" charset="2"/>
+              </a:rPr>
+              <a:t> </a:t>
+            </a:r>
+            <a:r>
+              <a:rPr lang="en-US" sz="1600" dirty="0"/>
+              <a:t>converted all text to lowercase</a:t>
+            </a:r>
+          </a:p>
+          <a:p>
+            <a:pPr marL="285750" indent="-285750">
+              <a:buFont typeface="Wingdings" pitchFamily="2" charset="2"/>
+              <a:buChar char="à"/>
+            </a:pPr>
+            <a:r>
+              <a:rPr lang="en-US" sz="1600" dirty="0">
+                <a:sym typeface="Wingdings" pitchFamily="2" charset="2"/>
+              </a:rPr>
+              <a:t>Removed numbers and special characters </a:t>
+            </a:r>
+          </a:p>
+          <a:p>
+            <a:endParaRPr lang="en-US" b="1" dirty="0"/>
+          </a:p>
+        </p:txBody>
+      </p:sp>
+      <p:sp>
+        <p:nvSpPr>
+          <p:cNvPr id="3" name="TextBox 2">
+            <a:extLst>
+              <a:ext uri="{FF2B5EF4-FFF2-40B4-BE49-F238E27FC236}">
+                <a16:creationId xmlns:a16="http://schemas.microsoft.com/office/drawing/2014/main" id="{106304A0-57D4-2ED2-E90F-0280FCA7DFB5}"/>
+              </a:ext>
+            </a:extLst>
+          </p:cNvPr>
+          <p:cNvSpPr txBox="1"/>
+          <p:nvPr/>
+        </p:nvSpPr>
+        <p:spPr>
+          <a:xfrm>
+            <a:off x="4642290" y="2120948"/>
+            <a:ext cx="4200760" cy="2616101"/>
+          </a:xfrm>
+          <a:prstGeom prst="rect">
+            <a:avLst/>
+          </a:prstGeom>
+          <a:noFill/>
+        </p:spPr>
+        <p:txBody>
+          <a:bodyPr wrap="square" rtlCol="0">
+            <a:spAutoFit/>
+          </a:bodyPr>
+          <a:lstStyle/>
+          <a:p>
+            <a:r>
+              <a:rPr lang="en-US" sz="1600" b="1" dirty="0"/>
+              <a:t>EUR-Lex Corpus:</a:t>
+            </a:r>
+          </a:p>
+          <a:p>
+            <a:pPr marL="285750" indent="-285750">
+              <a:buFont typeface="Wingdings" pitchFamily="2" charset="2"/>
+              <a:buChar char="à"/>
+            </a:pPr>
+            <a:r>
+              <a:rPr lang="en-US" sz="1600" dirty="0">
+                <a:sym typeface="Wingdings" pitchFamily="2" charset="2"/>
+              </a:rPr>
+              <a:t>EUR-Lex result Documents</a:t>
+            </a:r>
+          </a:p>
+          <a:p>
+            <a:pPr marL="285750" indent="-285750">
+              <a:buFont typeface="Wingdings" pitchFamily="2" charset="2"/>
+              <a:buChar char="à"/>
+            </a:pPr>
+            <a:r>
+              <a:rPr lang="en-US" sz="1600" dirty="0">
+                <a:sym typeface="Wingdings" pitchFamily="2" charset="2"/>
+              </a:rPr>
+              <a:t>Meta data includes </a:t>
+            </a:r>
+          </a:p>
+          <a:p>
+            <a:pPr marL="742950" lvl="1" indent="-285750">
+              <a:buFont typeface="Wingdings" pitchFamily="2" charset="2"/>
+              <a:buChar char="à"/>
+            </a:pPr>
+            <a:r>
+              <a:rPr lang="en-US" sz="1600" dirty="0">
+                <a:sym typeface="Wingdings" pitchFamily="2" charset="2"/>
+              </a:rPr>
+              <a:t>year/date</a:t>
+            </a:r>
+          </a:p>
+          <a:p>
+            <a:pPr marL="742950" lvl="1" indent="-285750">
+              <a:buFont typeface="Wingdings" pitchFamily="2" charset="2"/>
+              <a:buChar char="à"/>
+            </a:pPr>
+            <a:r>
+              <a:rPr lang="en-US" sz="1600" dirty="0">
+                <a:sym typeface="Wingdings" pitchFamily="2" charset="2"/>
+              </a:rPr>
+              <a:t>enforced(True/False/NA)</a:t>
+            </a:r>
+          </a:p>
+          <a:p>
+            <a:pPr marL="742950" lvl="1" indent="-285750">
+              <a:buFont typeface="Wingdings" pitchFamily="2" charset="2"/>
+              <a:buChar char="à"/>
+            </a:pPr>
+            <a:r>
+              <a:rPr lang="en-US" sz="1600" dirty="0">
+                <a:sym typeface="Wingdings" pitchFamily="2" charset="2"/>
+              </a:rPr>
+              <a:t>Type of leg. (dir., rec., </a:t>
+            </a:r>
+            <a:r>
+              <a:rPr lang="en-US" sz="1600" dirty="0" err="1">
+                <a:sym typeface="Wingdings" pitchFamily="2" charset="2"/>
+              </a:rPr>
+              <a:t>opin</a:t>
+            </a:r>
+            <a:r>
+              <a:rPr lang="en-US" sz="1600" dirty="0">
+                <a:sym typeface="Wingdings" pitchFamily="2" charset="2"/>
+              </a:rPr>
+              <a:t>, </a:t>
+            </a:r>
+            <a:r>
+              <a:rPr lang="en-US" sz="1600" dirty="0" err="1">
+                <a:sym typeface="Wingdings" pitchFamily="2" charset="2"/>
+              </a:rPr>
+              <a:t>etc</a:t>
+            </a:r>
+            <a:r>
+              <a:rPr lang="en-US" sz="1600" dirty="0">
+                <a:sym typeface="Wingdings" pitchFamily="2" charset="2"/>
+              </a:rPr>
+              <a:t>…)</a:t>
+            </a:r>
+          </a:p>
+          <a:p>
+            <a:pPr marL="742950" lvl="1" indent="-285750">
+              <a:buFont typeface="Wingdings" pitchFamily="2" charset="2"/>
+              <a:buChar char="à"/>
+            </a:pPr>
+            <a:r>
+              <a:rPr lang="en-US" sz="1600" dirty="0">
+                <a:sym typeface="Wingdings" pitchFamily="2" charset="2"/>
+              </a:rPr>
+              <a:t> for the second query we also have the MPA design. Search term</a:t>
+            </a:r>
+            <a:endParaRPr lang="en-US" sz="1600" dirty="0"/>
+          </a:p>
+          <a:p>
+            <a:endParaRPr lang="en-US" dirty="0"/>
+          </a:p>
+          <a:p>
+            <a:endParaRPr lang="en-US" dirty="0"/>
+          </a:p>
+        </p:txBody>
+      </p:sp>
+      <p:sp>
+        <p:nvSpPr>
+          <p:cNvPr id="4" name="TextBox 3">
+            <a:extLst>
+              <a:ext uri="{FF2B5EF4-FFF2-40B4-BE49-F238E27FC236}">
+                <a16:creationId xmlns:a16="http://schemas.microsoft.com/office/drawing/2014/main" id="{6FC00BAA-F50E-7E36-279E-E61574CC87AB}"/>
+              </a:ext>
+            </a:extLst>
+          </p:cNvPr>
+          <p:cNvSpPr txBox="1"/>
+          <p:nvPr/>
+        </p:nvSpPr>
+        <p:spPr>
+          <a:xfrm>
+            <a:off x="9532131" y="2859613"/>
+            <a:ext cx="2708289" cy="1138773"/>
+          </a:xfrm>
+          <a:prstGeom prst="rect">
+            <a:avLst/>
+          </a:prstGeom>
+          <a:noFill/>
+        </p:spPr>
+        <p:txBody>
+          <a:bodyPr wrap="square" rtlCol="0">
+            <a:spAutoFit/>
+          </a:bodyPr>
+          <a:lstStyle/>
+          <a:p>
+            <a:r>
+              <a:rPr lang="en-US" sz="1600" b="1" dirty="0"/>
+              <a:t>Document-Term and </a:t>
+            </a:r>
+          </a:p>
+          <a:p>
+            <a:r>
+              <a:rPr lang="en-US" sz="1600" b="1" dirty="0"/>
+              <a:t>Term-Document matrices</a:t>
+            </a:r>
+            <a:endParaRPr lang="en-US" sz="1600" dirty="0"/>
+          </a:p>
+          <a:p>
+            <a:endParaRPr lang="en-US" dirty="0"/>
+          </a:p>
+          <a:p>
+            <a:endParaRPr lang="en-US" dirty="0"/>
+          </a:p>
+        </p:txBody>
+      </p:sp>
+      <p:sp>
+        <p:nvSpPr>
+          <p:cNvPr id="5" name="Right Brace 4">
+            <a:extLst>
+              <a:ext uri="{FF2B5EF4-FFF2-40B4-BE49-F238E27FC236}">
+                <a16:creationId xmlns:a16="http://schemas.microsoft.com/office/drawing/2014/main" id="{61427D44-474C-DF99-99AC-1BBC6432CF7F}"/>
+              </a:ext>
+            </a:extLst>
+          </p:cNvPr>
+          <p:cNvSpPr/>
+          <p:nvPr/>
+        </p:nvSpPr>
+        <p:spPr>
+          <a:xfrm>
+            <a:off x="3972910" y="1797269"/>
+            <a:ext cx="785648" cy="2822028"/>
+          </a:xfrm>
+          <a:prstGeom prst="rightBrace">
+            <a:avLst/>
+          </a:prstGeom>
+        </p:spPr>
+        <p:style>
+          <a:lnRef idx="1">
+            <a:schemeClr val="accent1"/>
+          </a:lnRef>
+          <a:fillRef idx="0">
+            <a:schemeClr val="accent1"/>
+          </a:fillRef>
+          <a:effectRef idx="0">
+            <a:schemeClr val="accent1"/>
+          </a:effectRef>
+          <a:fontRef idx="minor">
+            <a:schemeClr val="tx1"/>
+          </a:fontRef>
+        </p:style>
+        <p:txBody>
+          <a:bodyPr rtlCol="0" anchor="ctr"/>
+          <a:lstStyle/>
+          <a:p>
+            <a:pPr algn="ctr"/>
+            <a:endParaRPr lang="en-US"/>
+          </a:p>
+        </p:txBody>
+      </p:sp>
+      <p:sp>
+        <p:nvSpPr>
+          <p:cNvPr id="6" name="Right Brace 5">
+            <a:extLst>
+              <a:ext uri="{FF2B5EF4-FFF2-40B4-BE49-F238E27FC236}">
+                <a16:creationId xmlns:a16="http://schemas.microsoft.com/office/drawing/2014/main" id="{36009A26-0C4A-919E-5B3D-4329EA8572BD}"/>
+              </a:ext>
+            </a:extLst>
+          </p:cNvPr>
+          <p:cNvSpPr/>
+          <p:nvPr/>
+        </p:nvSpPr>
+        <p:spPr>
+          <a:xfrm>
+            <a:off x="8566494" y="1797269"/>
+            <a:ext cx="785648" cy="2822028"/>
+          </a:xfrm>
+          <a:prstGeom prst="rightBrace">
+            <a:avLst/>
+          </a:prstGeom>
+        </p:spPr>
+        <p:style>
+          <a:lnRef idx="1">
+            <a:schemeClr val="accent1"/>
+          </a:lnRef>
+          <a:fillRef idx="0">
+            <a:schemeClr val="accent1"/>
+          </a:fillRef>
+          <a:effectRef idx="0">
+            <a:schemeClr val="accent1"/>
+          </a:effectRef>
+          <a:fontRef idx="minor">
+            <a:schemeClr val="tx1"/>
+          </a:fontRef>
+        </p:style>
+        <p:txBody>
+          <a:bodyPr rtlCol="0" anchor="ctr"/>
+          <a:lstStyle/>
+          <a:p>
+            <a:pPr algn="ctr"/>
+            <a:endParaRPr lang="en-US"/>
           </a:p>
         </p:txBody>
       </p:sp>
     </p:spTree>
     <p:extLst>
       <p:ext uri="{BB962C8B-B14F-4D97-AF65-F5344CB8AC3E}">
-        <p14:creationId xmlns:p14="http://schemas.microsoft.com/office/powerpoint/2010/main" val="1461501907"/>
+        <p14:creationId xmlns:p14="http://schemas.microsoft.com/office/powerpoint/2010/main" val="2573923139"/>
       </p:ext>
     </p:extLst>
   </p:cSld>

</xml_diff>

<commit_message>
adding work flow chart to slides
</commit_message>
<xml_diff>
--- a/WP4/prelim.res.pptx
+++ b/WP4/prelim.res.pptx
@@ -15,6 +15,7 @@
     <p:sldId id="262" r:id="rId9"/>
     <p:sldId id="265" r:id="rId10"/>
     <p:sldId id="263" r:id="rId11"/>
+    <p:sldId id="266" r:id="rId12"/>
   </p:sldIdLst>
   <p:sldSz cx="12192000" cy="6858000"/>
   <p:notesSz cx="6858000" cy="9144000"/>
@@ -4615,6 +4616,2448 @@
 </p:sld>
 </file>
 
+<file path=ppt/slides/slide11.xml><?xml version="1.0" encoding="utf-8"?>
+<p:sld xmlns:a="http://schemas.openxmlformats.org/drawingml/2006/main" xmlns:r="http://schemas.openxmlformats.org/officeDocument/2006/relationships" xmlns:p="http://schemas.openxmlformats.org/presentationml/2006/main">
+  <p:cSld>
+    <p:spTree>
+      <p:nvGrpSpPr>
+        <p:cNvPr id="1" name=""/>
+        <p:cNvGrpSpPr/>
+        <p:nvPr/>
+      </p:nvGrpSpPr>
+      <p:grpSpPr>
+        <a:xfrm>
+          <a:off x="0" y="0"/>
+          <a:ext cx="0" cy="0"/>
+          <a:chOff x="0" y="0"/>
+          <a:chExt cx="0" cy="0"/>
+        </a:xfrm>
+      </p:grpSpPr>
+      <p:sp>
+        <p:nvSpPr>
+          <p:cNvPr id="103" name="Rectangle 102">
+            <a:extLst>
+              <a:ext uri="{FF2B5EF4-FFF2-40B4-BE49-F238E27FC236}">
+                <a16:creationId xmlns:a16="http://schemas.microsoft.com/office/drawing/2014/main" id="{BE57B42F-2AA8-F870-9491-3BD31AA45EE9}"/>
+              </a:ext>
+            </a:extLst>
+          </p:cNvPr>
+          <p:cNvSpPr/>
+          <p:nvPr/>
+        </p:nvSpPr>
+        <p:spPr>
+          <a:xfrm>
+            <a:off x="3849952" y="3027513"/>
+            <a:ext cx="4367002" cy="824304"/>
+          </a:xfrm>
+          <a:prstGeom prst="rect">
+            <a:avLst/>
+          </a:prstGeom>
+          <a:ln/>
+        </p:spPr>
+        <p:style>
+          <a:lnRef idx="2">
+            <a:schemeClr val="accent1"/>
+          </a:lnRef>
+          <a:fillRef idx="1">
+            <a:schemeClr val="lt1"/>
+          </a:fillRef>
+          <a:effectRef idx="0">
+            <a:schemeClr val="accent1"/>
+          </a:effectRef>
+          <a:fontRef idx="minor">
+            <a:schemeClr val="dk1"/>
+          </a:fontRef>
+        </p:style>
+        <p:txBody>
+          <a:bodyPr rtlCol="0" anchor="ctr"/>
+          <a:lstStyle/>
+          <a:p>
+            <a:pPr algn="ctr"/>
+            <a:r>
+              <a:rPr lang="da-DK" sz="1400" dirty="0">
+                <a:solidFill>
+                  <a:schemeClr val="tx1"/>
+                </a:solidFill>
+              </a:rPr>
+              <a:t>link </a:t>
+            </a:r>
+            <a:r>
+              <a:rPr lang="da-DK" sz="1400" dirty="0" err="1">
+                <a:solidFill>
+                  <a:schemeClr val="tx1"/>
+                </a:solidFill>
+              </a:rPr>
+              <a:t>associated</a:t>
+            </a:r>
+            <a:r>
+              <a:rPr lang="da-DK" sz="1400" dirty="0">
+                <a:solidFill>
+                  <a:schemeClr val="tx1"/>
+                </a:solidFill>
+              </a:rPr>
+              <a:t> </a:t>
+            </a:r>
+            <a:r>
+              <a:rPr lang="da-DK" sz="1400" dirty="0" err="1">
+                <a:solidFill>
+                  <a:schemeClr val="tx1"/>
+                </a:solidFill>
+              </a:rPr>
+              <a:t>document</a:t>
+            </a:r>
+            <a:r>
+              <a:rPr lang="da-DK" sz="1400" dirty="0">
+                <a:solidFill>
+                  <a:schemeClr val="tx1"/>
+                </a:solidFill>
+              </a:rPr>
+              <a:t> data</a:t>
+            </a:r>
+          </a:p>
+          <a:p>
+            <a:pPr algn="ctr"/>
+            <a:endParaRPr lang="da-DK" sz="1400" dirty="0"/>
+          </a:p>
+          <a:p>
+            <a:pPr algn="ctr"/>
+            <a:endParaRPr lang="da-DK" sz="1400" dirty="0"/>
+          </a:p>
+          <a:p>
+            <a:pPr algn="ctr"/>
+            <a:endParaRPr lang="da-DK" sz="1400" dirty="0"/>
+          </a:p>
+        </p:txBody>
+      </p:sp>
+      <p:sp>
+        <p:nvSpPr>
+          <p:cNvPr id="4" name="Rectangle 3">
+            <a:extLst>
+              <a:ext uri="{FF2B5EF4-FFF2-40B4-BE49-F238E27FC236}">
+                <a16:creationId xmlns:a16="http://schemas.microsoft.com/office/drawing/2014/main" id="{0A7DDDF4-A54E-5A7F-5900-89E3A9DC9AF1}"/>
+              </a:ext>
+            </a:extLst>
+          </p:cNvPr>
+          <p:cNvSpPr/>
+          <p:nvPr/>
+        </p:nvSpPr>
+        <p:spPr>
+          <a:xfrm>
+            <a:off x="4474408" y="94638"/>
+            <a:ext cx="3015855" cy="761227"/>
+          </a:xfrm>
+          <a:prstGeom prst="rect">
+            <a:avLst/>
+          </a:prstGeom>
+          <a:solidFill>
+            <a:schemeClr val="accent1">
+              <a:alpha val="50000"/>
+            </a:schemeClr>
+          </a:solidFill>
+          <a:ln>
+            <a:noFill/>
+          </a:ln>
+        </p:spPr>
+        <p:style>
+          <a:lnRef idx="0">
+            <a:scrgbClr r="0" g="0" b="0"/>
+          </a:lnRef>
+          <a:fillRef idx="0">
+            <a:scrgbClr r="0" g="0" b="0"/>
+          </a:fillRef>
+          <a:effectRef idx="0">
+            <a:scrgbClr r="0" g="0" b="0"/>
+          </a:effectRef>
+          <a:fontRef idx="minor">
+            <a:schemeClr val="lt1"/>
+          </a:fontRef>
+        </p:style>
+        <p:txBody>
+          <a:bodyPr rtlCol="0" anchor="ctr"/>
+          <a:lstStyle/>
+          <a:p>
+            <a:pPr algn="ctr"/>
+            <a:r>
+              <a:rPr lang="da-DK" sz="1400" dirty="0"/>
+              <a:t>EUR-Lex Database</a:t>
+            </a:r>
+          </a:p>
+          <a:p>
+            <a:pPr algn="ctr"/>
+            <a:r>
+              <a:rPr lang="da-DK" sz="1400" dirty="0" err="1"/>
+              <a:t>Extract</a:t>
+            </a:r>
+            <a:r>
+              <a:rPr lang="da-DK" sz="1400" dirty="0"/>
+              <a:t> EU </a:t>
+            </a:r>
+            <a:r>
+              <a:rPr lang="da-DK" sz="1400" dirty="0" err="1"/>
+              <a:t>legislation</a:t>
+            </a:r>
+            <a:r>
+              <a:rPr lang="da-DK" sz="1400" dirty="0"/>
+              <a:t> </a:t>
+            </a:r>
+            <a:r>
+              <a:rPr lang="da-DK" sz="1400" dirty="0" err="1"/>
+              <a:t>which</a:t>
+            </a:r>
+            <a:r>
+              <a:rPr lang="da-DK" sz="1400" dirty="0"/>
+              <a:t> </a:t>
+            </a:r>
+            <a:r>
+              <a:rPr lang="da-DK" sz="1400" dirty="0" err="1"/>
+              <a:t>mentions</a:t>
+            </a:r>
+            <a:r>
+              <a:rPr lang="da-DK" sz="1400" dirty="0"/>
+              <a:t>: </a:t>
+            </a:r>
+          </a:p>
+        </p:txBody>
+      </p:sp>
+      <p:sp>
+        <p:nvSpPr>
+          <p:cNvPr id="6" name="TextBox 5">
+            <a:extLst>
+              <a:ext uri="{FF2B5EF4-FFF2-40B4-BE49-F238E27FC236}">
+                <a16:creationId xmlns:a16="http://schemas.microsoft.com/office/drawing/2014/main" id="{F0AEBC7A-F189-D7F1-AB86-BBD0E403EDA6}"/>
+              </a:ext>
+            </a:extLst>
+          </p:cNvPr>
+          <p:cNvSpPr txBox="1"/>
+          <p:nvPr/>
+        </p:nvSpPr>
+        <p:spPr>
+          <a:xfrm>
+            <a:off x="6061184" y="1550631"/>
+            <a:ext cx="3517438" cy="923330"/>
+          </a:xfrm>
+          <a:prstGeom prst="rect">
+            <a:avLst/>
+          </a:prstGeom>
+          <a:noFill/>
+        </p:spPr>
+        <p:txBody>
+          <a:bodyPr wrap="square" rtlCol="0">
+            <a:spAutoFit/>
+          </a:bodyPr>
+          <a:lstStyle/>
+          <a:p>
+            <a:r>
+              <a:rPr lang="en-US" sz="1200" dirty="0"/>
+              <a:t>(2) A query for every official MPA designation title (i.e., world heritage site, Ramsar site, etc.) within the EU and the UK.</a:t>
+            </a:r>
+          </a:p>
+          <a:p>
+            <a:endParaRPr lang="da-DK" dirty="0"/>
+          </a:p>
+        </p:txBody>
+      </p:sp>
+      <p:sp>
+        <p:nvSpPr>
+          <p:cNvPr id="7" name="TextBox 6">
+            <a:extLst>
+              <a:ext uri="{FF2B5EF4-FFF2-40B4-BE49-F238E27FC236}">
+                <a16:creationId xmlns:a16="http://schemas.microsoft.com/office/drawing/2014/main" id="{1883D803-871E-635A-0271-AE22C442A14B}"/>
+              </a:ext>
+            </a:extLst>
+          </p:cNvPr>
+          <p:cNvSpPr txBox="1"/>
+          <p:nvPr/>
+        </p:nvSpPr>
+        <p:spPr>
+          <a:xfrm>
+            <a:off x="3572850" y="1537838"/>
+            <a:ext cx="1605311" cy="553998"/>
+          </a:xfrm>
+          <a:prstGeom prst="rect">
+            <a:avLst/>
+          </a:prstGeom>
+          <a:noFill/>
+        </p:spPr>
+        <p:txBody>
+          <a:bodyPr wrap="none" rtlCol="0">
+            <a:spAutoFit/>
+          </a:bodyPr>
+          <a:lstStyle/>
+          <a:p>
+            <a:r>
+              <a:rPr lang="en-US" sz="1200" dirty="0"/>
+              <a:t>(1) ”marine protected”</a:t>
+            </a:r>
+          </a:p>
+          <a:p>
+            <a:endParaRPr lang="da-DK" dirty="0"/>
+          </a:p>
+        </p:txBody>
+      </p:sp>
+      <p:cxnSp>
+        <p:nvCxnSpPr>
+          <p:cNvPr id="9" name="Straight Arrow Connector 8">
+            <a:extLst>
+              <a:ext uri="{FF2B5EF4-FFF2-40B4-BE49-F238E27FC236}">
+                <a16:creationId xmlns:a16="http://schemas.microsoft.com/office/drawing/2014/main" id="{433B5DCF-8F9F-4825-B866-148CB5E081F2}"/>
+              </a:ext>
+            </a:extLst>
+          </p:cNvPr>
+          <p:cNvCxnSpPr>
+            <a:cxnSpLocks/>
+          </p:cNvCxnSpPr>
+          <p:nvPr/>
+        </p:nvCxnSpPr>
+        <p:spPr>
+          <a:xfrm flipH="1">
+            <a:off x="4488196" y="845273"/>
+            <a:ext cx="503539" cy="658153"/>
+          </a:xfrm>
+          <a:prstGeom prst="straightConnector1">
+            <a:avLst/>
+          </a:prstGeom>
+          <a:ln w="12700" cap="flat" cmpd="sng" algn="ctr">
+            <a:solidFill>
+              <a:schemeClr val="accent1"/>
+            </a:solidFill>
+            <a:prstDash val="solid"/>
+            <a:round/>
+            <a:headEnd type="none" w="med" len="med"/>
+            <a:tailEnd type="arrow" w="med" len="med"/>
+          </a:ln>
+        </p:spPr>
+        <p:style>
+          <a:lnRef idx="0">
+            <a:scrgbClr r="0" g="0" b="0"/>
+          </a:lnRef>
+          <a:fillRef idx="0">
+            <a:scrgbClr r="0" g="0" b="0"/>
+          </a:fillRef>
+          <a:effectRef idx="0">
+            <a:scrgbClr r="0" g="0" b="0"/>
+          </a:effectRef>
+          <a:fontRef idx="minor">
+            <a:schemeClr val="tx1"/>
+          </a:fontRef>
+        </p:style>
+      </p:cxnSp>
+      <p:cxnSp>
+        <p:nvCxnSpPr>
+          <p:cNvPr id="11" name="Straight Arrow Connector 10">
+            <a:extLst>
+              <a:ext uri="{FF2B5EF4-FFF2-40B4-BE49-F238E27FC236}">
+                <a16:creationId xmlns:a16="http://schemas.microsoft.com/office/drawing/2014/main" id="{D0F6D07F-CCF1-8AA0-915F-8F5A6FCF99FD}"/>
+              </a:ext>
+            </a:extLst>
+          </p:cNvPr>
+          <p:cNvCxnSpPr/>
+          <p:nvPr/>
+        </p:nvCxnSpPr>
+        <p:spPr>
+          <a:xfrm>
+            <a:off x="6994317" y="900335"/>
+            <a:ext cx="495946" cy="615246"/>
+          </a:xfrm>
+          <a:prstGeom prst="straightConnector1">
+            <a:avLst/>
+          </a:prstGeom>
+          <a:ln w="12700" cap="flat" cmpd="sng" algn="ctr">
+            <a:solidFill>
+              <a:schemeClr val="accent1"/>
+            </a:solidFill>
+            <a:prstDash val="solid"/>
+            <a:round/>
+            <a:headEnd type="none" w="med" len="med"/>
+            <a:tailEnd type="arrow" w="med" len="med"/>
+          </a:ln>
+        </p:spPr>
+        <p:style>
+          <a:lnRef idx="0">
+            <a:scrgbClr r="0" g="0" b="0"/>
+          </a:lnRef>
+          <a:fillRef idx="0">
+            <a:scrgbClr r="0" g="0" b="0"/>
+          </a:fillRef>
+          <a:effectRef idx="0">
+            <a:scrgbClr r="0" g="0" b="0"/>
+          </a:effectRef>
+          <a:fontRef idx="minor">
+            <a:schemeClr val="tx1"/>
+          </a:fontRef>
+        </p:style>
+      </p:cxnSp>
+      <p:sp>
+        <p:nvSpPr>
+          <p:cNvPr id="12" name="TextBox 11">
+            <a:extLst>
+              <a:ext uri="{FF2B5EF4-FFF2-40B4-BE49-F238E27FC236}">
+                <a16:creationId xmlns:a16="http://schemas.microsoft.com/office/drawing/2014/main" id="{668FD0B1-2588-6288-41A4-880E2D643C58}"/>
+              </a:ext>
+            </a:extLst>
+          </p:cNvPr>
+          <p:cNvSpPr txBox="1"/>
+          <p:nvPr/>
+        </p:nvSpPr>
+        <p:spPr>
+          <a:xfrm>
+            <a:off x="3781254" y="2394144"/>
+            <a:ext cx="2487478" cy="276999"/>
+          </a:xfrm>
+          <a:prstGeom prst="rect">
+            <a:avLst/>
+          </a:prstGeom>
+          <a:noFill/>
+        </p:spPr>
+        <p:txBody>
+          <a:bodyPr wrap="square" rtlCol="0">
+            <a:spAutoFit/>
+          </a:bodyPr>
+          <a:lstStyle/>
+          <a:p>
+            <a:r>
+              <a:rPr lang="da-DK" sz="1200" dirty="0"/>
+              <a:t>24 legislative </a:t>
+            </a:r>
+            <a:r>
+              <a:rPr lang="da-DK" sz="1200" dirty="0" err="1"/>
+              <a:t>documents</a:t>
+            </a:r>
+            <a:endParaRPr lang="da-DK" sz="1200" dirty="0"/>
+          </a:p>
+        </p:txBody>
+      </p:sp>
+      <p:sp>
+        <p:nvSpPr>
+          <p:cNvPr id="13" name="TextBox 12">
+            <a:extLst>
+              <a:ext uri="{FF2B5EF4-FFF2-40B4-BE49-F238E27FC236}">
+                <a16:creationId xmlns:a16="http://schemas.microsoft.com/office/drawing/2014/main" id="{1B3A450B-B5C5-DA5F-A168-14CAEDFF9548}"/>
+              </a:ext>
+            </a:extLst>
+          </p:cNvPr>
+          <p:cNvSpPr txBox="1"/>
+          <p:nvPr/>
+        </p:nvSpPr>
+        <p:spPr>
+          <a:xfrm>
+            <a:off x="7026987" y="2410117"/>
+            <a:ext cx="3029919" cy="276999"/>
+          </a:xfrm>
+          <a:prstGeom prst="rect">
+            <a:avLst/>
+          </a:prstGeom>
+          <a:noFill/>
+        </p:spPr>
+        <p:txBody>
+          <a:bodyPr wrap="square" rtlCol="0">
+            <a:spAutoFit/>
+          </a:bodyPr>
+          <a:lstStyle/>
+          <a:p>
+            <a:r>
+              <a:rPr lang="da-DK" sz="1200" dirty="0"/>
+              <a:t>179 legislative </a:t>
+            </a:r>
+            <a:r>
+              <a:rPr lang="da-DK" sz="1200" dirty="0" err="1"/>
+              <a:t>documents</a:t>
+            </a:r>
+            <a:endParaRPr lang="da-DK" sz="1200" dirty="0"/>
+          </a:p>
+        </p:txBody>
+      </p:sp>
+      <p:cxnSp>
+        <p:nvCxnSpPr>
+          <p:cNvPr id="15" name="Straight Arrow Connector 14">
+            <a:extLst>
+              <a:ext uri="{FF2B5EF4-FFF2-40B4-BE49-F238E27FC236}">
+                <a16:creationId xmlns:a16="http://schemas.microsoft.com/office/drawing/2014/main" id="{5F8E9009-5BE1-D17E-6D60-8F5FA34947C6}"/>
+              </a:ext>
+            </a:extLst>
+          </p:cNvPr>
+          <p:cNvCxnSpPr>
+            <a:cxnSpLocks/>
+          </p:cNvCxnSpPr>
+          <p:nvPr/>
+        </p:nvCxnSpPr>
+        <p:spPr>
+          <a:xfrm>
+            <a:off x="4375505" y="1814837"/>
+            <a:ext cx="0" cy="595280"/>
+          </a:xfrm>
+          <a:prstGeom prst="straightConnector1">
+            <a:avLst/>
+          </a:prstGeom>
+          <a:ln w="12700" cap="flat" cmpd="sng" algn="ctr">
+            <a:solidFill>
+              <a:schemeClr val="accent1"/>
+            </a:solidFill>
+            <a:prstDash val="solid"/>
+            <a:round/>
+            <a:headEnd type="none" w="med" len="med"/>
+            <a:tailEnd type="arrow" w="med" len="med"/>
+          </a:ln>
+        </p:spPr>
+        <p:style>
+          <a:lnRef idx="0">
+            <a:scrgbClr r="0" g="0" b="0"/>
+          </a:lnRef>
+          <a:fillRef idx="0">
+            <a:scrgbClr r="0" g="0" b="0"/>
+          </a:fillRef>
+          <a:effectRef idx="0">
+            <a:scrgbClr r="0" g="0" b="0"/>
+          </a:effectRef>
+          <a:fontRef idx="minor">
+            <a:schemeClr val="tx1"/>
+          </a:fontRef>
+        </p:style>
+      </p:cxnSp>
+      <p:cxnSp>
+        <p:nvCxnSpPr>
+          <p:cNvPr id="17" name="Straight Arrow Connector 16">
+            <a:extLst>
+              <a:ext uri="{FF2B5EF4-FFF2-40B4-BE49-F238E27FC236}">
+                <a16:creationId xmlns:a16="http://schemas.microsoft.com/office/drawing/2014/main" id="{1AAD43DA-1E6E-F6CD-F77E-F21EC0A390C7}"/>
+              </a:ext>
+            </a:extLst>
+          </p:cNvPr>
+          <p:cNvCxnSpPr>
+            <a:cxnSpLocks/>
+          </p:cNvCxnSpPr>
+          <p:nvPr/>
+        </p:nvCxnSpPr>
+        <p:spPr>
+          <a:xfrm>
+            <a:off x="7848335" y="2012000"/>
+            <a:ext cx="0" cy="360336"/>
+          </a:xfrm>
+          <a:prstGeom prst="straightConnector1">
+            <a:avLst/>
+          </a:prstGeom>
+          <a:ln w="12700" cap="flat" cmpd="sng" algn="ctr">
+            <a:solidFill>
+              <a:schemeClr val="accent1"/>
+            </a:solidFill>
+            <a:prstDash val="solid"/>
+            <a:round/>
+            <a:headEnd type="none" w="med" len="med"/>
+            <a:tailEnd type="arrow" w="med" len="med"/>
+          </a:ln>
+        </p:spPr>
+        <p:style>
+          <a:lnRef idx="0">
+            <a:scrgbClr r="0" g="0" b="0"/>
+          </a:lnRef>
+          <a:fillRef idx="0">
+            <a:scrgbClr r="0" g="0" b="0"/>
+          </a:fillRef>
+          <a:effectRef idx="0">
+            <a:scrgbClr r="0" g="0" b="0"/>
+          </a:effectRef>
+          <a:fontRef idx="minor">
+            <a:schemeClr val="tx1"/>
+          </a:fontRef>
+        </p:style>
+      </p:cxnSp>
+      <p:pic>
+        <p:nvPicPr>
+          <p:cNvPr id="20" name="Graphic 19" descr="Network outline">
+            <a:extLst>
+              <a:ext uri="{FF2B5EF4-FFF2-40B4-BE49-F238E27FC236}">
+                <a16:creationId xmlns:a16="http://schemas.microsoft.com/office/drawing/2014/main" id="{5963E2ED-20B0-066E-25EF-D003BF15CECD}"/>
+              </a:ext>
+            </a:extLst>
+          </p:cNvPr>
+          <p:cNvPicPr>
+            <a:picLocks noChangeAspect="1"/>
+          </p:cNvPicPr>
+          <p:nvPr/>
+        </p:nvPicPr>
+        <p:blipFill>
+          <a:blip r:embed="rId2">
+            <a:extLst>
+              <a:ext uri="{28A0092B-C50C-407E-A947-70E740481C1C}">
+                <a14:useLocalDpi xmlns:a14="http://schemas.microsoft.com/office/drawing/2010/main" val="0"/>
+              </a:ext>
+              <a:ext uri="{96DAC541-7B7A-43D3-8B79-37D633B846F1}">
+                <asvg:svgBlip xmlns:asvg="http://schemas.microsoft.com/office/drawing/2016/SVG/main" r:embed="rId3"/>
+              </a:ext>
+            </a:extLst>
+          </a:blip>
+          <a:stretch>
+            <a:fillRect/>
+          </a:stretch>
+        </p:blipFill>
+        <p:spPr>
+          <a:xfrm>
+            <a:off x="4091727" y="5115543"/>
+            <a:ext cx="758746" cy="758746"/>
+          </a:xfrm>
+          <a:prstGeom prst="rect">
+            <a:avLst/>
+          </a:prstGeom>
+        </p:spPr>
+      </p:pic>
+      <p:pic>
+        <p:nvPicPr>
+          <p:cNvPr id="21" name="Graphic 20" descr="Network outline">
+            <a:extLst>
+              <a:ext uri="{FF2B5EF4-FFF2-40B4-BE49-F238E27FC236}">
+                <a16:creationId xmlns:a16="http://schemas.microsoft.com/office/drawing/2014/main" id="{E818E953-21FE-8075-9BB6-1E685AF44356}"/>
+              </a:ext>
+            </a:extLst>
+          </p:cNvPr>
+          <p:cNvPicPr>
+            <a:picLocks noChangeAspect="1"/>
+          </p:cNvPicPr>
+          <p:nvPr/>
+        </p:nvPicPr>
+        <p:blipFill>
+          <a:blip r:embed="rId2">
+            <a:extLst>
+              <a:ext uri="{28A0092B-C50C-407E-A947-70E740481C1C}">
+                <a14:useLocalDpi xmlns:a14="http://schemas.microsoft.com/office/drawing/2010/main" val="0"/>
+              </a:ext>
+              <a:ext uri="{96DAC541-7B7A-43D3-8B79-37D633B846F1}">
+                <asvg:svgBlip xmlns:asvg="http://schemas.microsoft.com/office/drawing/2016/SVG/main" r:embed="rId3"/>
+              </a:ext>
+            </a:extLst>
+          </a:blip>
+          <a:stretch>
+            <a:fillRect/>
+          </a:stretch>
+        </p:blipFill>
+        <p:spPr>
+          <a:xfrm rot="20387264">
+            <a:off x="4568106" y="5038841"/>
+            <a:ext cx="758746" cy="758746"/>
+          </a:xfrm>
+          <a:prstGeom prst="rect">
+            <a:avLst/>
+          </a:prstGeom>
+        </p:spPr>
+      </p:pic>
+      <p:pic>
+        <p:nvPicPr>
+          <p:cNvPr id="22" name="Graphic 21" descr="Network outline">
+            <a:extLst>
+              <a:ext uri="{FF2B5EF4-FFF2-40B4-BE49-F238E27FC236}">
+                <a16:creationId xmlns:a16="http://schemas.microsoft.com/office/drawing/2014/main" id="{38DC20BC-1239-9ACB-48E3-110C917AD314}"/>
+              </a:ext>
+            </a:extLst>
+          </p:cNvPr>
+          <p:cNvPicPr>
+            <a:picLocks noChangeAspect="1"/>
+          </p:cNvPicPr>
+          <p:nvPr/>
+        </p:nvPicPr>
+        <p:blipFill>
+          <a:blip r:embed="rId2">
+            <a:extLst>
+              <a:ext uri="{28A0092B-C50C-407E-A947-70E740481C1C}">
+                <a14:useLocalDpi xmlns:a14="http://schemas.microsoft.com/office/drawing/2010/main" val="0"/>
+              </a:ext>
+              <a:ext uri="{96DAC541-7B7A-43D3-8B79-37D633B846F1}">
+                <asvg:svgBlip xmlns:asvg="http://schemas.microsoft.com/office/drawing/2016/SVG/main" r:embed="rId3"/>
+              </a:ext>
+            </a:extLst>
+          </a:blip>
+          <a:stretch>
+            <a:fillRect/>
+          </a:stretch>
+        </p:blipFill>
+        <p:spPr>
+          <a:xfrm rot="19762809">
+            <a:off x="4581465" y="5500602"/>
+            <a:ext cx="758746" cy="758746"/>
+          </a:xfrm>
+          <a:prstGeom prst="rect">
+            <a:avLst/>
+          </a:prstGeom>
+        </p:spPr>
+      </p:pic>
+      <p:pic>
+        <p:nvPicPr>
+          <p:cNvPr id="23" name="Graphic 22" descr="Network outline">
+            <a:extLst>
+              <a:ext uri="{FF2B5EF4-FFF2-40B4-BE49-F238E27FC236}">
+                <a16:creationId xmlns:a16="http://schemas.microsoft.com/office/drawing/2014/main" id="{D0A86861-D495-DB17-7D84-8B35E5964810}"/>
+              </a:ext>
+            </a:extLst>
+          </p:cNvPr>
+          <p:cNvPicPr>
+            <a:picLocks noChangeAspect="1"/>
+          </p:cNvPicPr>
+          <p:nvPr/>
+        </p:nvPicPr>
+        <p:blipFill>
+          <a:blip r:embed="rId2">
+            <a:extLst>
+              <a:ext uri="{28A0092B-C50C-407E-A947-70E740481C1C}">
+                <a14:useLocalDpi xmlns:a14="http://schemas.microsoft.com/office/drawing/2010/main" val="0"/>
+              </a:ext>
+              <a:ext uri="{96DAC541-7B7A-43D3-8B79-37D633B846F1}">
+                <asvg:svgBlip xmlns:asvg="http://schemas.microsoft.com/office/drawing/2016/SVG/main" r:embed="rId3"/>
+              </a:ext>
+            </a:extLst>
+          </a:blip>
+          <a:stretch>
+            <a:fillRect/>
+          </a:stretch>
+        </p:blipFill>
+        <p:spPr>
+          <a:xfrm rot="19934484">
+            <a:off x="3736184" y="5493303"/>
+            <a:ext cx="758746" cy="758746"/>
+          </a:xfrm>
+          <a:prstGeom prst="rect">
+            <a:avLst/>
+          </a:prstGeom>
+        </p:spPr>
+      </p:pic>
+      <p:sp>
+        <p:nvSpPr>
+          <p:cNvPr id="34" name="TextBox 33">
+            <a:extLst>
+              <a:ext uri="{FF2B5EF4-FFF2-40B4-BE49-F238E27FC236}">
+                <a16:creationId xmlns:a16="http://schemas.microsoft.com/office/drawing/2014/main" id="{66383C48-3A42-034B-37F1-1035DD34A8B0}"/>
+              </a:ext>
+            </a:extLst>
+          </p:cNvPr>
+          <p:cNvSpPr txBox="1"/>
+          <p:nvPr/>
+        </p:nvSpPr>
+        <p:spPr>
+          <a:xfrm>
+            <a:off x="3849952" y="3305784"/>
+            <a:ext cx="2686334" cy="276999"/>
+          </a:xfrm>
+          <a:prstGeom prst="rect">
+            <a:avLst/>
+          </a:prstGeom>
+          <a:noFill/>
+        </p:spPr>
+        <p:txBody>
+          <a:bodyPr wrap="square" rtlCol="0">
+            <a:spAutoFit/>
+          </a:bodyPr>
+          <a:lstStyle/>
+          <a:p>
+            <a:r>
+              <a:rPr lang="da-DK" sz="1200" dirty="0"/>
+              <a:t>(1) </a:t>
+            </a:r>
+            <a:r>
+              <a:rPr lang="da-DK" sz="1200" dirty="0" err="1"/>
+              <a:t>Extract</a:t>
+            </a:r>
+            <a:r>
+              <a:rPr lang="da-DK" sz="1200" dirty="0"/>
+              <a:t> </a:t>
+            </a:r>
+            <a:r>
+              <a:rPr lang="da-DK" sz="1200" dirty="0" err="1"/>
+              <a:t>document</a:t>
+            </a:r>
+            <a:r>
+              <a:rPr lang="da-DK" sz="1200" dirty="0"/>
+              <a:t> citations</a:t>
+            </a:r>
+          </a:p>
+        </p:txBody>
+      </p:sp>
+      <p:sp>
+        <p:nvSpPr>
+          <p:cNvPr id="38" name="TextBox 37">
+            <a:extLst>
+              <a:ext uri="{FF2B5EF4-FFF2-40B4-BE49-F238E27FC236}">
+                <a16:creationId xmlns:a16="http://schemas.microsoft.com/office/drawing/2014/main" id="{D2FF6B7E-1969-6D0E-135B-FB7AFD71521B}"/>
+              </a:ext>
+            </a:extLst>
+          </p:cNvPr>
+          <p:cNvSpPr txBox="1"/>
+          <p:nvPr/>
+        </p:nvSpPr>
+        <p:spPr>
+          <a:xfrm>
+            <a:off x="6045075" y="3306932"/>
+            <a:ext cx="2552645" cy="461665"/>
+          </a:xfrm>
+          <a:prstGeom prst="rect">
+            <a:avLst/>
+          </a:prstGeom>
+          <a:noFill/>
+        </p:spPr>
+        <p:txBody>
+          <a:bodyPr wrap="square" rtlCol="0">
+            <a:spAutoFit/>
+          </a:bodyPr>
+          <a:lstStyle/>
+          <a:p>
+            <a:r>
+              <a:rPr lang="da-DK" sz="1200" dirty="0"/>
+              <a:t>(2) </a:t>
+            </a:r>
+            <a:r>
+              <a:rPr lang="da-DK" sz="1200" dirty="0" err="1"/>
+              <a:t>Attach</a:t>
+            </a:r>
+            <a:r>
+              <a:rPr lang="da-DK" sz="1200" dirty="0"/>
+              <a:t> </a:t>
+            </a:r>
+            <a:r>
+              <a:rPr lang="da-DK" sz="1200" dirty="0" err="1"/>
+              <a:t>documents</a:t>
+            </a:r>
+            <a:r>
+              <a:rPr lang="da-DK" sz="1200" dirty="0"/>
+              <a:t> to </a:t>
+            </a:r>
+            <a:r>
+              <a:rPr lang="da-DK" sz="1200" dirty="0" err="1"/>
+              <a:t>their</a:t>
+            </a:r>
+            <a:r>
+              <a:rPr lang="da-DK" sz="1200" dirty="0"/>
+              <a:t> </a:t>
+            </a:r>
+            <a:r>
+              <a:rPr lang="da-DK" sz="1200" dirty="0" err="1"/>
+              <a:t>assigned</a:t>
+            </a:r>
+            <a:r>
+              <a:rPr lang="da-DK" sz="1200" dirty="0"/>
+              <a:t> EU labels and </a:t>
+            </a:r>
+            <a:r>
+              <a:rPr lang="da-DK" sz="1200" dirty="0" err="1"/>
+              <a:t>themes</a:t>
+            </a:r>
+            <a:r>
+              <a:rPr lang="da-DK" sz="1200" dirty="0"/>
+              <a:t>.</a:t>
+            </a:r>
+          </a:p>
+        </p:txBody>
+      </p:sp>
+      <p:sp>
+        <p:nvSpPr>
+          <p:cNvPr id="50" name="Oval 49">
+            <a:extLst>
+              <a:ext uri="{FF2B5EF4-FFF2-40B4-BE49-F238E27FC236}">
+                <a16:creationId xmlns:a16="http://schemas.microsoft.com/office/drawing/2014/main" id="{BCCC681D-4C4E-4743-9009-74C3290129FA}"/>
+              </a:ext>
+            </a:extLst>
+          </p:cNvPr>
+          <p:cNvSpPr/>
+          <p:nvPr/>
+        </p:nvSpPr>
+        <p:spPr>
+          <a:xfrm>
+            <a:off x="5218812" y="5892035"/>
+            <a:ext cx="1631245" cy="391130"/>
+          </a:xfrm>
+          <a:prstGeom prst="ellipse">
+            <a:avLst/>
+          </a:prstGeom>
+          <a:noFill/>
+          <a:ln>
+            <a:noFill/>
+          </a:ln>
+        </p:spPr>
+        <p:style>
+          <a:lnRef idx="0">
+            <a:scrgbClr r="0" g="0" b="0"/>
+          </a:lnRef>
+          <a:fillRef idx="0">
+            <a:scrgbClr r="0" g="0" b="0"/>
+          </a:fillRef>
+          <a:effectRef idx="0">
+            <a:scrgbClr r="0" g="0" b="0"/>
+          </a:effectRef>
+          <a:fontRef idx="minor">
+            <a:schemeClr val="dk1"/>
+          </a:fontRef>
+        </p:style>
+        <p:txBody>
+          <a:bodyPr rtlCol="0" anchor="ctr"/>
+          <a:lstStyle/>
+          <a:p>
+            <a:pPr algn="ctr"/>
+            <a:r>
+              <a:rPr lang="da-DK" sz="900" b="1" dirty="0" err="1">
+                <a:solidFill>
+                  <a:schemeClr val="tx1"/>
+                </a:solidFill>
+              </a:rPr>
+              <a:t>plasic</a:t>
+            </a:r>
+            <a:endParaRPr lang="da-DK" sz="900" b="1" dirty="0">
+              <a:solidFill>
+                <a:schemeClr val="tx1"/>
+              </a:solidFill>
+            </a:endParaRPr>
+          </a:p>
+        </p:txBody>
+      </p:sp>
+      <p:grpSp>
+        <p:nvGrpSpPr>
+          <p:cNvPr id="101" name="Group 100">
+            <a:extLst>
+              <a:ext uri="{FF2B5EF4-FFF2-40B4-BE49-F238E27FC236}">
+                <a16:creationId xmlns:a16="http://schemas.microsoft.com/office/drawing/2014/main" id="{AB81F1DE-5134-FD19-541D-ACFB02548FEA}"/>
+              </a:ext>
+            </a:extLst>
+          </p:cNvPr>
+          <p:cNvGrpSpPr/>
+          <p:nvPr/>
+        </p:nvGrpSpPr>
+        <p:grpSpPr>
+          <a:xfrm rot="693841">
+            <a:off x="5858291" y="4866521"/>
+            <a:ext cx="3030101" cy="1968416"/>
+            <a:chOff x="7837310" y="4395277"/>
+            <a:chExt cx="3594651" cy="2410457"/>
+          </a:xfrm>
+        </p:grpSpPr>
+        <p:sp>
+          <p:nvSpPr>
+            <p:cNvPr id="43" name="Oval 42">
+              <a:extLst>
+                <a:ext uri="{FF2B5EF4-FFF2-40B4-BE49-F238E27FC236}">
+                  <a16:creationId xmlns:a16="http://schemas.microsoft.com/office/drawing/2014/main" id="{C9C3B61E-533A-0762-9568-1DCA0FC5478E}"/>
+                </a:ext>
+              </a:extLst>
+            </p:cNvPr>
+            <p:cNvSpPr/>
+            <p:nvPr/>
+          </p:nvSpPr>
+          <p:spPr>
+            <a:xfrm>
+              <a:off x="7947377" y="5499217"/>
+              <a:ext cx="1478845" cy="391130"/>
+            </a:xfrm>
+            <a:prstGeom prst="ellipse">
+              <a:avLst/>
+            </a:prstGeom>
+            <a:noFill/>
+            <a:ln>
+              <a:noFill/>
+            </a:ln>
+          </p:spPr>
+          <p:style>
+            <a:lnRef idx="0">
+              <a:scrgbClr r="0" g="0" b="0"/>
+            </a:lnRef>
+            <a:fillRef idx="0">
+              <a:scrgbClr r="0" g="0" b="0"/>
+            </a:fillRef>
+            <a:effectRef idx="0">
+              <a:scrgbClr r="0" g="0" b="0"/>
+            </a:effectRef>
+            <a:fontRef idx="minor">
+              <a:schemeClr val="dk1"/>
+            </a:fontRef>
+          </p:style>
+          <p:txBody>
+            <a:bodyPr rtlCol="0" anchor="ctr"/>
+            <a:lstStyle/>
+            <a:p>
+              <a:pPr algn="ctr"/>
+              <a:r>
+                <a:rPr lang="da-DK" sz="900" b="1" dirty="0" err="1">
+                  <a:solidFill>
+                    <a:schemeClr val="tx1"/>
+                  </a:solidFill>
+                </a:rPr>
+                <a:t>sustainable</a:t>
+              </a:r>
+              <a:r>
+                <a:rPr lang="da-DK" sz="900" b="1" dirty="0">
+                  <a:solidFill>
+                    <a:schemeClr val="tx1"/>
+                  </a:solidFill>
+                </a:rPr>
+                <a:t> </a:t>
+              </a:r>
+              <a:r>
+                <a:rPr lang="da-DK" sz="900" b="1" dirty="0" err="1">
+                  <a:solidFill>
+                    <a:schemeClr val="tx1"/>
+                  </a:solidFill>
+                </a:rPr>
+                <a:t>development</a:t>
+              </a:r>
+              <a:endParaRPr lang="da-DK" sz="900" b="1" dirty="0">
+                <a:solidFill>
+                  <a:schemeClr val="tx1"/>
+                </a:solidFill>
+              </a:endParaRPr>
+            </a:p>
+          </p:txBody>
+        </p:sp>
+        <p:sp>
+          <p:nvSpPr>
+            <p:cNvPr id="44" name="Oval 43">
+              <a:extLst>
+                <a:ext uri="{FF2B5EF4-FFF2-40B4-BE49-F238E27FC236}">
+                  <a16:creationId xmlns:a16="http://schemas.microsoft.com/office/drawing/2014/main" id="{0FF5FDCD-0B60-918B-2F18-740B41BA83F0}"/>
+                </a:ext>
+              </a:extLst>
+            </p:cNvPr>
+            <p:cNvSpPr/>
+            <p:nvPr/>
+          </p:nvSpPr>
+          <p:spPr>
+            <a:xfrm>
+              <a:off x="8042528" y="4794080"/>
+              <a:ext cx="1478845" cy="391130"/>
+            </a:xfrm>
+            <a:prstGeom prst="ellipse">
+              <a:avLst/>
+            </a:prstGeom>
+            <a:noFill/>
+            <a:ln>
+              <a:noFill/>
+            </a:ln>
+          </p:spPr>
+          <p:style>
+            <a:lnRef idx="0">
+              <a:scrgbClr r="0" g="0" b="0"/>
+            </a:lnRef>
+            <a:fillRef idx="0">
+              <a:scrgbClr r="0" g="0" b="0"/>
+            </a:fillRef>
+            <a:effectRef idx="0">
+              <a:scrgbClr r="0" g="0" b="0"/>
+            </a:effectRef>
+            <a:fontRef idx="minor">
+              <a:schemeClr val="dk1"/>
+            </a:fontRef>
+          </p:style>
+          <p:txBody>
+            <a:bodyPr rtlCol="0" anchor="ctr"/>
+            <a:lstStyle/>
+            <a:p>
+              <a:pPr algn="ctr"/>
+              <a:r>
+                <a:rPr lang="da-DK" sz="900" b="1" dirty="0" err="1">
+                  <a:solidFill>
+                    <a:schemeClr val="tx1"/>
+                  </a:solidFill>
+                </a:rPr>
+                <a:t>catch</a:t>
+              </a:r>
+              <a:r>
+                <a:rPr lang="da-DK" sz="900" b="1" dirty="0">
+                  <a:solidFill>
+                    <a:schemeClr val="tx1"/>
+                  </a:solidFill>
+                </a:rPr>
+                <a:t> </a:t>
+              </a:r>
+              <a:r>
+                <a:rPr lang="da-DK" sz="900" b="1" dirty="0" err="1">
+                  <a:solidFill>
+                    <a:schemeClr val="tx1"/>
+                  </a:solidFill>
+                </a:rPr>
+                <a:t>quota</a:t>
+              </a:r>
+              <a:endParaRPr lang="da-DK" sz="900" b="1" dirty="0">
+                <a:solidFill>
+                  <a:schemeClr val="tx1"/>
+                </a:solidFill>
+              </a:endParaRPr>
+            </a:p>
+          </p:txBody>
+        </p:sp>
+        <p:sp>
+          <p:nvSpPr>
+            <p:cNvPr id="47" name="Oval 46">
+              <a:extLst>
+                <a:ext uri="{FF2B5EF4-FFF2-40B4-BE49-F238E27FC236}">
+                  <a16:creationId xmlns:a16="http://schemas.microsoft.com/office/drawing/2014/main" id="{9AEBBAC2-934C-6DFE-1EA9-4C1210EDC5C1}"/>
+                </a:ext>
+              </a:extLst>
+            </p:cNvPr>
+            <p:cNvSpPr/>
+            <p:nvPr/>
+          </p:nvSpPr>
+          <p:spPr>
+            <a:xfrm>
+              <a:off x="9087555" y="5873496"/>
+              <a:ext cx="1478845" cy="391130"/>
+            </a:xfrm>
+            <a:prstGeom prst="ellipse">
+              <a:avLst/>
+            </a:prstGeom>
+            <a:noFill/>
+            <a:ln>
+              <a:noFill/>
+            </a:ln>
+          </p:spPr>
+          <p:style>
+            <a:lnRef idx="0">
+              <a:scrgbClr r="0" g="0" b="0"/>
+            </a:lnRef>
+            <a:fillRef idx="0">
+              <a:scrgbClr r="0" g="0" b="0"/>
+            </a:fillRef>
+            <a:effectRef idx="0">
+              <a:scrgbClr r="0" g="0" b="0"/>
+            </a:effectRef>
+            <a:fontRef idx="minor">
+              <a:schemeClr val="dk1"/>
+            </a:fontRef>
+          </p:style>
+          <p:txBody>
+            <a:bodyPr rtlCol="0" anchor="ctr"/>
+            <a:lstStyle/>
+            <a:p>
+              <a:pPr algn="ctr"/>
+              <a:r>
+                <a:rPr lang="da-DK" sz="900" b="1" dirty="0" err="1">
+                  <a:solidFill>
+                    <a:schemeClr val="tx1"/>
+                  </a:solidFill>
+                </a:rPr>
+                <a:t>oil</a:t>
+              </a:r>
+              <a:r>
+                <a:rPr lang="da-DK" sz="900" b="1" dirty="0">
+                  <a:solidFill>
+                    <a:schemeClr val="tx1"/>
+                  </a:solidFill>
+                </a:rPr>
+                <a:t> </a:t>
+              </a:r>
+              <a:r>
+                <a:rPr lang="da-DK" sz="900" b="1" dirty="0" err="1">
+                  <a:solidFill>
+                    <a:schemeClr val="tx1"/>
+                  </a:solidFill>
+                </a:rPr>
+                <a:t>spills</a:t>
+              </a:r>
+              <a:endParaRPr lang="da-DK" sz="900" b="1" dirty="0">
+                <a:solidFill>
+                  <a:schemeClr val="tx1"/>
+                </a:solidFill>
+              </a:endParaRPr>
+            </a:p>
+          </p:txBody>
+        </p:sp>
+        <p:sp>
+          <p:nvSpPr>
+            <p:cNvPr id="51" name="Oval 50">
+              <a:extLst>
+                <a:ext uri="{FF2B5EF4-FFF2-40B4-BE49-F238E27FC236}">
+                  <a16:creationId xmlns:a16="http://schemas.microsoft.com/office/drawing/2014/main" id="{EA4397AB-CFE2-8573-E149-CA76CE73ED2F}"/>
+                </a:ext>
+              </a:extLst>
+            </p:cNvPr>
+            <p:cNvSpPr/>
+            <p:nvPr/>
+          </p:nvSpPr>
+          <p:spPr>
+            <a:xfrm>
+              <a:off x="8523109" y="6090874"/>
+              <a:ext cx="1478845" cy="391130"/>
+            </a:xfrm>
+            <a:prstGeom prst="ellipse">
+              <a:avLst/>
+            </a:prstGeom>
+            <a:noFill/>
+            <a:ln>
+              <a:noFill/>
+            </a:ln>
+          </p:spPr>
+          <p:style>
+            <a:lnRef idx="0">
+              <a:scrgbClr r="0" g="0" b="0"/>
+            </a:lnRef>
+            <a:fillRef idx="0">
+              <a:scrgbClr r="0" g="0" b="0"/>
+            </a:fillRef>
+            <a:effectRef idx="0">
+              <a:scrgbClr r="0" g="0" b="0"/>
+            </a:effectRef>
+            <a:fontRef idx="minor">
+              <a:schemeClr val="dk1"/>
+            </a:fontRef>
+          </p:style>
+          <p:txBody>
+            <a:bodyPr rtlCol="0" anchor="ctr"/>
+            <a:lstStyle/>
+            <a:p>
+              <a:pPr algn="ctr"/>
+              <a:r>
+                <a:rPr lang="da-DK" sz="900" b="1" dirty="0">
+                  <a:solidFill>
+                    <a:schemeClr val="tx1"/>
+                  </a:solidFill>
+                </a:rPr>
+                <a:t>gas</a:t>
+              </a:r>
+            </a:p>
+          </p:txBody>
+        </p:sp>
+        <p:sp>
+          <p:nvSpPr>
+            <p:cNvPr id="52" name="Oval 51">
+              <a:extLst>
+                <a:ext uri="{FF2B5EF4-FFF2-40B4-BE49-F238E27FC236}">
+                  <a16:creationId xmlns:a16="http://schemas.microsoft.com/office/drawing/2014/main" id="{2F47DFF4-5CAC-C108-BD7F-E3EEF2FF9A28}"/>
+                </a:ext>
+              </a:extLst>
+            </p:cNvPr>
+            <p:cNvSpPr/>
+            <p:nvPr/>
+          </p:nvSpPr>
+          <p:spPr>
+            <a:xfrm>
+              <a:off x="9137494" y="4395277"/>
+              <a:ext cx="1631245" cy="391130"/>
+            </a:xfrm>
+            <a:prstGeom prst="ellipse">
+              <a:avLst/>
+            </a:prstGeom>
+            <a:noFill/>
+            <a:ln>
+              <a:noFill/>
+            </a:ln>
+          </p:spPr>
+          <p:style>
+            <a:lnRef idx="0">
+              <a:scrgbClr r="0" g="0" b="0"/>
+            </a:lnRef>
+            <a:fillRef idx="0">
+              <a:scrgbClr r="0" g="0" b="0"/>
+            </a:fillRef>
+            <a:effectRef idx="0">
+              <a:scrgbClr r="0" g="0" b="0"/>
+            </a:effectRef>
+            <a:fontRef idx="minor">
+              <a:schemeClr val="dk1"/>
+            </a:fontRef>
+          </p:style>
+          <p:txBody>
+            <a:bodyPr rtlCol="0" anchor="ctr"/>
+            <a:lstStyle/>
+            <a:p>
+              <a:pPr algn="ctr"/>
+              <a:r>
+                <a:rPr lang="da-DK" sz="900" b="1" dirty="0" err="1">
+                  <a:solidFill>
+                    <a:schemeClr val="tx1"/>
+                  </a:solidFill>
+                </a:rPr>
+                <a:t>indiginous</a:t>
+              </a:r>
+              <a:r>
+                <a:rPr lang="da-DK" sz="900" b="1" dirty="0">
+                  <a:solidFill>
+                    <a:schemeClr val="tx1"/>
+                  </a:solidFill>
+                </a:rPr>
+                <a:t> </a:t>
+              </a:r>
+              <a:r>
+                <a:rPr lang="da-DK" sz="900" b="1" dirty="0" err="1">
+                  <a:solidFill>
+                    <a:schemeClr val="tx1"/>
+                  </a:solidFill>
+                </a:rPr>
+                <a:t>communities</a:t>
+              </a:r>
+              <a:endParaRPr lang="da-DK" sz="900" b="1" dirty="0">
+                <a:solidFill>
+                  <a:schemeClr val="tx1"/>
+                </a:solidFill>
+              </a:endParaRPr>
+            </a:p>
+          </p:txBody>
+        </p:sp>
+        <p:sp>
+          <p:nvSpPr>
+            <p:cNvPr id="53" name="Oval 52">
+              <a:extLst>
+                <a:ext uri="{FF2B5EF4-FFF2-40B4-BE49-F238E27FC236}">
+                  <a16:creationId xmlns:a16="http://schemas.microsoft.com/office/drawing/2014/main" id="{E1253534-EE7D-4041-E38D-41B055140DE0}"/>
+                </a:ext>
+              </a:extLst>
+            </p:cNvPr>
+            <p:cNvSpPr/>
+            <p:nvPr/>
+          </p:nvSpPr>
+          <p:spPr>
+            <a:xfrm>
+              <a:off x="9137494" y="5275034"/>
+              <a:ext cx="1478845" cy="391130"/>
+            </a:xfrm>
+            <a:prstGeom prst="ellipse">
+              <a:avLst/>
+            </a:prstGeom>
+            <a:noFill/>
+            <a:ln>
+              <a:noFill/>
+            </a:ln>
+          </p:spPr>
+          <p:style>
+            <a:lnRef idx="0">
+              <a:scrgbClr r="0" g="0" b="0"/>
+            </a:lnRef>
+            <a:fillRef idx="0">
+              <a:scrgbClr r="0" g="0" b="0"/>
+            </a:fillRef>
+            <a:effectRef idx="0">
+              <a:scrgbClr r="0" g="0" b="0"/>
+            </a:effectRef>
+            <a:fontRef idx="minor">
+              <a:schemeClr val="dk1"/>
+            </a:fontRef>
+          </p:style>
+          <p:txBody>
+            <a:bodyPr rtlCol="0" anchor="ctr"/>
+            <a:lstStyle/>
+            <a:p>
+              <a:pPr algn="ctr"/>
+              <a:r>
+                <a:rPr lang="da-DK" sz="900" b="1" dirty="0" err="1">
+                  <a:solidFill>
+                    <a:schemeClr val="tx1"/>
+                  </a:solidFill>
+                </a:rPr>
+                <a:t>fishing</a:t>
+              </a:r>
+              <a:r>
+                <a:rPr lang="da-DK" sz="900" b="1" dirty="0">
+                  <a:solidFill>
+                    <a:schemeClr val="tx1"/>
+                  </a:solidFill>
+                </a:rPr>
+                <a:t> </a:t>
+              </a:r>
+              <a:r>
+                <a:rPr lang="da-DK" sz="900" b="1" dirty="0" err="1">
+                  <a:solidFill>
+                    <a:schemeClr val="tx1"/>
+                  </a:solidFill>
+                </a:rPr>
+                <a:t>fleet</a:t>
+              </a:r>
+              <a:endParaRPr lang="da-DK" sz="900" b="1" dirty="0">
+                <a:solidFill>
+                  <a:schemeClr val="tx1"/>
+                </a:solidFill>
+              </a:endParaRPr>
+            </a:p>
+          </p:txBody>
+        </p:sp>
+        <p:cxnSp>
+          <p:nvCxnSpPr>
+            <p:cNvPr id="55" name="Straight Connector 54">
+              <a:extLst>
+                <a:ext uri="{FF2B5EF4-FFF2-40B4-BE49-F238E27FC236}">
+                  <a16:creationId xmlns:a16="http://schemas.microsoft.com/office/drawing/2014/main" id="{F105E0D5-3863-CFFD-45C8-7E07715FEE48}"/>
+                </a:ext>
+              </a:extLst>
+            </p:cNvPr>
+            <p:cNvCxnSpPr>
+              <a:cxnSpLocks/>
+            </p:cNvCxnSpPr>
+            <p:nvPr/>
+          </p:nvCxnSpPr>
+          <p:spPr>
+            <a:xfrm flipV="1">
+              <a:off x="9028766" y="4833253"/>
+              <a:ext cx="710723" cy="681499"/>
+            </a:xfrm>
+            <a:prstGeom prst="line">
+              <a:avLst/>
+            </a:prstGeom>
+          </p:spPr>
+          <p:style>
+            <a:lnRef idx="1">
+              <a:schemeClr val="dk1"/>
+            </a:lnRef>
+            <a:fillRef idx="0">
+              <a:schemeClr val="dk1"/>
+            </a:fillRef>
+            <a:effectRef idx="0">
+              <a:schemeClr val="dk1"/>
+            </a:effectRef>
+            <a:fontRef idx="minor">
+              <a:schemeClr val="tx1"/>
+            </a:fontRef>
+          </p:style>
+        </p:cxnSp>
+        <p:cxnSp>
+          <p:nvCxnSpPr>
+            <p:cNvPr id="58" name="Straight Connector 57">
+              <a:extLst>
+                <a:ext uri="{FF2B5EF4-FFF2-40B4-BE49-F238E27FC236}">
+                  <a16:creationId xmlns:a16="http://schemas.microsoft.com/office/drawing/2014/main" id="{C19C0E46-5103-25BC-0B6D-9FBAD90449D9}"/>
+                </a:ext>
+              </a:extLst>
+            </p:cNvPr>
+            <p:cNvCxnSpPr>
+              <a:cxnSpLocks/>
+            </p:cNvCxnSpPr>
+            <p:nvPr/>
+          </p:nvCxnSpPr>
+          <p:spPr>
+            <a:xfrm flipV="1">
+              <a:off x="9426222" y="6181231"/>
+              <a:ext cx="313267" cy="105208"/>
+            </a:xfrm>
+            <a:prstGeom prst="line">
+              <a:avLst/>
+            </a:prstGeom>
+          </p:spPr>
+          <p:style>
+            <a:lnRef idx="1">
+              <a:schemeClr val="dk1"/>
+            </a:lnRef>
+            <a:fillRef idx="0">
+              <a:schemeClr val="dk1"/>
+            </a:fillRef>
+            <a:effectRef idx="0">
+              <a:schemeClr val="dk1"/>
+            </a:effectRef>
+            <a:fontRef idx="minor">
+              <a:schemeClr val="tx1"/>
+            </a:fontRef>
+          </p:style>
+        </p:cxnSp>
+        <p:cxnSp>
+          <p:nvCxnSpPr>
+            <p:cNvPr id="60" name="Straight Connector 59">
+              <a:extLst>
+                <a:ext uri="{FF2B5EF4-FFF2-40B4-BE49-F238E27FC236}">
+                  <a16:creationId xmlns:a16="http://schemas.microsoft.com/office/drawing/2014/main" id="{AE991B7D-4EBD-CF49-7781-DD825CFE1026}"/>
+                </a:ext>
+              </a:extLst>
+            </p:cNvPr>
+            <p:cNvCxnSpPr>
+              <a:cxnSpLocks/>
+            </p:cNvCxnSpPr>
+            <p:nvPr/>
+          </p:nvCxnSpPr>
+          <p:spPr>
+            <a:xfrm flipV="1">
+              <a:off x="8286044" y="5897825"/>
+              <a:ext cx="170195" cy="193049"/>
+            </a:xfrm>
+            <a:prstGeom prst="line">
+              <a:avLst/>
+            </a:prstGeom>
+          </p:spPr>
+          <p:style>
+            <a:lnRef idx="1">
+              <a:schemeClr val="dk1"/>
+            </a:lnRef>
+            <a:fillRef idx="0">
+              <a:schemeClr val="dk1"/>
+            </a:fillRef>
+            <a:effectRef idx="0">
+              <a:schemeClr val="dk1"/>
+            </a:effectRef>
+            <a:fontRef idx="minor">
+              <a:schemeClr val="tx1"/>
+            </a:fontRef>
+          </p:style>
+        </p:cxnSp>
+        <p:sp>
+          <p:nvSpPr>
+            <p:cNvPr id="64" name="Oval 63">
+              <a:extLst>
+                <a:ext uri="{FF2B5EF4-FFF2-40B4-BE49-F238E27FC236}">
+                  <a16:creationId xmlns:a16="http://schemas.microsoft.com/office/drawing/2014/main" id="{00D8D6BA-B16F-7848-DFC3-BBD88372D500}"/>
+                </a:ext>
+              </a:extLst>
+            </p:cNvPr>
+            <p:cNvSpPr/>
+            <p:nvPr/>
+          </p:nvSpPr>
+          <p:spPr>
+            <a:xfrm>
+              <a:off x="7837310" y="6414604"/>
+              <a:ext cx="1631245" cy="391130"/>
+            </a:xfrm>
+            <a:prstGeom prst="ellipse">
+              <a:avLst/>
+            </a:prstGeom>
+            <a:noFill/>
+            <a:ln>
+              <a:noFill/>
+            </a:ln>
+          </p:spPr>
+          <p:style>
+            <a:lnRef idx="0">
+              <a:scrgbClr r="0" g="0" b="0"/>
+            </a:lnRef>
+            <a:fillRef idx="0">
+              <a:scrgbClr r="0" g="0" b="0"/>
+            </a:fillRef>
+            <a:effectRef idx="0">
+              <a:scrgbClr r="0" g="0" b="0"/>
+            </a:effectRef>
+            <a:fontRef idx="minor">
+              <a:schemeClr val="dk1"/>
+            </a:fontRef>
+          </p:style>
+          <p:txBody>
+            <a:bodyPr rtlCol="0" anchor="ctr"/>
+            <a:lstStyle/>
+            <a:p>
+              <a:pPr algn="ctr"/>
+              <a:r>
+                <a:rPr lang="da-DK" sz="900" b="1" dirty="0">
+                  <a:solidFill>
+                    <a:schemeClr val="tx1"/>
+                  </a:solidFill>
+                </a:rPr>
+                <a:t>marine pollution</a:t>
+              </a:r>
+            </a:p>
+          </p:txBody>
+        </p:sp>
+        <p:cxnSp>
+          <p:nvCxnSpPr>
+            <p:cNvPr id="65" name="Straight Connector 64">
+              <a:extLst>
+                <a:ext uri="{FF2B5EF4-FFF2-40B4-BE49-F238E27FC236}">
+                  <a16:creationId xmlns:a16="http://schemas.microsoft.com/office/drawing/2014/main" id="{25B0A37F-A66D-74D1-E535-BE514A1F8E44}"/>
+                </a:ext>
+              </a:extLst>
+            </p:cNvPr>
+            <p:cNvCxnSpPr>
+              <a:cxnSpLocks/>
+            </p:cNvCxnSpPr>
+            <p:nvPr/>
+          </p:nvCxnSpPr>
+          <p:spPr>
+            <a:xfrm flipH="1" flipV="1">
+              <a:off x="8117572" y="6327035"/>
+              <a:ext cx="253569" cy="192485"/>
+            </a:xfrm>
+            <a:prstGeom prst="line">
+              <a:avLst/>
+            </a:prstGeom>
+          </p:spPr>
+          <p:style>
+            <a:lnRef idx="1">
+              <a:schemeClr val="dk1"/>
+            </a:lnRef>
+            <a:fillRef idx="0">
+              <a:schemeClr val="dk1"/>
+            </a:fillRef>
+            <a:effectRef idx="0">
+              <a:schemeClr val="dk1"/>
+            </a:effectRef>
+            <a:fontRef idx="minor">
+              <a:schemeClr val="tx1"/>
+            </a:fontRef>
+          </p:style>
+        </p:cxnSp>
+        <p:cxnSp>
+          <p:nvCxnSpPr>
+            <p:cNvPr id="67" name="Straight Connector 66">
+              <a:extLst>
+                <a:ext uri="{FF2B5EF4-FFF2-40B4-BE49-F238E27FC236}">
+                  <a16:creationId xmlns:a16="http://schemas.microsoft.com/office/drawing/2014/main" id="{C50CAF3C-A290-E4A1-4E92-A97987FB60AC}"/>
+                </a:ext>
+              </a:extLst>
+            </p:cNvPr>
+            <p:cNvCxnSpPr>
+              <a:cxnSpLocks/>
+            </p:cNvCxnSpPr>
+            <p:nvPr/>
+          </p:nvCxnSpPr>
+          <p:spPr>
+            <a:xfrm flipH="1" flipV="1">
+              <a:off x="8856994" y="5854040"/>
+              <a:ext cx="280500" cy="343097"/>
+            </a:xfrm>
+            <a:prstGeom prst="line">
+              <a:avLst/>
+            </a:prstGeom>
+          </p:spPr>
+          <p:style>
+            <a:lnRef idx="1">
+              <a:schemeClr val="dk1"/>
+            </a:lnRef>
+            <a:fillRef idx="0">
+              <a:schemeClr val="dk1"/>
+            </a:fillRef>
+            <a:effectRef idx="0">
+              <a:schemeClr val="dk1"/>
+            </a:effectRef>
+            <a:fontRef idx="minor">
+              <a:schemeClr val="tx1"/>
+            </a:fontRef>
+          </p:style>
+        </p:cxnSp>
+        <p:cxnSp>
+          <p:nvCxnSpPr>
+            <p:cNvPr id="69" name="Straight Connector 68">
+              <a:extLst>
+                <a:ext uri="{FF2B5EF4-FFF2-40B4-BE49-F238E27FC236}">
+                  <a16:creationId xmlns:a16="http://schemas.microsoft.com/office/drawing/2014/main" id="{1112C186-2A84-E1FF-6573-4E5CE44ABDAD}"/>
+                </a:ext>
+              </a:extLst>
+            </p:cNvPr>
+            <p:cNvCxnSpPr>
+              <a:cxnSpLocks/>
+            </p:cNvCxnSpPr>
+            <p:nvPr/>
+          </p:nvCxnSpPr>
+          <p:spPr>
+            <a:xfrm flipV="1">
+              <a:off x="8912146" y="6363360"/>
+              <a:ext cx="170195" cy="193049"/>
+            </a:xfrm>
+            <a:prstGeom prst="line">
+              <a:avLst/>
+            </a:prstGeom>
+          </p:spPr>
+          <p:style>
+            <a:lnRef idx="1">
+              <a:schemeClr val="dk1"/>
+            </a:lnRef>
+            <a:fillRef idx="0">
+              <a:schemeClr val="dk1"/>
+            </a:fillRef>
+            <a:effectRef idx="0">
+              <a:schemeClr val="dk1"/>
+            </a:effectRef>
+            <a:fontRef idx="minor">
+              <a:schemeClr val="tx1"/>
+            </a:fontRef>
+          </p:style>
+        </p:cxnSp>
+        <p:cxnSp>
+          <p:nvCxnSpPr>
+            <p:cNvPr id="70" name="Straight Connector 69">
+              <a:extLst>
+                <a:ext uri="{FF2B5EF4-FFF2-40B4-BE49-F238E27FC236}">
+                  <a16:creationId xmlns:a16="http://schemas.microsoft.com/office/drawing/2014/main" id="{A7FF44C2-B218-E905-8077-C0A3DD82339E}"/>
+                </a:ext>
+              </a:extLst>
+            </p:cNvPr>
+            <p:cNvCxnSpPr>
+              <a:cxnSpLocks/>
+            </p:cNvCxnSpPr>
+            <p:nvPr/>
+          </p:nvCxnSpPr>
+          <p:spPr>
+            <a:xfrm flipV="1">
+              <a:off x="8621889" y="5897825"/>
+              <a:ext cx="25395" cy="478589"/>
+            </a:xfrm>
+            <a:prstGeom prst="line">
+              <a:avLst/>
+            </a:prstGeom>
+          </p:spPr>
+          <p:style>
+            <a:lnRef idx="1">
+              <a:schemeClr val="dk1"/>
+            </a:lnRef>
+            <a:fillRef idx="0">
+              <a:schemeClr val="dk1"/>
+            </a:fillRef>
+            <a:effectRef idx="0">
+              <a:schemeClr val="dk1"/>
+            </a:effectRef>
+            <a:fontRef idx="minor">
+              <a:schemeClr val="tx1"/>
+            </a:fontRef>
+          </p:style>
+        </p:cxnSp>
+        <p:cxnSp>
+          <p:nvCxnSpPr>
+            <p:cNvPr id="72" name="Straight Connector 71">
+              <a:extLst>
+                <a:ext uri="{FF2B5EF4-FFF2-40B4-BE49-F238E27FC236}">
+                  <a16:creationId xmlns:a16="http://schemas.microsoft.com/office/drawing/2014/main" id="{8C6B8F40-E1F6-39C2-C27E-A03F1DF489C4}"/>
+                </a:ext>
+              </a:extLst>
+            </p:cNvPr>
+            <p:cNvCxnSpPr>
+              <a:cxnSpLocks/>
+            </p:cNvCxnSpPr>
+            <p:nvPr/>
+          </p:nvCxnSpPr>
+          <p:spPr>
+            <a:xfrm flipH="1" flipV="1">
+              <a:off x="9105528" y="5828029"/>
+              <a:ext cx="425174" cy="152202"/>
+            </a:xfrm>
+            <a:prstGeom prst="line">
+              <a:avLst/>
+            </a:prstGeom>
+          </p:spPr>
+          <p:style>
+            <a:lnRef idx="1">
+              <a:schemeClr val="dk1"/>
+            </a:lnRef>
+            <a:fillRef idx="0">
+              <a:schemeClr val="dk1"/>
+            </a:fillRef>
+            <a:effectRef idx="0">
+              <a:schemeClr val="dk1"/>
+            </a:effectRef>
+            <a:fontRef idx="minor">
+              <a:schemeClr val="tx1"/>
+            </a:fontRef>
+          </p:style>
+        </p:cxnSp>
+        <p:cxnSp>
+          <p:nvCxnSpPr>
+            <p:cNvPr id="74" name="Straight Connector 73">
+              <a:extLst>
+                <a:ext uri="{FF2B5EF4-FFF2-40B4-BE49-F238E27FC236}">
+                  <a16:creationId xmlns:a16="http://schemas.microsoft.com/office/drawing/2014/main" id="{8FF64CA8-E40D-9146-5C45-414E9C611635}"/>
+                </a:ext>
+              </a:extLst>
+            </p:cNvPr>
+            <p:cNvCxnSpPr>
+              <a:cxnSpLocks/>
+              <a:stCxn id="43" idx="0"/>
+            </p:cNvCxnSpPr>
+            <p:nvPr/>
+          </p:nvCxnSpPr>
+          <p:spPr>
+            <a:xfrm flipV="1">
+              <a:off x="8686800" y="5104171"/>
+              <a:ext cx="11095" cy="395046"/>
+            </a:xfrm>
+            <a:prstGeom prst="line">
+              <a:avLst/>
+            </a:prstGeom>
+          </p:spPr>
+          <p:style>
+            <a:lnRef idx="1">
+              <a:schemeClr val="dk1"/>
+            </a:lnRef>
+            <a:fillRef idx="0">
+              <a:schemeClr val="dk1"/>
+            </a:fillRef>
+            <a:effectRef idx="0">
+              <a:schemeClr val="dk1"/>
+            </a:effectRef>
+            <a:fontRef idx="minor">
+              <a:schemeClr val="tx1"/>
+            </a:fontRef>
+          </p:style>
+        </p:cxnSp>
+        <p:cxnSp>
+          <p:nvCxnSpPr>
+            <p:cNvPr id="77" name="Straight Connector 76">
+              <a:extLst>
+                <a:ext uri="{FF2B5EF4-FFF2-40B4-BE49-F238E27FC236}">
+                  <a16:creationId xmlns:a16="http://schemas.microsoft.com/office/drawing/2014/main" id="{91A9D9DD-F0E1-9615-8ECA-CE1AB9A84A91}"/>
+                </a:ext>
+              </a:extLst>
+            </p:cNvPr>
+            <p:cNvCxnSpPr>
+              <a:cxnSpLocks/>
+            </p:cNvCxnSpPr>
+            <p:nvPr/>
+          </p:nvCxnSpPr>
+          <p:spPr>
+            <a:xfrm flipV="1">
+              <a:off x="9210764" y="4752216"/>
+              <a:ext cx="223027" cy="131973"/>
+            </a:xfrm>
+            <a:prstGeom prst="line">
+              <a:avLst/>
+            </a:prstGeom>
+          </p:spPr>
+          <p:style>
+            <a:lnRef idx="1">
+              <a:schemeClr val="dk1"/>
+            </a:lnRef>
+            <a:fillRef idx="0">
+              <a:schemeClr val="dk1"/>
+            </a:fillRef>
+            <a:effectRef idx="0">
+              <a:schemeClr val="dk1"/>
+            </a:effectRef>
+            <a:fontRef idx="minor">
+              <a:schemeClr val="tx1"/>
+            </a:fontRef>
+          </p:style>
+        </p:cxnSp>
+        <p:cxnSp>
+          <p:nvCxnSpPr>
+            <p:cNvPr id="79" name="Straight Connector 78">
+              <a:extLst>
+                <a:ext uri="{FF2B5EF4-FFF2-40B4-BE49-F238E27FC236}">
+                  <a16:creationId xmlns:a16="http://schemas.microsoft.com/office/drawing/2014/main" id="{115BAC95-0ED4-582B-2AA0-9BE978DA5FCF}"/>
+                </a:ext>
+              </a:extLst>
+            </p:cNvPr>
+            <p:cNvCxnSpPr>
+              <a:cxnSpLocks/>
+              <a:endCxn id="52" idx="4"/>
+            </p:cNvCxnSpPr>
+            <p:nvPr/>
+          </p:nvCxnSpPr>
+          <p:spPr>
+            <a:xfrm flipV="1">
+              <a:off x="9884879" y="4786407"/>
+              <a:ext cx="68238" cy="562832"/>
+            </a:xfrm>
+            <a:prstGeom prst="line">
+              <a:avLst/>
+            </a:prstGeom>
+          </p:spPr>
+          <p:style>
+            <a:lnRef idx="1">
+              <a:schemeClr val="dk1"/>
+            </a:lnRef>
+            <a:fillRef idx="0">
+              <a:schemeClr val="dk1"/>
+            </a:fillRef>
+            <a:effectRef idx="0">
+              <a:schemeClr val="dk1"/>
+            </a:effectRef>
+            <a:fontRef idx="minor">
+              <a:schemeClr val="tx1"/>
+            </a:fontRef>
+          </p:style>
+        </p:cxnSp>
+        <p:cxnSp>
+          <p:nvCxnSpPr>
+            <p:cNvPr id="81" name="Straight Connector 80">
+              <a:extLst>
+                <a:ext uri="{FF2B5EF4-FFF2-40B4-BE49-F238E27FC236}">
+                  <a16:creationId xmlns:a16="http://schemas.microsoft.com/office/drawing/2014/main" id="{600DD077-04A5-315C-EF66-77374B0BB0BA}"/>
+                </a:ext>
+              </a:extLst>
+            </p:cNvPr>
+            <p:cNvCxnSpPr>
+              <a:cxnSpLocks/>
+            </p:cNvCxnSpPr>
+            <p:nvPr/>
+          </p:nvCxnSpPr>
+          <p:spPr>
+            <a:xfrm flipH="1" flipV="1">
+              <a:off x="9176577" y="5075331"/>
+              <a:ext cx="474537" cy="273908"/>
+            </a:xfrm>
+            <a:prstGeom prst="line">
+              <a:avLst/>
+            </a:prstGeom>
+          </p:spPr>
+          <p:style>
+            <a:lnRef idx="1">
+              <a:schemeClr val="dk1"/>
+            </a:lnRef>
+            <a:fillRef idx="0">
+              <a:schemeClr val="dk1"/>
+            </a:fillRef>
+            <a:effectRef idx="0">
+              <a:schemeClr val="dk1"/>
+            </a:effectRef>
+            <a:fontRef idx="minor">
+              <a:schemeClr val="tx1"/>
+            </a:fontRef>
+          </p:style>
+        </p:cxnSp>
+        <p:sp>
+          <p:nvSpPr>
+            <p:cNvPr id="85" name="Oval 84">
+              <a:extLst>
+                <a:ext uri="{FF2B5EF4-FFF2-40B4-BE49-F238E27FC236}">
+                  <a16:creationId xmlns:a16="http://schemas.microsoft.com/office/drawing/2014/main" id="{73211C92-5469-ABA2-9B16-C0DBA90AF7F8}"/>
+                </a:ext>
+              </a:extLst>
+            </p:cNvPr>
+            <p:cNvSpPr/>
+            <p:nvPr/>
+          </p:nvSpPr>
+          <p:spPr>
+            <a:xfrm>
+              <a:off x="9953116" y="4808220"/>
+              <a:ext cx="1478845" cy="391130"/>
+            </a:xfrm>
+            <a:prstGeom prst="ellipse">
+              <a:avLst/>
+            </a:prstGeom>
+            <a:noFill/>
+            <a:ln>
+              <a:noFill/>
+            </a:ln>
+          </p:spPr>
+          <p:style>
+            <a:lnRef idx="0">
+              <a:scrgbClr r="0" g="0" b="0"/>
+            </a:lnRef>
+            <a:fillRef idx="0">
+              <a:scrgbClr r="0" g="0" b="0"/>
+            </a:fillRef>
+            <a:effectRef idx="0">
+              <a:scrgbClr r="0" g="0" b="0"/>
+            </a:effectRef>
+            <a:fontRef idx="minor">
+              <a:schemeClr val="dk1"/>
+            </a:fontRef>
+          </p:style>
+          <p:txBody>
+            <a:bodyPr rtlCol="0" anchor="ctr"/>
+            <a:lstStyle/>
+            <a:p>
+              <a:pPr algn="ctr"/>
+              <a:r>
+                <a:rPr lang="da-DK" sz="900" b="1" dirty="0">
+                  <a:solidFill>
+                    <a:schemeClr val="tx1"/>
+                  </a:solidFill>
+                </a:rPr>
+                <a:t>international </a:t>
+              </a:r>
+              <a:r>
+                <a:rPr lang="da-DK" sz="900" b="1" dirty="0" err="1">
+                  <a:solidFill>
+                    <a:schemeClr val="tx1"/>
+                  </a:solidFill>
+                </a:rPr>
+                <a:t>waters</a:t>
+              </a:r>
+              <a:endParaRPr lang="da-DK" sz="900" b="1" dirty="0">
+                <a:solidFill>
+                  <a:schemeClr val="tx1"/>
+                </a:solidFill>
+              </a:endParaRPr>
+            </a:p>
+          </p:txBody>
+        </p:sp>
+        <p:cxnSp>
+          <p:nvCxnSpPr>
+            <p:cNvPr id="91" name="Straight Connector 90">
+              <a:extLst>
+                <a:ext uri="{FF2B5EF4-FFF2-40B4-BE49-F238E27FC236}">
+                  <a16:creationId xmlns:a16="http://schemas.microsoft.com/office/drawing/2014/main" id="{8BAE7961-9ED8-A96B-242C-101AC875DCAD}"/>
+                </a:ext>
+              </a:extLst>
+            </p:cNvPr>
+            <p:cNvCxnSpPr>
+              <a:cxnSpLocks/>
+            </p:cNvCxnSpPr>
+            <p:nvPr/>
+          </p:nvCxnSpPr>
+          <p:spPr>
+            <a:xfrm flipV="1">
+              <a:off x="9262531" y="4992595"/>
+              <a:ext cx="1070074" cy="11190"/>
+            </a:xfrm>
+            <a:prstGeom prst="line">
+              <a:avLst/>
+            </a:prstGeom>
+          </p:spPr>
+          <p:style>
+            <a:lnRef idx="1">
+              <a:schemeClr val="dk1"/>
+            </a:lnRef>
+            <a:fillRef idx="0">
+              <a:schemeClr val="dk1"/>
+            </a:fillRef>
+            <a:effectRef idx="0">
+              <a:schemeClr val="dk1"/>
+            </a:effectRef>
+            <a:fontRef idx="minor">
+              <a:schemeClr val="tx1"/>
+            </a:fontRef>
+          </p:style>
+        </p:cxnSp>
+        <p:cxnSp>
+          <p:nvCxnSpPr>
+            <p:cNvPr id="97" name="Straight Connector 96">
+              <a:extLst>
+                <a:ext uri="{FF2B5EF4-FFF2-40B4-BE49-F238E27FC236}">
+                  <a16:creationId xmlns:a16="http://schemas.microsoft.com/office/drawing/2014/main" id="{8A7A93A4-056C-E467-E938-B057921D33EE}"/>
+                </a:ext>
+              </a:extLst>
+            </p:cNvPr>
+            <p:cNvCxnSpPr>
+              <a:cxnSpLocks/>
+            </p:cNvCxnSpPr>
+            <p:nvPr/>
+          </p:nvCxnSpPr>
+          <p:spPr>
+            <a:xfrm flipV="1">
+              <a:off x="10165645" y="5178363"/>
+              <a:ext cx="285951" cy="187616"/>
+            </a:xfrm>
+            <a:prstGeom prst="line">
+              <a:avLst/>
+            </a:prstGeom>
+          </p:spPr>
+          <p:style>
+            <a:lnRef idx="1">
+              <a:schemeClr val="dk1"/>
+            </a:lnRef>
+            <a:fillRef idx="0">
+              <a:schemeClr val="dk1"/>
+            </a:fillRef>
+            <a:effectRef idx="0">
+              <a:schemeClr val="dk1"/>
+            </a:effectRef>
+            <a:fontRef idx="minor">
+              <a:schemeClr val="tx1"/>
+            </a:fontRef>
+          </p:style>
+        </p:cxnSp>
+        <p:cxnSp>
+          <p:nvCxnSpPr>
+            <p:cNvPr id="99" name="Straight Connector 98">
+              <a:extLst>
+                <a:ext uri="{FF2B5EF4-FFF2-40B4-BE49-F238E27FC236}">
+                  <a16:creationId xmlns:a16="http://schemas.microsoft.com/office/drawing/2014/main" id="{48C63428-75ED-37C1-9368-1B3A79B1A244}"/>
+                </a:ext>
+              </a:extLst>
+            </p:cNvPr>
+            <p:cNvCxnSpPr>
+              <a:cxnSpLocks/>
+            </p:cNvCxnSpPr>
+            <p:nvPr/>
+          </p:nvCxnSpPr>
+          <p:spPr>
+            <a:xfrm flipV="1">
+              <a:off x="10098507" y="5257295"/>
+              <a:ext cx="624096" cy="768293"/>
+            </a:xfrm>
+            <a:prstGeom prst="line">
+              <a:avLst/>
+            </a:prstGeom>
+          </p:spPr>
+          <p:style>
+            <a:lnRef idx="1">
+              <a:schemeClr val="dk1"/>
+            </a:lnRef>
+            <a:fillRef idx="0">
+              <a:schemeClr val="dk1"/>
+            </a:fillRef>
+            <a:effectRef idx="0">
+              <a:schemeClr val="dk1"/>
+            </a:effectRef>
+            <a:fontRef idx="minor">
+              <a:schemeClr val="tx1"/>
+            </a:fontRef>
+          </p:style>
+        </p:cxnSp>
+      </p:grpSp>
+      <p:sp>
+        <p:nvSpPr>
+          <p:cNvPr id="110" name="Rectangle 109">
+            <a:extLst>
+              <a:ext uri="{FF2B5EF4-FFF2-40B4-BE49-F238E27FC236}">
+                <a16:creationId xmlns:a16="http://schemas.microsoft.com/office/drawing/2014/main" id="{571BB537-2331-71D5-E940-AB8357AC6E22}"/>
+              </a:ext>
+            </a:extLst>
+          </p:cNvPr>
+          <p:cNvSpPr/>
+          <p:nvPr/>
+        </p:nvSpPr>
+        <p:spPr>
+          <a:xfrm>
+            <a:off x="3849952" y="4023261"/>
+            <a:ext cx="4367002" cy="585797"/>
+          </a:xfrm>
+          <a:prstGeom prst="rect">
+            <a:avLst/>
+          </a:prstGeom>
+          <a:ln/>
+        </p:spPr>
+        <p:style>
+          <a:lnRef idx="2">
+            <a:schemeClr val="accent1"/>
+          </a:lnRef>
+          <a:fillRef idx="1">
+            <a:schemeClr val="lt1"/>
+          </a:fillRef>
+          <a:effectRef idx="0">
+            <a:schemeClr val="accent1"/>
+          </a:effectRef>
+          <a:fontRef idx="minor">
+            <a:schemeClr val="dk1"/>
+          </a:fontRef>
+        </p:style>
+        <p:txBody>
+          <a:bodyPr rtlCol="0" anchor="ctr"/>
+          <a:lstStyle/>
+          <a:p>
+            <a:pPr algn="ctr"/>
+            <a:endParaRPr lang="da-DK" sz="1400" dirty="0">
+              <a:solidFill>
+                <a:schemeClr val="tx1"/>
+              </a:solidFill>
+            </a:endParaRPr>
+          </a:p>
+          <a:p>
+            <a:pPr algn="ctr"/>
+            <a:endParaRPr lang="da-DK" sz="1400" dirty="0">
+              <a:solidFill>
+                <a:schemeClr val="tx1"/>
+              </a:solidFill>
+            </a:endParaRPr>
+          </a:p>
+          <a:p>
+            <a:pPr algn="ctr"/>
+            <a:endParaRPr lang="da-DK" sz="1400" dirty="0">
+              <a:solidFill>
+                <a:schemeClr val="tx1"/>
+              </a:solidFill>
+            </a:endParaRPr>
+          </a:p>
+          <a:p>
+            <a:r>
+              <a:rPr lang="da-DK" sz="1400" dirty="0">
+                <a:solidFill>
+                  <a:schemeClr val="tx1"/>
+                </a:solidFill>
+              </a:rPr>
+              <a:t>                                 Network </a:t>
+            </a:r>
+            <a:r>
+              <a:rPr lang="da-DK" sz="1400" dirty="0" err="1">
+                <a:solidFill>
+                  <a:schemeClr val="tx1"/>
+                </a:solidFill>
+              </a:rPr>
+              <a:t>analysis</a:t>
+            </a:r>
+            <a:endParaRPr lang="da-DK" sz="1400" dirty="0">
+              <a:solidFill>
+                <a:schemeClr val="tx1"/>
+              </a:solidFill>
+            </a:endParaRPr>
+          </a:p>
+          <a:p>
+            <a:pPr algn="ctr"/>
+            <a:r>
+              <a:rPr lang="da-DK" sz="1200" dirty="0">
+                <a:solidFill>
+                  <a:schemeClr val="tx1"/>
+                </a:solidFill>
+              </a:rPr>
+              <a:t>(1) Citation </a:t>
+            </a:r>
+            <a:r>
+              <a:rPr lang="da-DK" sz="1200" dirty="0" err="1">
+                <a:solidFill>
+                  <a:schemeClr val="tx1"/>
+                </a:solidFill>
+              </a:rPr>
+              <a:t>network</a:t>
+            </a:r>
+            <a:r>
+              <a:rPr lang="da-DK" sz="1200" dirty="0">
+                <a:solidFill>
+                  <a:schemeClr val="tx1"/>
+                </a:solidFill>
+              </a:rPr>
+              <a:t>                   (2) term label </a:t>
+            </a:r>
+            <a:r>
+              <a:rPr lang="da-DK" sz="1200" dirty="0" err="1">
+                <a:solidFill>
+                  <a:schemeClr val="tx1"/>
+                </a:solidFill>
+              </a:rPr>
+              <a:t>co-occurance</a:t>
+            </a:r>
+            <a:r>
+              <a:rPr lang="da-DK" sz="1200" dirty="0">
+                <a:solidFill>
+                  <a:schemeClr val="tx1"/>
+                </a:solidFill>
+              </a:rPr>
+              <a:t> </a:t>
+            </a:r>
+            <a:r>
+              <a:rPr lang="da-DK" sz="1200" dirty="0" err="1">
+                <a:solidFill>
+                  <a:schemeClr val="tx1"/>
+                </a:solidFill>
+              </a:rPr>
+              <a:t>network</a:t>
+            </a:r>
+            <a:endParaRPr lang="da-DK" sz="1200" dirty="0">
+              <a:solidFill>
+                <a:schemeClr val="tx1"/>
+              </a:solidFill>
+            </a:endParaRPr>
+          </a:p>
+          <a:p>
+            <a:pPr algn="ctr"/>
+            <a:endParaRPr lang="da-DK" sz="1400" dirty="0"/>
+          </a:p>
+          <a:p>
+            <a:pPr algn="ctr"/>
+            <a:endParaRPr lang="da-DK" sz="1400" dirty="0"/>
+          </a:p>
+          <a:p>
+            <a:pPr algn="ctr"/>
+            <a:endParaRPr lang="da-DK" sz="1400" dirty="0"/>
+          </a:p>
+        </p:txBody>
+      </p:sp>
+      <p:cxnSp>
+        <p:nvCxnSpPr>
+          <p:cNvPr id="111" name="Straight Arrow Connector 110">
+            <a:extLst>
+              <a:ext uri="{FF2B5EF4-FFF2-40B4-BE49-F238E27FC236}">
+                <a16:creationId xmlns:a16="http://schemas.microsoft.com/office/drawing/2014/main" id="{7A5467DC-AA20-52F7-52EB-83FC40F882E9}"/>
+              </a:ext>
+            </a:extLst>
+          </p:cNvPr>
+          <p:cNvCxnSpPr>
+            <a:cxnSpLocks/>
+          </p:cNvCxnSpPr>
+          <p:nvPr/>
+        </p:nvCxnSpPr>
+        <p:spPr>
+          <a:xfrm>
+            <a:off x="4387854" y="2610703"/>
+            <a:ext cx="0" cy="369564"/>
+          </a:xfrm>
+          <a:prstGeom prst="straightConnector1">
+            <a:avLst/>
+          </a:prstGeom>
+          <a:ln w="12700" cap="flat" cmpd="sng" algn="ctr">
+            <a:solidFill>
+              <a:schemeClr val="accent1"/>
+            </a:solidFill>
+            <a:prstDash val="solid"/>
+            <a:round/>
+            <a:headEnd type="none" w="med" len="med"/>
+            <a:tailEnd type="arrow" w="med" len="med"/>
+          </a:ln>
+        </p:spPr>
+        <p:style>
+          <a:lnRef idx="0">
+            <a:scrgbClr r="0" g="0" b="0"/>
+          </a:lnRef>
+          <a:fillRef idx="0">
+            <a:scrgbClr r="0" g="0" b="0"/>
+          </a:fillRef>
+          <a:effectRef idx="0">
+            <a:scrgbClr r="0" g="0" b="0"/>
+          </a:effectRef>
+          <a:fontRef idx="minor">
+            <a:schemeClr val="tx1"/>
+          </a:fontRef>
+        </p:style>
+      </p:cxnSp>
+      <p:cxnSp>
+        <p:nvCxnSpPr>
+          <p:cNvPr id="113" name="Straight Arrow Connector 112">
+            <a:extLst>
+              <a:ext uri="{FF2B5EF4-FFF2-40B4-BE49-F238E27FC236}">
+                <a16:creationId xmlns:a16="http://schemas.microsoft.com/office/drawing/2014/main" id="{C26A1942-4967-33DA-3110-524502C357D2}"/>
+              </a:ext>
+            </a:extLst>
+          </p:cNvPr>
+          <p:cNvCxnSpPr>
+            <a:cxnSpLocks/>
+          </p:cNvCxnSpPr>
+          <p:nvPr/>
+        </p:nvCxnSpPr>
+        <p:spPr>
+          <a:xfrm>
+            <a:off x="7848335" y="2610703"/>
+            <a:ext cx="0" cy="369564"/>
+          </a:xfrm>
+          <a:prstGeom prst="straightConnector1">
+            <a:avLst/>
+          </a:prstGeom>
+          <a:ln w="12700" cap="flat" cmpd="sng" algn="ctr">
+            <a:solidFill>
+              <a:schemeClr val="accent1"/>
+            </a:solidFill>
+            <a:prstDash val="solid"/>
+            <a:round/>
+            <a:headEnd type="none" w="med" len="med"/>
+            <a:tailEnd type="arrow" w="med" len="med"/>
+          </a:ln>
+        </p:spPr>
+        <p:style>
+          <a:lnRef idx="0">
+            <a:scrgbClr r="0" g="0" b="0"/>
+          </a:lnRef>
+          <a:fillRef idx="0">
+            <a:scrgbClr r="0" g="0" b="0"/>
+          </a:fillRef>
+          <a:effectRef idx="0">
+            <a:scrgbClr r="0" g="0" b="0"/>
+          </a:effectRef>
+          <a:fontRef idx="minor">
+            <a:schemeClr val="tx1"/>
+          </a:fontRef>
+        </p:style>
+      </p:cxnSp>
+      <p:cxnSp>
+        <p:nvCxnSpPr>
+          <p:cNvPr id="114" name="Straight Arrow Connector 113">
+            <a:extLst>
+              <a:ext uri="{FF2B5EF4-FFF2-40B4-BE49-F238E27FC236}">
+                <a16:creationId xmlns:a16="http://schemas.microsoft.com/office/drawing/2014/main" id="{E0B9FD49-4D41-E387-4F6C-6C2644B68577}"/>
+              </a:ext>
+            </a:extLst>
+          </p:cNvPr>
+          <p:cNvCxnSpPr>
+            <a:cxnSpLocks/>
+          </p:cNvCxnSpPr>
+          <p:nvPr/>
+        </p:nvCxnSpPr>
+        <p:spPr>
+          <a:xfrm>
+            <a:off x="5945720" y="3851817"/>
+            <a:ext cx="0" cy="171444"/>
+          </a:xfrm>
+          <a:prstGeom prst="straightConnector1">
+            <a:avLst/>
+          </a:prstGeom>
+          <a:ln w="12700" cap="flat" cmpd="sng" algn="ctr">
+            <a:solidFill>
+              <a:schemeClr val="accent1"/>
+            </a:solidFill>
+            <a:prstDash val="solid"/>
+            <a:round/>
+            <a:headEnd type="none" w="med" len="med"/>
+            <a:tailEnd type="arrow" w="med" len="med"/>
+          </a:ln>
+        </p:spPr>
+        <p:style>
+          <a:lnRef idx="0">
+            <a:scrgbClr r="0" g="0" b="0"/>
+          </a:lnRef>
+          <a:fillRef idx="0">
+            <a:scrgbClr r="0" g="0" b="0"/>
+          </a:fillRef>
+          <a:effectRef idx="0">
+            <a:scrgbClr r="0" g="0" b="0"/>
+          </a:effectRef>
+          <a:fontRef idx="minor">
+            <a:schemeClr val="tx1"/>
+          </a:fontRef>
+        </p:style>
+      </p:cxnSp>
+      <p:cxnSp>
+        <p:nvCxnSpPr>
+          <p:cNvPr id="116" name="Straight Arrow Connector 115">
+            <a:extLst>
+              <a:ext uri="{FF2B5EF4-FFF2-40B4-BE49-F238E27FC236}">
+                <a16:creationId xmlns:a16="http://schemas.microsoft.com/office/drawing/2014/main" id="{09E86055-BACF-C34F-378C-1D5967BB1F71}"/>
+              </a:ext>
+            </a:extLst>
+          </p:cNvPr>
+          <p:cNvCxnSpPr>
+            <a:cxnSpLocks/>
+          </p:cNvCxnSpPr>
+          <p:nvPr/>
+        </p:nvCxnSpPr>
+        <p:spPr>
+          <a:xfrm>
+            <a:off x="4771323" y="4619388"/>
+            <a:ext cx="0" cy="369564"/>
+          </a:xfrm>
+          <a:prstGeom prst="straightConnector1">
+            <a:avLst/>
+          </a:prstGeom>
+          <a:ln w="12700" cap="flat" cmpd="sng" algn="ctr">
+            <a:solidFill>
+              <a:schemeClr val="accent1"/>
+            </a:solidFill>
+            <a:prstDash val="solid"/>
+            <a:round/>
+            <a:headEnd type="none" w="med" len="med"/>
+            <a:tailEnd type="arrow" w="med" len="med"/>
+          </a:ln>
+        </p:spPr>
+        <p:style>
+          <a:lnRef idx="0">
+            <a:scrgbClr r="0" g="0" b="0"/>
+          </a:lnRef>
+          <a:fillRef idx="0">
+            <a:scrgbClr r="0" g="0" b="0"/>
+          </a:fillRef>
+          <a:effectRef idx="0">
+            <a:scrgbClr r="0" g="0" b="0"/>
+          </a:effectRef>
+          <a:fontRef idx="minor">
+            <a:schemeClr val="tx1"/>
+          </a:fontRef>
+        </p:style>
+      </p:cxnSp>
+      <p:cxnSp>
+        <p:nvCxnSpPr>
+          <p:cNvPr id="117" name="Straight Arrow Connector 116">
+            <a:extLst>
+              <a:ext uri="{FF2B5EF4-FFF2-40B4-BE49-F238E27FC236}">
+                <a16:creationId xmlns:a16="http://schemas.microsoft.com/office/drawing/2014/main" id="{D16D8493-018D-62E5-ACC7-D7572A916C83}"/>
+              </a:ext>
+            </a:extLst>
+          </p:cNvPr>
+          <p:cNvCxnSpPr>
+            <a:cxnSpLocks/>
+          </p:cNvCxnSpPr>
+          <p:nvPr/>
+        </p:nvCxnSpPr>
+        <p:spPr>
+          <a:xfrm>
+            <a:off x="7155990" y="4619388"/>
+            <a:ext cx="0" cy="369564"/>
+          </a:xfrm>
+          <a:prstGeom prst="straightConnector1">
+            <a:avLst/>
+          </a:prstGeom>
+          <a:ln w="12700" cap="flat" cmpd="sng" algn="ctr">
+            <a:solidFill>
+              <a:schemeClr val="accent1"/>
+            </a:solidFill>
+            <a:prstDash val="solid"/>
+            <a:round/>
+            <a:headEnd type="none" w="med" len="med"/>
+            <a:tailEnd type="arrow" w="med" len="med"/>
+          </a:ln>
+        </p:spPr>
+        <p:style>
+          <a:lnRef idx="0">
+            <a:scrgbClr r="0" g="0" b="0"/>
+          </a:lnRef>
+          <a:fillRef idx="0">
+            <a:scrgbClr r="0" g="0" b="0"/>
+          </a:fillRef>
+          <a:effectRef idx="0">
+            <a:scrgbClr r="0" g="0" b="0"/>
+          </a:effectRef>
+          <a:fontRef idx="minor">
+            <a:schemeClr val="tx1"/>
+          </a:fontRef>
+        </p:style>
+      </p:cxnSp>
+    </p:spTree>
+    <p:extLst>
+      <p:ext uri="{BB962C8B-B14F-4D97-AF65-F5344CB8AC3E}">
+        <p14:creationId xmlns:p14="http://schemas.microsoft.com/office/powerpoint/2010/main" val="759310393"/>
+      </p:ext>
+    </p:extLst>
+  </p:cSld>
+  <p:clrMapOvr>
+    <a:masterClrMapping/>
+  </p:clrMapOvr>
+</p:sld>
+</file>
+
 <file path=ppt/slides/slide2.xml><?xml version="1.0" encoding="utf-8"?>
 <p:sld xmlns:a="http://schemas.openxmlformats.org/drawingml/2006/main" xmlns:r="http://schemas.openxmlformats.org/officeDocument/2006/relationships" xmlns:p="http://schemas.openxmlformats.org/presentationml/2006/main">
   <p:cSld>

</xml_diff>

<commit_message>
fixing plots and network bc I found a slight error
</commit_message>
<xml_diff>
--- a/WP4/prelim.res.pptx
+++ b/WP4/prelim.res.pptx
@@ -271,7 +271,7 @@
           <a:p>
             <a:fld id="{E4EFA994-F2DF-48DF-AC6C-D99B8D21D338}" type="datetimeFigureOut">
               <a:rPr lang="da-DK" smtClean="0"/>
-              <a:t>04-10-2022</a:t>
+              <a:t>05-10-2022</a:t>
             </a:fld>
             <a:endParaRPr lang="da-DK"/>
           </a:p>
@@ -471,7 +471,7 @@
           <a:p>
             <a:fld id="{E4EFA994-F2DF-48DF-AC6C-D99B8D21D338}" type="datetimeFigureOut">
               <a:rPr lang="da-DK" smtClean="0"/>
-              <a:t>04-10-2022</a:t>
+              <a:t>05-10-2022</a:t>
             </a:fld>
             <a:endParaRPr lang="da-DK"/>
           </a:p>
@@ -681,7 +681,7 @@
           <a:p>
             <a:fld id="{E4EFA994-F2DF-48DF-AC6C-D99B8D21D338}" type="datetimeFigureOut">
               <a:rPr lang="da-DK" smtClean="0"/>
-              <a:t>04-10-2022</a:t>
+              <a:t>05-10-2022</a:t>
             </a:fld>
             <a:endParaRPr lang="da-DK"/>
           </a:p>
@@ -881,7 +881,7 @@
           <a:p>
             <a:fld id="{E4EFA994-F2DF-48DF-AC6C-D99B8D21D338}" type="datetimeFigureOut">
               <a:rPr lang="da-DK" smtClean="0"/>
-              <a:t>04-10-2022</a:t>
+              <a:t>05-10-2022</a:t>
             </a:fld>
             <a:endParaRPr lang="da-DK"/>
           </a:p>
@@ -1157,7 +1157,7 @@
           <a:p>
             <a:fld id="{E4EFA994-F2DF-48DF-AC6C-D99B8D21D338}" type="datetimeFigureOut">
               <a:rPr lang="da-DK" smtClean="0"/>
-              <a:t>04-10-2022</a:t>
+              <a:t>05-10-2022</a:t>
             </a:fld>
             <a:endParaRPr lang="da-DK"/>
           </a:p>
@@ -1425,7 +1425,7 @@
           <a:p>
             <a:fld id="{E4EFA994-F2DF-48DF-AC6C-D99B8D21D338}" type="datetimeFigureOut">
               <a:rPr lang="da-DK" smtClean="0"/>
-              <a:t>04-10-2022</a:t>
+              <a:t>05-10-2022</a:t>
             </a:fld>
             <a:endParaRPr lang="da-DK"/>
           </a:p>
@@ -1840,7 +1840,7 @@
           <a:p>
             <a:fld id="{E4EFA994-F2DF-48DF-AC6C-D99B8D21D338}" type="datetimeFigureOut">
               <a:rPr lang="da-DK" smtClean="0"/>
-              <a:t>04-10-2022</a:t>
+              <a:t>05-10-2022</a:t>
             </a:fld>
             <a:endParaRPr lang="da-DK"/>
           </a:p>
@@ -1982,7 +1982,7 @@
           <a:p>
             <a:fld id="{E4EFA994-F2DF-48DF-AC6C-D99B8D21D338}" type="datetimeFigureOut">
               <a:rPr lang="da-DK" smtClean="0"/>
-              <a:t>04-10-2022</a:t>
+              <a:t>05-10-2022</a:t>
             </a:fld>
             <a:endParaRPr lang="da-DK"/>
           </a:p>
@@ -2095,7 +2095,7 @@
           <a:p>
             <a:fld id="{E4EFA994-F2DF-48DF-AC6C-D99B8D21D338}" type="datetimeFigureOut">
               <a:rPr lang="da-DK" smtClean="0"/>
-              <a:t>04-10-2022</a:t>
+              <a:t>05-10-2022</a:t>
             </a:fld>
             <a:endParaRPr lang="da-DK"/>
           </a:p>
@@ -2408,7 +2408,7 @@
           <a:p>
             <a:fld id="{E4EFA994-F2DF-48DF-AC6C-D99B8D21D338}" type="datetimeFigureOut">
               <a:rPr lang="da-DK" smtClean="0"/>
-              <a:t>04-10-2022</a:t>
+              <a:t>05-10-2022</a:t>
             </a:fld>
             <a:endParaRPr lang="da-DK"/>
           </a:p>
@@ -2697,7 +2697,7 @@
           <a:p>
             <a:fld id="{E4EFA994-F2DF-48DF-AC6C-D99B8D21D338}" type="datetimeFigureOut">
               <a:rPr lang="da-DK" smtClean="0"/>
-              <a:t>04-10-2022</a:t>
+              <a:t>05-10-2022</a:t>
             </a:fld>
             <a:endParaRPr lang="da-DK"/>
           </a:p>
@@ -2940,7 +2940,7 @@
           <a:p>
             <a:fld id="{E4EFA994-F2DF-48DF-AC6C-D99B8D21D338}" type="datetimeFigureOut">
               <a:rPr lang="da-DK" smtClean="0"/>
-              <a:t>04-10-2022</a:t>
+              <a:t>05-10-2022</a:t>
             </a:fld>
             <a:endParaRPr lang="da-DK"/>
           </a:p>
@@ -3372,7 +3372,7 @@
         <p:spPr>
           <a:xfrm>
             <a:off x="349513" y="346118"/>
-            <a:ext cx="4657726" cy="5478423"/>
+            <a:ext cx="4657726" cy="5663089"/>
           </a:xfrm>
           <a:prstGeom prst="rect">
             <a:avLst/>
@@ -4121,6 +4121,30 @@
             </a:r>
           </a:p>
           <a:p>
+            <a:pPr marL="742950" lvl="1" indent="-285750">
+              <a:buFont typeface="Wingdings" panose="05000000000000000000" pitchFamily="2" charset="2"/>
+              <a:buChar char="à"/>
+            </a:pPr>
+            <a:r>
+              <a:rPr lang="da-DK" sz="1200" dirty="0">
+                <a:sym typeface="Wingdings" panose="05000000000000000000" pitchFamily="2" charset="2"/>
+              </a:rPr>
+              <a:t>Opinion on EU policy for the </a:t>
+            </a:r>
+            <a:r>
+              <a:rPr lang="da-DK" sz="1200" dirty="0" err="1">
+                <a:sym typeface="Wingdings" panose="05000000000000000000" pitchFamily="2" charset="2"/>
+              </a:rPr>
+              <a:t>Arctic</a:t>
+            </a:r>
+            <a:r>
+              <a:rPr lang="da-DK" sz="1200" dirty="0">
+                <a:sym typeface="Wingdings" panose="05000000000000000000" pitchFamily="2" charset="2"/>
+              </a:rPr>
+              <a:t> (52016AE4426)</a:t>
+            </a:r>
+          </a:p>
+          <a:p>
             <a:endParaRPr lang="da-DK" sz="1200" dirty="0">
               <a:sym typeface="Wingdings" panose="05000000000000000000" pitchFamily="2" charset="2"/>
             </a:endParaRPr>
@@ -4192,10 +4216,10 @@
       </p:sp>
       <p:pic>
         <p:nvPicPr>
-          <p:cNvPr id="7" name="Picture 6" descr="Chart, scatter chart&#10;&#10;Description automatically generated">
+          <p:cNvPr id="3" name="Picture 2" descr="Chart, scatter chart&#10;&#10;Description automatically generated">
             <a:extLst>
               <a:ext uri="{FF2B5EF4-FFF2-40B4-BE49-F238E27FC236}">
-                <a16:creationId xmlns:a16="http://schemas.microsoft.com/office/drawing/2014/main" id="{F01D2914-F5CE-726C-7988-D96F0563DEF5}"/>
+                <a16:creationId xmlns:a16="http://schemas.microsoft.com/office/drawing/2014/main" id="{AF58B23E-ABB2-2795-22C5-ACD2DDB933C1}"/>
               </a:ext>
             </a:extLst>
           </p:cNvPr>
@@ -4218,8 +4242,8 @@
         </p:blipFill>
         <p:spPr>
           <a:xfrm>
-            <a:off x="5702157" y="12689"/>
-            <a:ext cx="6489843" cy="6845311"/>
+            <a:off x="5119577" y="0"/>
+            <a:ext cx="6858000" cy="6858000"/>
           </a:xfrm>
           <a:prstGeom prst="rect">
             <a:avLst/>
@@ -7099,7 +7123,7 @@
         </p:spPr>
         <p:txBody>
           <a:bodyPr>
-            <a:normAutofit fontScale="92500" lnSpcReduction="10000"/>
+            <a:normAutofit fontScale="77500" lnSpcReduction="20000"/>
           </a:bodyPr>
           <a:lstStyle/>
           <a:p>
@@ -7167,7 +7191,7 @@
               <a:rPr lang="da-DK" dirty="0">
                 <a:sym typeface="Wingdings" panose="05000000000000000000" pitchFamily="2" charset="2"/>
               </a:rPr>
-              <a:t>435 </a:t>
+              <a:t>54 </a:t>
             </a:r>
             <a:r>
               <a:rPr lang="da-DK" dirty="0" err="1">
@@ -7185,23 +7209,37 @@
               <a:rPr lang="da-DK" dirty="0" err="1">
                 <a:sym typeface="Wingdings" panose="05000000000000000000" pitchFamily="2" charset="2"/>
               </a:rPr>
-              <a:t>s</a:t>
-            </a:r>
-            <a:r>
-              <a:rPr lang="da-DK" dirty="0" err="1"/>
-              <a:t>econd</a:t>
-            </a:r>
-            <a:r>
-              <a:rPr lang="da-DK" dirty="0"/>
-              <a:t> </a:t>
-            </a:r>
-            <a:r>
-              <a:rPr lang="da-DK" dirty="0" err="1"/>
+              <a:t>only</a:t>
+            </a:r>
+            <a:r>
+              <a:rPr lang="da-DK" dirty="0">
+                <a:sym typeface="Wingdings" panose="05000000000000000000" pitchFamily="2" charset="2"/>
+              </a:rPr>
+              <a:t> </a:t>
+            </a:r>
+            <a:r>
+              <a:rPr lang="da-DK" dirty="0" err="1">
+                <a:sym typeface="Wingdings" panose="05000000000000000000" pitchFamily="2" charset="2"/>
+              </a:rPr>
+              <a:t>first</a:t>
+            </a:r>
+            <a:r>
+              <a:rPr lang="da-DK" dirty="0">
+                <a:sym typeface="Wingdings" panose="05000000000000000000" pitchFamily="2" charset="2"/>
+              </a:rPr>
+              <a:t> </a:t>
+            </a:r>
+            <a:r>
+              <a:rPr lang="da-DK" dirty="0" err="1">
+                <a:sym typeface="Wingdings" panose="05000000000000000000" pitchFamily="2" charset="2"/>
+              </a:rPr>
               <a:t>order</a:t>
             </a:r>
             <a:r>
-              <a:rPr lang="da-DK" dirty="0"/>
-              <a:t> citations.</a:t>
+              <a:rPr lang="da-DK" dirty="0">
+                <a:sym typeface="Wingdings" panose="05000000000000000000" pitchFamily="2" charset="2"/>
+              </a:rPr>
+              <a:t> citations</a:t>
             </a:r>
           </a:p>
           <a:p>
@@ -7213,30 +7251,45 @@
               <a:buChar char="à"/>
             </a:pPr>
             <a:r>
+              <a:rPr lang="da-DK" dirty="0">
+                <a:sym typeface="Wingdings" panose="05000000000000000000" pitchFamily="2" charset="2"/>
+              </a:rPr>
+              <a:t>435 </a:t>
+            </a:r>
+            <a:r>
+              <a:rPr lang="da-DK" dirty="0" err="1">
+                <a:sym typeface="Wingdings" panose="05000000000000000000" pitchFamily="2" charset="2"/>
+              </a:rPr>
+              <a:t>are</a:t>
+            </a:r>
+            <a:r>
+              <a:rPr lang="da-DK" dirty="0">
+                <a:sym typeface="Wingdings" panose="05000000000000000000" pitchFamily="2" charset="2"/>
+              </a:rPr>
+              <a:t> </a:t>
+            </a:r>
+            <a:r>
+              <a:rPr lang="da-DK" dirty="0" err="1">
+                <a:sym typeface="Wingdings" panose="05000000000000000000" pitchFamily="2" charset="2"/>
+              </a:rPr>
+              <a:t>s</a:t>
+            </a:r>
+            <a:r>
+              <a:rPr lang="da-DK" dirty="0" err="1"/>
+              <a:t>econd</a:t>
+            </a:r>
+            <a:r>
               <a:rPr lang="da-DK" dirty="0"/>
-              <a:t>118 citations </a:t>
+              <a:t> </a:t>
             </a:r>
             <a:r>
               <a:rPr lang="da-DK" dirty="0" err="1"/>
-              <a:t>cite</a:t>
+              <a:t>order</a:t>
             </a:r>
             <a:r>
               <a:rPr lang="da-DK" dirty="0"/>
-              <a:t> </a:t>
-            </a:r>
-            <a:r>
-              <a:rPr lang="da-DK" dirty="0" err="1"/>
-              <a:t>another</a:t>
-            </a:r>
-            <a:r>
-              <a:rPr lang="da-DK" dirty="0"/>
-              <a:t> legislative </a:t>
-            </a:r>
-            <a:r>
-              <a:rPr lang="da-DK" dirty="0" err="1"/>
-              <a:t>document</a:t>
-            </a:r>
-            <a:endParaRPr lang="da-DK" dirty="0"/>
+              <a:t> citations.</a:t>
+            </a:r>
           </a:p>
           <a:p>
             <a:pPr marL="285750" indent="-285750">
@@ -7248,12 +7301,152 @@
             </a:pPr>
             <a:r>
               <a:rPr lang="da-DK" dirty="0"/>
-              <a:t>A new </a:t>
+              <a:t>76 </a:t>
+            </a:r>
+            <a:r>
+              <a:rPr lang="da-DK" dirty="0" err="1"/>
+              <a:t>are</a:t>
+            </a:r>
+            <a:r>
+              <a:rPr lang="da-DK" dirty="0"/>
+              <a:t> </a:t>
+            </a:r>
+            <a:r>
+              <a:rPr lang="da-DK" dirty="0" err="1"/>
+              <a:t>both</a:t>
+            </a:r>
+            <a:r>
+              <a:rPr lang="da-DK" dirty="0"/>
+              <a:t> </a:t>
+            </a:r>
+            <a:r>
+              <a:rPr lang="da-DK" dirty="0" err="1"/>
+              <a:t>first</a:t>
+            </a:r>
+            <a:r>
+              <a:rPr lang="da-DK" dirty="0"/>
+              <a:t> and </a:t>
+            </a:r>
+            <a:r>
+              <a:rPr lang="da-DK" dirty="0" err="1"/>
+              <a:t>second</a:t>
+            </a:r>
+            <a:r>
+              <a:rPr lang="da-DK" dirty="0"/>
+              <a:t> </a:t>
+            </a:r>
+            <a:r>
+              <a:rPr lang="da-DK" dirty="0" err="1"/>
+              <a:t>order</a:t>
+            </a:r>
+            <a:r>
+              <a:rPr lang="da-DK" dirty="0"/>
+              <a:t> citations. </a:t>
+            </a:r>
+          </a:p>
+          <a:p>
+            <a:pPr marL="285750" indent="-285750">
+              <a:lnSpc>
+                <a:spcPct val="100000"/>
+              </a:lnSpc>
+              <a:buFont typeface="Wingdings" panose="05000000000000000000" pitchFamily="2" charset="2"/>
+              <a:buChar char="à"/>
+            </a:pPr>
+            <a:r>
+              <a:rPr lang="da-DK" dirty="0"/>
+              <a:t>5 </a:t>
+            </a:r>
+            <a:r>
+              <a:rPr lang="da-DK" dirty="0" err="1"/>
+              <a:t>documents</a:t>
+            </a:r>
+            <a:r>
+              <a:rPr lang="da-DK" dirty="0"/>
+              <a:t> </a:t>
+            </a:r>
+            <a:r>
+              <a:rPr lang="da-DK" dirty="0" err="1"/>
+              <a:t>are</a:t>
+            </a:r>
+            <a:r>
+              <a:rPr lang="da-DK" dirty="0"/>
+              <a:t> </a:t>
+            </a:r>
+            <a:r>
+              <a:rPr lang="da-DK" dirty="0" err="1"/>
+              <a:t>both</a:t>
+            </a:r>
+            <a:r>
+              <a:rPr lang="da-DK" dirty="0"/>
+              <a:t> a </a:t>
+            </a:r>
+            <a:r>
+              <a:rPr lang="da-DK" dirty="0" err="1"/>
+              <a:t>result</a:t>
+            </a:r>
+            <a:r>
+              <a:rPr lang="da-DK" dirty="0"/>
+              <a:t> and at </a:t>
+            </a:r>
+            <a:r>
+              <a:rPr lang="da-DK" dirty="0" err="1"/>
+              <a:t>one</a:t>
+            </a:r>
+            <a:r>
+              <a:rPr lang="da-DK" dirty="0"/>
+              <a:t> point a citation</a:t>
+            </a:r>
+          </a:p>
+          <a:p>
+            <a:pPr marL="285750" indent="-285750">
+              <a:lnSpc>
+                <a:spcPct val="100000"/>
+              </a:lnSpc>
+              <a:buFont typeface="Wingdings" panose="05000000000000000000" pitchFamily="2" charset="2"/>
+              <a:buChar char="à"/>
+            </a:pPr>
+            <a:r>
+              <a:rPr lang="da-DK" dirty="0"/>
+              <a:t>118 citations </a:t>
+            </a:r>
+            <a:r>
+              <a:rPr lang="da-DK" dirty="0" err="1"/>
+              <a:t>cite</a:t>
+            </a:r>
+            <a:r>
+              <a:rPr lang="da-DK" dirty="0"/>
+              <a:t> </a:t>
+            </a:r>
+            <a:r>
+              <a:rPr lang="da-DK" dirty="0" err="1"/>
+              <a:t>another</a:t>
+            </a:r>
+            <a:r>
+              <a:rPr lang="da-DK" dirty="0"/>
+              <a:t> legislative </a:t>
             </a:r>
             <a:r>
               <a:rPr lang="da-DK" dirty="0" err="1"/>
               <a:t>document</a:t>
             </a:r>
+            <a:endParaRPr lang="da-DK" dirty="0"/>
+          </a:p>
+          <a:p>
+            <a:pPr marL="285750" indent="-285750">
+              <a:lnSpc>
+                <a:spcPct val="100000"/>
+              </a:lnSpc>
+              <a:buFont typeface="Wingdings" panose="05000000000000000000" pitchFamily="2" charset="2"/>
+              <a:buChar char="à"/>
+            </a:pPr>
+            <a:r>
+              <a:rPr lang="da-DK" dirty="0"/>
+              <a:t>A new </a:t>
+            </a:r>
+            <a:r>
+              <a:rPr lang="da-DK" dirty="0" err="1"/>
+              <a:t>document</a:t>
+            </a:r>
             <a:r>
               <a:rPr lang="da-DK" dirty="0"/>
               <a:t> is </a:t>
@@ -7272,7 +7465,7 @@
             </a:r>
             <a:r>
               <a:rPr lang="da-DK" dirty="0"/>
-              <a:t> t the </a:t>
+              <a:t> to the </a:t>
             </a:r>
             <a:r>
               <a:rPr lang="da-DK" dirty="0" err="1"/>
@@ -7407,10 +7600,10 @@
       </p:sp>
       <p:pic>
         <p:nvPicPr>
-          <p:cNvPr id="3" name="Picture 2" descr="Chart, scatter chart&#10;&#10;Description automatically generated">
+          <p:cNvPr id="5" name="Picture 4" descr="Chart, scatter chart&#10;&#10;Description automatically generated">
             <a:extLst>
               <a:ext uri="{FF2B5EF4-FFF2-40B4-BE49-F238E27FC236}">
-                <a16:creationId xmlns:a16="http://schemas.microsoft.com/office/drawing/2014/main" id="{EFF11456-3D5D-A6C3-05B1-170EEF0929C2}"/>
+                <a16:creationId xmlns:a16="http://schemas.microsoft.com/office/drawing/2014/main" id="{302435E7-3DE9-C5E8-C07D-1FB75EE0176A}"/>
               </a:ext>
             </a:extLst>
           </p:cNvPr>
@@ -7433,8 +7626,8 @@
         </p:blipFill>
         <p:spPr>
           <a:xfrm>
-            <a:off x="5181600" y="0"/>
-            <a:ext cx="7147990" cy="6858000"/>
+            <a:off x="5438554" y="0"/>
+            <a:ext cx="6858000" cy="6858000"/>
           </a:xfrm>
           <a:prstGeom prst="rect">
             <a:avLst/>
@@ -8621,7 +8814,7 @@
         </p:nvSpPr>
         <p:spPr>
           <a:xfrm>
-            <a:off x="349513" y="613246"/>
+            <a:off x="285903" y="81235"/>
             <a:ext cx="4657726" cy="800219"/>
           </a:xfrm>
           <a:prstGeom prst="rect">
@@ -8677,8 +8870,8 @@
         </p:nvSpPr>
         <p:spPr>
           <a:xfrm>
-            <a:off x="349513" y="1731812"/>
-            <a:ext cx="11842487" cy="4524315"/>
+            <a:off x="508884" y="744344"/>
+            <a:ext cx="11842487" cy="6032421"/>
           </a:xfrm>
           <a:prstGeom prst="rect">
             <a:avLst/>
@@ -8692,185 +8885,328 @@
           <a:lstStyle/>
           <a:p>
             <a:r>
-              <a:rPr lang="en-US" dirty="0"/>
+              <a:rPr lang="en-US" sz="1600" dirty="0"/>
               <a:t> 18 unique search terms with exactly = TRUE</a:t>
             </a:r>
           </a:p>
           <a:p>
-            <a:endParaRPr lang="en-US" dirty="0"/>
-          </a:p>
-          <a:p>
-            <a:endParaRPr lang="en-US" dirty="0"/>
-          </a:p>
-          <a:p>
-            <a:r>
-              <a:rPr lang="en-US" b="1" dirty="0"/>
+            <a:endParaRPr lang="en-US" sz="1600" dirty="0"/>
+          </a:p>
+          <a:p>
+            <a:r>
+              <a:rPr lang="en-US" sz="1600" b="1" dirty="0"/>
               <a:t> Results</a:t>
             </a:r>
             <a:r>
-              <a:rPr lang="en-US" dirty="0"/>
+              <a:rPr lang="en-US" sz="1600" dirty="0"/>
               <a:t>:</a:t>
             </a:r>
           </a:p>
           <a:p>
             <a:r>
-              <a:rPr lang="en-US" b="1" dirty="0"/>
-              <a:t> </a:t>
-            </a:r>
-            <a:r>
-              <a:rPr lang="en-US" b="1" dirty="0" err="1"/>
+              <a:rPr lang="en-US" sz="1600" b="1" dirty="0"/>
+              <a:t> </a:t>
+            </a:r>
+            <a:r>
+              <a:rPr lang="en-US" sz="1600" b="1" dirty="0" err="1"/>
               <a:t>search.term</a:t>
             </a:r>
             <a:r>
-              <a:rPr lang="en-US" b="1" dirty="0"/>
+              <a:rPr lang="en-US" sz="1600" b="1" dirty="0"/>
               <a:t>                              </a:t>
             </a:r>
             <a:r>
-              <a:rPr lang="en-US" b="1" dirty="0" err="1"/>
+              <a:rPr lang="en-US" sz="1600" b="1" dirty="0" err="1"/>
               <a:t>nmbr</a:t>
             </a:r>
             <a:r>
-              <a:rPr lang="en-US" b="1" dirty="0"/>
+              <a:rPr lang="en-US" sz="1600" b="1" dirty="0"/>
               <a:t>. of documents pulled.     </a:t>
             </a:r>
             <a:r>
-              <a:rPr lang="en-US" b="1" dirty="0" err="1"/>
+              <a:rPr lang="en-US" sz="1600" b="1" dirty="0" err="1"/>
               <a:t>Nmbr</a:t>
             </a:r>
             <a:r>
-              <a:rPr lang="en-US" b="1" dirty="0"/>
+              <a:rPr lang="en-US" sz="1600" b="1" dirty="0"/>
               <a:t>. Of </a:t>
             </a:r>
             <a:r>
-              <a:rPr lang="en-US" b="1" dirty="0" err="1"/>
+              <a:rPr lang="en-US" sz="1600" b="1" dirty="0" err="1"/>
               <a:t>mpas</a:t>
             </a:r>
             <a:r>
-              <a:rPr lang="en-US" b="1" dirty="0"/>
+              <a:rPr lang="en-US" sz="1600" b="1" dirty="0"/>
               <a:t>        </a:t>
             </a:r>
             <a:r>
-              <a:rPr lang="en-US" b="1" dirty="0" err="1"/>
+              <a:rPr lang="en-US" sz="1600" b="1" dirty="0" err="1"/>
               <a:t>Nmbr</a:t>
             </a:r>
             <a:r>
-              <a:rPr lang="en-US" b="1" dirty="0"/>
+              <a:rPr lang="en-US" sz="1600" b="1" dirty="0"/>
               <a:t>. Of EU countries linked via </a:t>
             </a:r>
             <a:r>
-              <a:rPr lang="en-US" b="1" dirty="0" err="1"/>
+              <a:rPr lang="en-US" sz="1600" b="1" dirty="0" err="1"/>
               <a:t>mpa</a:t>
             </a:r>
             <a:r>
-              <a:rPr lang="en-US" b="1" dirty="0"/>
-              <a:t> </a:t>
-            </a:r>
-            <a:r>
-              <a:rPr lang="en-US" b="1" dirty="0" err="1"/>
+              <a:rPr lang="en-US" sz="1600" b="1" dirty="0"/>
+              <a:t> </a:t>
+            </a:r>
+            <a:r>
+              <a:rPr lang="en-US" sz="1600" b="1" dirty="0" err="1"/>
               <a:t>desig</a:t>
             </a:r>
             <a:r>
-              <a:rPr lang="en-US" b="1" dirty="0"/>
+              <a:rPr lang="en-US" sz="1600" b="1" dirty="0"/>
               <a:t>.</a:t>
             </a:r>
           </a:p>
           <a:p>
             <a:r>
-              <a:rPr lang="en-US" dirty="0"/>
-              <a:t> </a:t>
-            </a:r>
-            <a:r>
-              <a:rPr lang="en-US" dirty="0" err="1"/>
+              <a:rPr lang="en-US" sz="1600" dirty="0"/>
+              <a:t> </a:t>
+            </a:r>
+            <a:r>
+              <a:rPr lang="en-US" sz="1600" dirty="0" err="1"/>
               <a:t>barcelona</a:t>
             </a:r>
             <a:r>
-              <a:rPr lang="en-US" dirty="0"/>
-              <a:t> convention*?               	37			24			4</a:t>
-            </a:r>
-          </a:p>
-          <a:p>
-            <a:r>
-              <a:rPr lang="en-US" dirty="0"/>
-              <a:t> birds directive*?                            	6			843			23</a:t>
-            </a:r>
-          </a:p>
-          <a:p>
-            <a:r>
-              <a:rPr lang="en-US" dirty="0"/>
-              <a:t> habitats directive*?                      	56			1869			22</a:t>
-            </a:r>
-          </a:p>
-          <a:p>
-            <a:r>
-              <a:rPr lang="en-US" dirty="0"/>
-              <a:t> </a:t>
-            </a:r>
-            <a:r>
-              <a:rPr lang="en-US" dirty="0" err="1"/>
+              <a:rPr lang="en-US" sz="1600" dirty="0"/>
+              <a:t> convention*?                           36                                          24                                              4</a:t>
+            </a:r>
+          </a:p>
+          <a:p>
+            <a:r>
+              <a:rPr lang="en-US" sz="1600" dirty="0"/>
+              <a:t> birds directive*?                                        36		           843                                             23</a:t>
+            </a:r>
+          </a:p>
+          <a:p>
+            <a:r>
+              <a:rPr lang="en-US" sz="1600" dirty="0"/>
+              <a:t> habitats directive*?                                   58                                    1388 + 481	                            22</a:t>
+            </a:r>
+          </a:p>
+          <a:p>
+            <a:r>
+              <a:rPr lang="en-US" sz="1600" dirty="0"/>
+              <a:t> </a:t>
+            </a:r>
+            <a:r>
+              <a:rPr lang="en-US" sz="1600" dirty="0" err="1"/>
               <a:t>helcom</a:t>
             </a:r>
             <a:r>
-              <a:rPr lang="en-US" dirty="0"/>
-              <a:t>*?                                       	12			163			8</a:t>
-            </a:r>
-          </a:p>
-          <a:p>
-            <a:r>
-              <a:rPr lang="en-US" dirty="0"/>
-              <a:t> marine protected area*?            	18			441 			10</a:t>
-            </a:r>
-          </a:p>
-          <a:p>
-            <a:r>
-              <a:rPr lang="en-US" dirty="0"/>
-              <a:t> </a:t>
-            </a:r>
-            <a:r>
-              <a:rPr lang="en-US" dirty="0" err="1"/>
+              <a:rPr lang="en-US" sz="1600" dirty="0"/>
+              <a:t>*?                                                    14                                          163                                             8</a:t>
+            </a:r>
+          </a:p>
+          <a:p>
+            <a:r>
+              <a:rPr lang="en-US" sz="1600" dirty="0"/>
+              <a:t> marine protected area*?                         24                                           441                                           10</a:t>
+            </a:r>
+          </a:p>
+          <a:p>
+            <a:r>
+              <a:rPr lang="en-US" sz="1600" dirty="0"/>
+              <a:t> </a:t>
+            </a:r>
+            <a:r>
+              <a:rPr lang="en-US" sz="1600" dirty="0" err="1"/>
               <a:t>ospar</a:t>
             </a:r>
             <a:r>
-              <a:rPr lang="en-US" dirty="0"/>
-              <a:t>*?                                          	19			441			10</a:t>
-            </a:r>
-          </a:p>
-          <a:p>
-            <a:r>
-              <a:rPr lang="en-US" dirty="0"/>
-              <a:t> </a:t>
-            </a:r>
-            <a:r>
-              <a:rPr lang="en-US" dirty="0" err="1"/>
+              <a:rPr lang="en-US" sz="1600" dirty="0"/>
+              <a:t>*?                                                       27                                           441                                           10</a:t>
+            </a:r>
+          </a:p>
+          <a:p>
+            <a:r>
+              <a:rPr lang="en-US" sz="1600" dirty="0"/>
+              <a:t> </a:t>
+            </a:r>
+            <a:r>
+              <a:rPr lang="en-US" sz="1600" dirty="0" err="1"/>
               <a:t>ramsar</a:t>
             </a:r>
             <a:r>
-              <a:rPr lang="en-US" dirty="0"/>
-              <a:t> site*?                                	1			237			18</a:t>
-            </a:r>
-          </a:p>
-          <a:p>
-            <a:r>
-              <a:rPr lang="en-US" dirty="0"/>
-              <a:t> sites of community importance*?         5			481			18</a:t>
-            </a:r>
-          </a:p>
-          <a:p>
-            <a:r>
-              <a:rPr lang="en-US" dirty="0"/>
-              <a:t> special areas of conservation*?    	16			1388			19</a:t>
-            </a:r>
-          </a:p>
-          <a:p>
-            <a:r>
-              <a:rPr lang="en-US" dirty="0"/>
-              <a:t> special protection area*?           	7			843			23</a:t>
-            </a:r>
-          </a:p>
-          <a:p>
-            <a:r>
-              <a:rPr lang="en-US" dirty="0"/>
-              <a:t> world heritage site*?               	2			9			4</a:t>
-            </a:r>
+              <a:rPr lang="en-US" sz="1600" dirty="0"/>
+              <a:t> site*?                                              1                                            237                                            18</a:t>
+            </a:r>
+          </a:p>
+          <a:p>
+            <a:r>
+              <a:rPr lang="en-US" sz="1600" dirty="0"/>
+              <a:t> site of community importance*?            4                                            481                                            18</a:t>
+            </a:r>
+          </a:p>
+          <a:p>
+            <a:r>
+              <a:rPr lang="en-US" sz="1600" dirty="0"/>
+              <a:t> sites of community importance*?         10                                           481                                            18</a:t>
+            </a:r>
+          </a:p>
+          <a:p>
+            <a:r>
+              <a:rPr lang="en-US" sz="1600" dirty="0"/>
+              <a:t> special areas of conservation*?             23                                           1388                                          19</a:t>
+            </a:r>
+          </a:p>
+          <a:p>
+            <a:r>
+              <a:rPr lang="en-US" sz="1600" dirty="0"/>
+              <a:t> special protection area*?                        29                                           843 		           23</a:t>
+            </a:r>
+          </a:p>
+          <a:p>
+            <a:r>
+              <a:rPr lang="en-US" sz="1600" dirty="0"/>
+              <a:t> specially protected area*?                      10                                             7  		           2</a:t>
+            </a:r>
+          </a:p>
+          <a:p>
+            <a:r>
+              <a:rPr lang="en-US" sz="1600" dirty="0"/>
+              <a:t> world heritage site*?                                2                                              9  		           4</a:t>
+            </a:r>
+          </a:p>
+          <a:p>
+            <a:r>
+              <a:rPr lang="da-DK" sz="1600" dirty="0"/>
+              <a:t> </a:t>
+            </a:r>
+            <a:r>
+              <a:rPr lang="da-DK" sz="1600" dirty="0" err="1"/>
+              <a:t>unesco-mab</a:t>
+            </a:r>
+            <a:r>
+              <a:rPr lang="da-DK" sz="1600" dirty="0"/>
+              <a:t> </a:t>
+            </a:r>
+            <a:r>
+              <a:rPr lang="da-DK" sz="1600" dirty="0" err="1"/>
+              <a:t>biosphere</a:t>
+            </a:r>
+            <a:r>
+              <a:rPr lang="da-DK" sz="1600" dirty="0"/>
+              <a:t> reserve                0		                 11	                              6</a:t>
+            </a:r>
+          </a:p>
+          <a:p>
+            <a:r>
+              <a:rPr lang="da-DK" sz="1600" dirty="0"/>
+              <a:t> </a:t>
+            </a:r>
+            <a:r>
+              <a:rPr lang="da-DK" sz="1600" dirty="0" err="1"/>
+              <a:t>baltic</a:t>
+            </a:r>
+            <a:r>
+              <a:rPr lang="da-DK" sz="1600" dirty="0"/>
+              <a:t> </a:t>
+            </a:r>
+            <a:r>
+              <a:rPr lang="da-DK" sz="1600" dirty="0" err="1"/>
+              <a:t>sea</a:t>
+            </a:r>
+            <a:r>
+              <a:rPr lang="da-DK" sz="1600" dirty="0"/>
+              <a:t> </a:t>
+            </a:r>
+            <a:r>
+              <a:rPr lang="da-DK" sz="1600" dirty="0" err="1"/>
+              <a:t>protected</a:t>
+            </a:r>
+            <a:r>
+              <a:rPr lang="da-DK" sz="1600" dirty="0"/>
+              <a:t> </a:t>
+            </a:r>
+            <a:r>
+              <a:rPr lang="da-DK" sz="1600" dirty="0" err="1"/>
+              <a:t>area</a:t>
+            </a:r>
+            <a:r>
+              <a:rPr lang="da-DK" sz="1600" dirty="0"/>
+              <a:t>                           0                                            163                                            8</a:t>
+            </a:r>
+          </a:p>
+          <a:p>
+            <a:r>
+              <a:rPr lang="da-DK" sz="1600" dirty="0"/>
+              <a:t> </a:t>
+            </a:r>
+            <a:r>
+              <a:rPr lang="en-US" sz="1600" dirty="0"/>
+              <a:t>specially protected areas of                      0 		                  24                                                 4</a:t>
+            </a:r>
+          </a:p>
+          <a:p>
+            <a:r>
+              <a:rPr lang="en-US" sz="1600" dirty="0" err="1"/>
+              <a:t>mediterranean</a:t>
+            </a:r>
+            <a:r>
+              <a:rPr lang="en-US" sz="1600" dirty="0"/>
+              <a:t> importance </a:t>
+            </a:r>
+            <a:r>
+              <a:rPr lang="da-DK" sz="1600" dirty="0"/>
+              <a:t>   </a:t>
+            </a:r>
+          </a:p>
+          <a:p>
+            <a:r>
+              <a:rPr lang="da-DK" sz="1600" dirty="0"/>
+              <a:t> </a:t>
+            </a:r>
+            <a:r>
+              <a:rPr lang="da-DK" sz="1600" dirty="0" err="1"/>
+              <a:t>wetland</a:t>
+            </a:r>
+            <a:r>
+              <a:rPr lang="da-DK" sz="1600" dirty="0"/>
+              <a:t> of international </a:t>
+            </a:r>
+            <a:r>
+              <a:rPr lang="da-DK" sz="1600" dirty="0" err="1"/>
+              <a:t>importance</a:t>
+            </a:r>
+            <a:r>
+              <a:rPr lang="da-DK" sz="1600" dirty="0"/>
+              <a:t>     0		                   </a:t>
+            </a:r>
+            <a:r>
+              <a:rPr lang="en-US" sz="1600" dirty="0"/>
+              <a:t>237                                            18</a:t>
+            </a:r>
+            <a:r>
+              <a:rPr lang="da-DK" sz="1600" dirty="0"/>
+              <a:t>     </a:t>
+            </a:r>
+          </a:p>
+          <a:p>
+            <a:r>
+              <a:rPr lang="da-DK" sz="1600" dirty="0" err="1"/>
+              <a:t>cartagena</a:t>
+            </a:r>
+            <a:r>
+              <a:rPr lang="da-DK" sz="1600" dirty="0"/>
+              <a:t> </a:t>
+            </a:r>
+            <a:r>
+              <a:rPr lang="da-DK" sz="1600" dirty="0" err="1"/>
+              <a:t>convention</a:t>
+            </a:r>
+            <a:r>
+              <a:rPr lang="da-DK" sz="1600" dirty="0"/>
+              <a:t>                                 0    			7  		           2</a:t>
+            </a:r>
+          </a:p>
+          <a:p>
             <a:endParaRPr lang="da-DK" dirty="0"/>
           </a:p>
         </p:txBody>
@@ -8889,8 +9225,8 @@
         </p:nvSpPr>
         <p:spPr>
           <a:xfrm>
-            <a:off x="4113344" y="213136"/>
-            <a:ext cx="8078656" cy="646331"/>
+            <a:off x="6202016" y="0"/>
+            <a:ext cx="6077447" cy="923330"/>
           </a:xfrm>
           <a:prstGeom prst="rect">
             <a:avLst/>
@@ -9505,7 +9841,7 @@
               <a:rPr lang="da-DK" sz="1200" dirty="0">
                 <a:sym typeface="Wingdings" panose="05000000000000000000" pitchFamily="2" charset="2"/>
               </a:rPr>
-              <a:t>21 </a:t>
+              <a:t>32 </a:t>
             </a:r>
             <a:r>
               <a:rPr lang="da-DK" sz="1200" dirty="0" err="1">
@@ -9680,10 +10016,10 @@
       </p:sp>
       <p:pic>
         <p:nvPicPr>
-          <p:cNvPr id="4" name="Picture 3" descr="Chart, scatter chart&#10;&#10;Description automatically generated">
+          <p:cNvPr id="5" name="Picture 4">
             <a:extLst>
               <a:ext uri="{FF2B5EF4-FFF2-40B4-BE49-F238E27FC236}">
-                <a16:creationId xmlns:a16="http://schemas.microsoft.com/office/drawing/2014/main" id="{29370135-16BE-D2B6-EA00-2711845D509F}"/>
+                <a16:creationId xmlns:a16="http://schemas.microsoft.com/office/drawing/2014/main" id="{19C0F2AC-E533-AE7A-2CD7-2D425E41AB04}"/>
               </a:ext>
             </a:extLst>
           </p:cNvPr>
@@ -9692,7 +10028,7 @@
           </p:cNvPicPr>
           <p:nvPr/>
         </p:nvPicPr>
-        <p:blipFill rotWithShape="1">
+        <p:blipFill>
           <a:blip r:embed="rId2">
             <a:extLst>
               <a:ext uri="{28A0092B-C50C-407E-A947-70E740481C1C}">
@@ -9700,13 +10036,14 @@
               </a:ext>
             </a:extLst>
           </a:blip>
-          <a:srcRect r="14661"/>
-          <a:stretch/>
+          <a:stretch>
+            <a:fillRect/>
+          </a:stretch>
         </p:blipFill>
         <p:spPr>
           <a:xfrm>
-            <a:off x="4421491" y="0"/>
-            <a:ext cx="7762864" cy="6858000"/>
+            <a:off x="5334000" y="0"/>
+            <a:ext cx="6858000" cy="6858000"/>
           </a:xfrm>
           <a:prstGeom prst="rect">
             <a:avLst/>
@@ -10255,10 +10592,10 @@
       </p:sp>
       <p:pic>
         <p:nvPicPr>
-          <p:cNvPr id="3" name="Picture 2">
+          <p:cNvPr id="7" name="Picture 6" descr="A map of the world&#10;&#10;Description automatically generated with low confidence">
             <a:extLst>
               <a:ext uri="{FF2B5EF4-FFF2-40B4-BE49-F238E27FC236}">
-                <a16:creationId xmlns:a16="http://schemas.microsoft.com/office/drawing/2014/main" id="{7E371E05-DDFB-9FAB-0B99-C788CC00089A}"/>
+                <a16:creationId xmlns:a16="http://schemas.microsoft.com/office/drawing/2014/main" id="{BC884D9A-1DDC-4E81-9486-361000814491}"/>
               </a:ext>
             </a:extLst>
           </p:cNvPr>
@@ -10268,15 +10605,21 @@
           <p:nvPr/>
         </p:nvPicPr>
         <p:blipFill>
-          <a:blip r:embed="rId2"/>
+          <a:blip r:embed="rId2">
+            <a:extLst>
+              <a:ext uri="{28A0092B-C50C-407E-A947-70E740481C1C}">
+                <a14:useLocalDpi xmlns:a14="http://schemas.microsoft.com/office/drawing/2010/main" val="0"/>
+              </a:ext>
+            </a:extLst>
+          </a:blip>
           <a:stretch>
             <a:fillRect/>
           </a:stretch>
         </p:blipFill>
         <p:spPr>
           <a:xfrm>
-            <a:off x="5039698" y="1119883"/>
-            <a:ext cx="7152301" cy="5614095"/>
+            <a:off x="5334000" y="0"/>
+            <a:ext cx="6858000" cy="6858000"/>
           </a:xfrm>
           <a:prstGeom prst="rect">
             <a:avLst/>

</xml_diff>